<commit_message>
Presentación pieza por pieza: sumar caída del ingreso disponible (−16,5% vs. 2023, Equilibra)
Co-Authored-By: Claude Opus 5.5 <noreply@anthropic.com>
Claude-Session: https://claude.ai/code/session_01LjZCUeZeukTqwmHG81QxgV
</commit_message>
<xml_diff>
--- a/presentaciones/crisis_fundar_ladrillos.pptx
+++ b/presentaciones/crisis_fundar_ladrillos.pptx
@@ -115,18 +115,18 @@
   <p:extLst>
     <p:ext uri="{521415D9-36F7-43E2-AB2F-B90AF26B5E84}">
       <p14:sectionLst xmlns:p14="http://schemas.microsoft.com/office/powerpoint/2010/main">
-        <p14:section name="Portada" id="{afbfa94c-30f1-3504-04b4-ffdf36d2bbad}">
+        <p14:section name="Portada" id="{a91a738f-13ff-fd54-b7d4-ac3fd19452a1}">
           <p14:sldIdLst>
             <p14:sldId id="256"/>
           </p14:sldIdLst>
         </p14:section>
-        <p14:section name="Resumen" id="{f56540a0-9b94-7547-cad1-1ca1a821d8e0}">
+        <p14:section name="Resumen" id="{fa04aee1-dc4e-16c1-0a80-21df16f4c8bd}">
           <p14:sldIdLst>
             <p14:sldId id="257"/>
             <p14:sldId id="258"/>
           </p14:sldIdLst>
         </p14:section>
-        <p14:section name="Cómo se armó" id="{5c24ea68-3d77-f1f1-7c4f-b9c87a294c37}">
+        <p14:section name="Cómo se armó" id="{b253b6ad-db88-3686-819f-beb3da45012a}">
           <p14:sldIdLst>
             <p14:sldId id="259"/>
             <p14:sldId id="260"/>
@@ -134,7 +134,7 @@
             <p14:sldId id="262"/>
           </p14:sldIdLst>
         </p14:section>
-        <p14:section name="Qué hacer" id="{86ef5666-6a0d-7e6c-b2da-9378c22bc589}">
+        <p14:section name="Qué hacer" id="{01f33ba7-dbf5-ed90-cb35-2f5258db1cc1}">
           <p14:sldIdLst>
             <p14:sldId id="263"/>
             <p14:sldId id="264"/>
@@ -10520,7 +10520,7 @@
                   <a:schemeClr val="tx1"/>
                 </a:solidFill>
               </a:rPr>
-              <a:t>No</a:t>
+              <a:t>−16,5%</a:t>
             </a:r>
             <a:endParaRPr lang="en-US" sz="4000" dirty="0"/>
           </a:p>
@@ -10556,7 +10556,7 @@
                   <a:schemeClr val="tx2"/>
                 </a:solidFill>
               </a:rPr>
-              <a:t>El ingreso disponible quedó por debajo de los gastos fijos.</a:t>
+              <a:t>cayó el ingreso disponible entre 2023 y mayo de 2026.</a:t>
             </a:r>
             <a:endParaRPr lang="en-US" sz="1500" dirty="0"/>
           </a:p>
@@ -11450,7 +11450,7 @@
                   <a:schemeClr val="tx2"/>
                 </a:solidFill>
               </a:rPr>
-              <a:t>el ingreso disponible de los hogares quedó por debajo de sus gastos fijos. Lo que entra no cubre lo que sí o sí hay que pagar.</a:t>
+              <a:t>en mayo de 2026, lo que le queda a una familia después de pagar los gastos fijos fue 16,5% menor que en 2023.</a:t>
             </a:r>
             <a:endParaRPr lang="en-US" sz="1800" dirty="0"/>
           </a:p>
@@ -11561,7 +11561,7 @@
         <p:spPr>
           <a:xfrm>
             <a:off x="7178040" y="2011680"/>
-            <a:ext cx="4114800" cy="320040"/>
+            <a:ext cx="4114800" cy="548640"/>
           </a:xfrm>
           <a:prstGeom prst="rect">
             <a:avLst/>
@@ -11570,7 +11570,7 @@
           <a:ln/>
         </p:spPr>
         <p:txBody>
-          <a:bodyPr wrap="square" lIns="0" tIns="0" rIns="0" bIns="0" rtlCol="0" anchor="ctr"/>
+          <a:bodyPr wrap="square" lIns="0" tIns="0" rIns="0" bIns="0" rtlCol="0" anchor="t"/>
           <a:lstStyle/>
           <a:p>
             <a:pPr indent="0" marL="0">
@@ -11582,7 +11582,7 @@
                   <a:schemeClr val="tx1"/>
                 </a:solidFill>
               </a:rPr>
-              <a:t>Lo que entra y lo que sale, en un mes</a:t>
+              <a:t>Ingreso disponible: lo que queda del sueldo después de pagar los gastos fijos</a:t>
             </a:r>
             <a:endParaRPr lang="en-US" sz="1500" dirty="0"/>
           </a:p>
@@ -11596,7 +11596,7 @@
         </p:nvSpPr>
         <p:spPr>
           <a:xfrm>
-            <a:off x="7178040" y="2606040"/>
+            <a:off x="7178040" y="2788920"/>
             <a:ext cx="4114800" cy="274320"/>
           </a:xfrm>
           <a:prstGeom prst="rect">
@@ -11609,6 +11609,17 @@
           <a:bodyPr wrap="square" lIns="0" tIns="0" rIns="0" bIns="0" rtlCol="0" anchor="ctr"/>
           <a:lstStyle/>
           <a:p>
+            <a:pPr indent="0" marL="0">
+              <a:buNone/>
+            </a:pPr>
+            <a:r>
+              <a:rPr lang="en-US" sz="1400" b="1" dirty="0">
+                <a:solidFill>
+                  <a:schemeClr val="tx1"/>
+                </a:solidFill>
+              </a:rPr>
+              <a:t>2023</a:t>
+            </a:r>
             <a:pPr indent="0" marL="0">
               <a:buNone/>
             </a:pPr>
@@ -11618,7 +11629,7 @@
                   <a:schemeClr val="tx2"/>
                 </a:solidFill>
               </a:rPr>
-              <a:t>Gastos fijos</a:t>
+              <a:t>   100</a:t>
             </a:r>
             <a:endParaRPr lang="en-US" sz="1400" dirty="0"/>
           </a:p>
@@ -11632,7 +11643,7 @@
         </p:nvSpPr>
         <p:spPr>
           <a:xfrm>
-            <a:off x="7310628" y="2999232"/>
+            <a:off x="7310628" y="3136392"/>
             <a:ext cx="164592" cy="73152"/>
           </a:xfrm>
           <a:prstGeom prst="roundRect">
@@ -11654,7 +11665,7 @@
         </p:nvSpPr>
         <p:spPr>
           <a:xfrm>
-            <a:off x="7594092" y="2999232"/>
+            <a:off x="7594092" y="3136392"/>
             <a:ext cx="164592" cy="73152"/>
           </a:xfrm>
           <a:prstGeom prst="roundRect">
@@ -11676,7 +11687,7 @@
         </p:nvSpPr>
         <p:spPr>
           <a:xfrm>
-            <a:off x="7877556" y="2999232"/>
+            <a:off x="7877556" y="3136392"/>
             <a:ext cx="164592" cy="73152"/>
           </a:xfrm>
           <a:prstGeom prst="roundRect">
@@ -11698,7 +11709,7 @@
         </p:nvSpPr>
         <p:spPr>
           <a:xfrm>
-            <a:off x="8161020" y="2999232"/>
+            <a:off x="8161020" y="3136392"/>
             <a:ext cx="164592" cy="73152"/>
           </a:xfrm>
           <a:prstGeom prst="roundRect">
@@ -11720,7 +11731,7 @@
         </p:nvSpPr>
         <p:spPr>
           <a:xfrm>
-            <a:off x="8444484" y="2999232"/>
+            <a:off x="8444484" y="3136392"/>
             <a:ext cx="164592" cy="73152"/>
           </a:xfrm>
           <a:prstGeom prst="roundRect">
@@ -11742,7 +11753,7 @@
         </p:nvSpPr>
         <p:spPr>
           <a:xfrm>
-            <a:off x="8727948" y="2999232"/>
+            <a:off x="8727948" y="3136392"/>
             <a:ext cx="164592" cy="73152"/>
           </a:xfrm>
           <a:prstGeom prst="roundRect">
@@ -11764,7 +11775,7 @@
         </p:nvSpPr>
         <p:spPr>
           <a:xfrm>
-            <a:off x="9011412" y="2999232"/>
+            <a:off x="9011412" y="3136392"/>
             <a:ext cx="164592" cy="73152"/>
           </a:xfrm>
           <a:prstGeom prst="roundRect">
@@ -11786,7 +11797,7 @@
         </p:nvSpPr>
         <p:spPr>
           <a:xfrm>
-            <a:off x="9294876" y="2999232"/>
+            <a:off x="9294876" y="3136392"/>
             <a:ext cx="164592" cy="73152"/>
           </a:xfrm>
           <a:prstGeom prst="roundRect">
@@ -11808,7 +11819,7 @@
         </p:nvSpPr>
         <p:spPr>
           <a:xfrm>
-            <a:off x="9578340" y="2999232"/>
+            <a:off x="9578340" y="3136392"/>
             <a:ext cx="164592" cy="73152"/>
           </a:xfrm>
           <a:prstGeom prst="roundRect">
@@ -11830,7 +11841,7 @@
         </p:nvSpPr>
         <p:spPr>
           <a:xfrm>
-            <a:off x="9861804" y="2999232"/>
+            <a:off x="9861804" y="3136392"/>
             <a:ext cx="164592" cy="73152"/>
           </a:xfrm>
           <a:prstGeom prst="roundRect">
@@ -11852,7 +11863,7 @@
         </p:nvSpPr>
         <p:spPr>
           <a:xfrm>
-            <a:off x="10145268" y="2999232"/>
+            <a:off x="10145268" y="3136392"/>
             <a:ext cx="164592" cy="73152"/>
           </a:xfrm>
           <a:prstGeom prst="roundRect">
@@ -11874,7 +11885,7 @@
         </p:nvSpPr>
         <p:spPr>
           <a:xfrm>
-            <a:off x="10428732" y="2999232"/>
+            <a:off x="10428732" y="3136392"/>
             <a:ext cx="164592" cy="73152"/>
           </a:xfrm>
           <a:prstGeom prst="roundRect">
@@ -11896,7 +11907,7 @@
         </p:nvSpPr>
         <p:spPr>
           <a:xfrm>
-            <a:off x="10712196" y="2999232"/>
+            <a:off x="10712196" y="3136392"/>
             <a:ext cx="164592" cy="73152"/>
           </a:xfrm>
           <a:prstGeom prst="roundRect">
@@ -11918,7 +11929,7 @@
         </p:nvSpPr>
         <p:spPr>
           <a:xfrm>
-            <a:off x="10995660" y="2999232"/>
+            <a:off x="10995660" y="3136392"/>
             <a:ext cx="164592" cy="73152"/>
           </a:xfrm>
           <a:prstGeom prst="roundRect">
@@ -11940,7 +11951,7 @@
         </p:nvSpPr>
         <p:spPr>
           <a:xfrm>
-            <a:off x="7178040" y="3063240"/>
+            <a:off x="7178040" y="3200400"/>
             <a:ext cx="4114800" cy="548640"/>
           </a:xfrm>
           <a:prstGeom prst="roundRect">
@@ -11962,7 +11973,7 @@
         </p:nvSpPr>
         <p:spPr>
           <a:xfrm>
-            <a:off x="7205472" y="3538728"/>
+            <a:off x="7205472" y="3675888"/>
             <a:ext cx="4059936" cy="73152"/>
           </a:xfrm>
           <a:prstGeom prst="rect">
@@ -11982,7 +11993,7 @@
         </p:nvSpPr>
         <p:spPr>
           <a:xfrm>
-            <a:off x="7178040" y="3840480"/>
+            <a:off x="7178040" y="3977640"/>
             <a:ext cx="4114800" cy="274320"/>
           </a:xfrm>
           <a:prstGeom prst="rect">
@@ -11995,6 +12006,17 @@
           <a:bodyPr wrap="square" lIns="0" tIns="0" rIns="0" bIns="0" rtlCol="0" anchor="ctr"/>
           <a:lstStyle/>
           <a:p>
+            <a:pPr indent="0" marL="0">
+              <a:buNone/>
+            </a:pPr>
+            <a:r>
+              <a:rPr lang="en-US" sz="1400" b="1" dirty="0">
+                <a:solidFill>
+                  <a:schemeClr val="tx1"/>
+                </a:solidFill>
+              </a:rPr>
+              <a:t>Mayo de 2026</a:t>
+            </a:r>
             <a:pPr indent="0" marL="0">
               <a:buNone/>
             </a:pPr>
@@ -12004,7 +12026,7 @@
                   <a:schemeClr val="tx2"/>
                 </a:solidFill>
               </a:rPr>
-              <a:t>Ingreso disponible</a:t>
+              <a:t>   83,5</a:t>
             </a:r>
             <a:endParaRPr lang="en-US" sz="1400" dirty="0"/>
           </a:p>
@@ -12018,7 +12040,7 @@
         </p:nvSpPr>
         <p:spPr>
           <a:xfrm>
-            <a:off x="7312457" y="4233672"/>
+            <a:off x="7305961" y="4325112"/>
             <a:ext cx="164592" cy="73152"/>
           </a:xfrm>
           <a:prstGeom prst="roundRect">
@@ -12040,7 +12062,7 @@
         </p:nvSpPr>
         <p:spPr>
           <a:xfrm>
-            <a:off x="7599578" y="4233672"/>
+            <a:off x="7580090" y="4325112"/>
             <a:ext cx="164592" cy="73152"/>
           </a:xfrm>
           <a:prstGeom prst="roundRect">
@@ -12062,7 +12084,7 @@
         </p:nvSpPr>
         <p:spPr>
           <a:xfrm>
-            <a:off x="7886700" y="4233672"/>
+            <a:off x="7854220" y="4325112"/>
             <a:ext cx="164592" cy="73152"/>
           </a:xfrm>
           <a:prstGeom prst="roundRect">
@@ -12084,7 +12106,7 @@
         </p:nvSpPr>
         <p:spPr>
           <a:xfrm>
-            <a:off x="8173822" y="4233672"/>
+            <a:off x="8128349" y="4325112"/>
             <a:ext cx="164592" cy="73152"/>
           </a:xfrm>
           <a:prstGeom prst="roundRect">
@@ -12106,7 +12128,7 @@
         </p:nvSpPr>
         <p:spPr>
           <a:xfrm>
-            <a:off x="8460943" y="4233672"/>
+            <a:off x="8402479" y="4325112"/>
             <a:ext cx="164592" cy="73152"/>
           </a:xfrm>
           <a:prstGeom prst="roundRect">
@@ -12128,7 +12150,7 @@
         </p:nvSpPr>
         <p:spPr>
           <a:xfrm>
-            <a:off x="8748065" y="4233672"/>
+            <a:off x="8676608" y="4325112"/>
             <a:ext cx="164592" cy="73152"/>
           </a:xfrm>
           <a:prstGeom prst="roundRect">
@@ -12150,7 +12172,7 @@
         </p:nvSpPr>
         <p:spPr>
           <a:xfrm>
-            <a:off x="9035186" y="4233672"/>
+            <a:off x="8950738" y="4325112"/>
             <a:ext cx="164592" cy="73152"/>
           </a:xfrm>
           <a:prstGeom prst="roundRect">
@@ -12172,7 +12194,7 @@
         </p:nvSpPr>
         <p:spPr>
           <a:xfrm>
-            <a:off x="9322308" y="4233672"/>
+            <a:off x="9224867" y="4325112"/>
             <a:ext cx="164592" cy="73152"/>
           </a:xfrm>
           <a:prstGeom prst="roundRect">
@@ -12194,7 +12216,7 @@
         </p:nvSpPr>
         <p:spPr>
           <a:xfrm>
-            <a:off x="9609430" y="4233672"/>
+            <a:off x="9498997" y="4325112"/>
             <a:ext cx="164592" cy="73152"/>
           </a:xfrm>
           <a:prstGeom prst="roundRect">
@@ -12216,7 +12238,7 @@
         </p:nvSpPr>
         <p:spPr>
           <a:xfrm>
-            <a:off x="9896551" y="4233672"/>
+            <a:off x="9773126" y="4325112"/>
             <a:ext cx="164592" cy="73152"/>
           </a:xfrm>
           <a:prstGeom prst="roundRect">
@@ -12238,8 +12260,52 @@
         </p:nvSpPr>
         <p:spPr>
           <a:xfrm>
-            <a:off x="7178040" y="4297680"/>
-            <a:ext cx="3017520" cy="548640"/>
+            <a:off x="10047256" y="4325112"/>
+            <a:ext cx="164592" cy="73152"/>
+          </a:xfrm>
+          <a:prstGeom prst="roundRect">
+            <a:avLst>
+              <a:gd name="adj" fmla="val 37500"/>
+            </a:avLst>
+          </a:prstGeom>
+          <a:solidFill>
+            <a:schemeClr val="accent3"/>
+          </a:solidFill>
+          <a:ln/>
+        </p:spPr>
+      </p:sp>
+      <p:sp>
+        <p:nvSpPr>
+          <p:cNvPr id="41" name="Shape 39"/>
+          <p:cNvSpPr/>
+          <p:nvPr/>
+        </p:nvSpPr>
+        <p:spPr>
+          <a:xfrm>
+            <a:off x="10321385" y="4325112"/>
+            <a:ext cx="164592" cy="73152"/>
+          </a:xfrm>
+          <a:prstGeom prst="roundRect">
+            <a:avLst>
+              <a:gd name="adj" fmla="val 37500"/>
+            </a:avLst>
+          </a:prstGeom>
+          <a:solidFill>
+            <a:schemeClr val="accent3"/>
+          </a:solidFill>
+          <a:ln/>
+        </p:spPr>
+      </p:sp>
+      <p:sp>
+        <p:nvSpPr>
+          <p:cNvPr id="42" name="Shape 40"/>
+          <p:cNvSpPr/>
+          <p:nvPr/>
+        </p:nvSpPr>
+        <p:spPr>
+          <a:xfrm>
+            <a:off x="7178040" y="4389120"/>
+            <a:ext cx="3435858" cy="548640"/>
           </a:xfrm>
           <a:prstGeom prst="roundRect">
             <a:avLst>
@@ -12254,14 +12320,14 @@
       </p:sp>
       <p:sp>
         <p:nvSpPr>
-          <p:cNvPr id="41" name="Shape 39"/>
-          <p:cNvSpPr/>
-          <p:nvPr/>
-        </p:nvSpPr>
-        <p:spPr>
-          <a:xfrm>
-            <a:off x="7205472" y="4773168"/>
-            <a:ext cx="2962656" cy="73152"/>
+          <p:cNvPr id="43" name="Shape 41"/>
+          <p:cNvSpPr/>
+          <p:nvPr/>
+        </p:nvSpPr>
+        <p:spPr>
+          <a:xfrm>
+            <a:off x="7205472" y="4864608"/>
+            <a:ext cx="3380994" cy="73152"/>
           </a:xfrm>
           <a:prstGeom prst="rect">
             <a:avLst/>
@@ -12274,14 +12340,14 @@
       </p:sp>
       <p:sp>
         <p:nvSpPr>
-          <p:cNvPr id="42" name="Faltante"/>
-          <p:cNvSpPr/>
-          <p:nvPr/>
-        </p:nvSpPr>
-        <p:spPr>
-          <a:xfrm>
-            <a:off x="10241280" y="4297680"/>
-            <a:ext cx="1051560" cy="548640"/>
+          <p:cNvPr id="44" name="Caída"/>
+          <p:cNvSpPr/>
+          <p:nvPr/>
+        </p:nvSpPr>
+        <p:spPr>
+          <a:xfrm>
+            <a:off x="10650474" y="4389120"/>
+            <a:ext cx="642366" cy="548640"/>
           </a:xfrm>
           <a:prstGeom prst="rect">
             <a:avLst/>
@@ -12299,14 +12365,14 @@
       </p:sp>
       <p:sp>
         <p:nvSpPr>
-          <p:cNvPr id="43" name="Text 41"/>
+          <p:cNvPr id="45" name="Text 43"/>
           <p:cNvSpPr txBox="1"/>
           <p:nvPr/>
         </p:nvSpPr>
         <p:spPr>
           <a:xfrm>
-            <a:off x="10241280" y="4297680"/>
-            <a:ext cx="1051560" cy="548640"/>
+            <a:off x="10613898" y="4389120"/>
+            <a:ext cx="678942" cy="548640"/>
           </a:xfrm>
           <a:prstGeom prst="rect">
             <a:avLst/>
@@ -12322,26 +12388,26 @@
               <a:buNone/>
             </a:pPr>
             <a:r>
-              <a:rPr lang="en-US" sz="1300" b="1" dirty="0">
+              <a:rPr lang="en-US" sz="1200" b="1" dirty="0">
                 <a:solidFill>
                   <a:schemeClr val="accent1"/>
                 </a:solidFill>
               </a:rPr>
-              <a:t>falta</a:t>
+              <a:t>−16,5%</a:t>
             </a:r>
-            <a:endParaRPr lang="en-US" sz="1300" dirty="0"/>
+            <a:endParaRPr lang="en-US" sz="1200" dirty="0"/>
           </a:p>
         </p:txBody>
       </p:sp>
       <p:sp>
         <p:nvSpPr>
-          <p:cNvPr id="44" name="Text 42"/>
+          <p:cNvPr id="46" name="Text 44"/>
           <p:cNvSpPr txBox="1"/>
           <p:nvPr/>
         </p:nvSpPr>
         <p:spPr>
           <a:xfrm>
-            <a:off x="7178040" y="5257800"/>
+            <a:off x="7178040" y="5212080"/>
             <a:ext cx="4114800" cy="274320"/>
           </a:xfrm>
           <a:prstGeom prst="rect">
@@ -12363,9 +12429,45 @@
                   <a:schemeClr val="accent5"/>
                 </a:solidFill>
               </a:rPr>
-              <a:t>Esquema ilustrativo, no a escala.</a:t>
+              <a:t>Índice, 2023 = 100. Ladrillos a escala.</a:t>
             </a:r>
             <a:endParaRPr lang="en-US" sz="1100" dirty="0"/>
+          </a:p>
+        </p:txBody>
+      </p:sp>
+      <p:sp>
+        <p:nvSpPr>
+          <p:cNvPr id="47" name="Fuente"/>
+          <p:cNvSpPr txBox="1"/>
+          <p:nvPr/>
+        </p:nvSpPr>
+        <p:spPr>
+          <a:xfrm>
+            <a:off x="548640" y="6035040"/>
+            <a:ext cx="11094415" cy="237744"/>
+          </a:xfrm>
+          <a:prstGeom prst="rect">
+            <a:avLst/>
+          </a:prstGeom>
+          <a:noFill/>
+          <a:ln/>
+        </p:spPr>
+        <p:txBody>
+          <a:bodyPr wrap="square" lIns="0" tIns="0" rIns="0" bIns="0" rtlCol="0" anchor="ctr"/>
+          <a:lstStyle/>
+          <a:p>
+            <a:pPr indent="0" marL="0">
+              <a:buNone/>
+            </a:pPr>
+            <a:r>
+              <a:rPr lang="en-US" sz="1000" dirty="0">
+                <a:solidFill>
+                  <a:schemeClr val="accent5"/>
+                </a:solidFill>
+              </a:rPr>
+              <a:t>Fuente: Equilibra, citado por Infobae (22 de julio de 2026). Ingreso disponible = ingresos menos gastos fijos de los hogares.</a:t>
+            </a:r>
+            <a:endParaRPr lang="en-US" sz="1000" dirty="0"/>
           </a:p>
         </p:txBody>
       </p:sp>
@@ -16084,7 +16186,7 @@
                   <a:schemeClr val="accent5"/>
                 </a:solidFill>
               </a:rPr>
-              <a:t>BCRA (Informe sobre Bancos; BADLAR bancos privados), INDEC, First Capital Group y Max Capital.</a:t>
+              <a:t>BCRA (Informe sobre Bancos; BADLAR bancos privados), INDEC, Equilibra, First Capital Group y Max Capital.</a:t>
             </a:r>
             <a:endParaRPr lang="en-US" sz="1200" dirty="0"/>
           </a:p>

</xml_diff>

<commit_message>
Sumar resumen sobre Santa Fe (Word) y diapositiva de iniciativas santafesinas en la versión pieza por pieza
Co-Authored-By: Claude Opus 5.5 <noreply@anthropic.com>
Claude-Session: https://claude.ai/code/session_01LjZCUeZeukTqwmHG81QxgV
</commit_message>
<xml_diff>
--- a/presentaciones/crisis_fundar_ladrillos.pptx
+++ b/presentaciones/crisis_fundar_ladrillos.pptx
@@ -14,9 +14,10 @@
     <p:sldId id="262" r:id="rId8"/>
     <p:sldId id="263" r:id="rId9"/>
     <p:sldId id="264" r:id="rId10"/>
+    <p:sldId id="265" r:id="rId11"/>
   </p:sldIdLst>
   <p:notesMasterIdLst>
-    <p:notesMasterId r:id="rId11"/>
+    <p:notesMasterId r:id="rId12"/>
   </p:notesMasterIdLst>
   <p:sldSz cx="12192000" cy="6858000"/>
   <p:notesSz cx="6858000" cy="12192000"/>
@@ -115,18 +116,18 @@
   <p:extLst>
     <p:ext uri="{521415D9-36F7-43E2-AB2F-B90AF26B5E84}">
       <p14:sectionLst xmlns:p14="http://schemas.microsoft.com/office/powerpoint/2010/main">
-        <p14:section name="Portada" id="{a91a738f-13ff-fd54-b7d4-ac3fd19452a1}">
+        <p14:section name="Portada" id="{3c03eab3-5811-59f9-29bd-cdb10a29fbe9}">
           <p14:sldIdLst>
             <p14:sldId id="256"/>
           </p14:sldIdLst>
         </p14:section>
-        <p14:section name="Resumen" id="{fa04aee1-dc4e-16c1-0a80-21df16f4c8bd}">
+        <p14:section name="Resumen" id="{f9463ddd-dd69-38a2-3886-a9054dc2bf59}">
           <p14:sldIdLst>
             <p14:sldId id="257"/>
             <p14:sldId id="258"/>
           </p14:sldIdLst>
         </p14:section>
-        <p14:section name="Cómo se armó" id="{b253b6ad-db88-3686-819f-beb3da45012a}">
+        <p14:section name="Cómo se armó" id="{c9cbe108-0e32-e511-9dd0-5ea58f25980a}">
           <p14:sldIdLst>
             <p14:sldId id="259"/>
             <p14:sldId id="260"/>
@@ -134,10 +135,11 @@
             <p14:sldId id="262"/>
           </p14:sldIdLst>
         </p14:section>
-        <p14:section name="Qué hacer" id="{01f33ba7-dbf5-ed90-cb35-2f5258db1cc1}">
+        <p14:section name="Qué hacer" id="{efc4231d-378b-4a23-d06e-7465ba8702b7}">
           <p14:sldIdLst>
             <p14:sldId id="263"/>
             <p14:sldId id="264"/>
+            <p14:sldId id="265"/>
           </p14:sldIdLst>
         </p14:section>
       </p14:sectionLst>
@@ -4337,6 +4339,94 @@
 </p:notes>
 </file>
 
+<file path=ppt/notesSlides/notesSlide10.xml><?xml version="1.0" encoding="utf-8"?>
+<p:notes xmlns:a="http://schemas.openxmlformats.org/drawingml/2006/main" xmlns:r="http://schemas.openxmlformats.org/officeDocument/2006/relationships" xmlns:p="http://schemas.openxmlformats.org/presentationml/2006/main">
+  <p:cSld>
+    <p:spTree>
+      <p:nvGrpSpPr>
+        <p:cNvPr id="1" name=""/>
+        <p:cNvGrpSpPr/>
+        <p:nvPr/>
+      </p:nvGrpSpPr>
+      <p:grpSpPr>
+        <a:xfrm>
+          <a:off x="0" y="0"/>
+          <a:ext cx="0" cy="0"/>
+          <a:chOff x="0" y="0"/>
+          <a:chExt cx="0" cy="0"/>
+        </a:xfrm>
+      </p:grpSpPr>
+      <p:sp>
+        <p:nvSpPr>
+          <p:cNvPr id="2" name="Slide Image Placeholder 1"/>
+          <p:cNvSpPr>
+            <a:spLocks noGrp="1" noRot="1" noChangeAspect="1"/>
+          </p:cNvSpPr>
+          <p:nvPr>
+            <p:ph type="sldImg"/>
+          </p:nvPr>
+        </p:nvSpPr>
+        <p:spPr/>
+      </p:sp>
+      <p:sp>
+        <p:nvSpPr>
+          <p:cNvPr id="3" name="Notes Placeholder 2"/>
+          <p:cNvSpPr>
+            <a:spLocks noGrp="1"/>
+          </p:cNvSpPr>
+          <p:nvPr>
+            <p:ph type="body" idx="1"/>
+          </p:nvPr>
+        </p:nvSpPr>
+        <p:spPr/>
+        <p:txBody>
+          <a:bodyPr/>
+          <a:lstStyle/>
+          <a:p>
+            <a:r>
+              <a:rPr lang="en-US" dirty="0"/>
+              <a:t>Mensaje de cierre: las medidas financieras alivian, pero el problema de fondo es el ingreso. La pieza azul, la primera, es la que sostiene todo lo demás.</a:t>
+            </a:r>
+            <a:endParaRPr lang="en-US" dirty="0"/>
+          </a:p>
+        </p:txBody>
+      </p:sp>
+      <p:sp>
+        <p:nvSpPr>
+          <p:cNvPr id="4" name="Slide Number Placeholder 3"/>
+          <p:cNvSpPr>
+            <a:spLocks noGrp="1"/>
+          </p:cNvSpPr>
+          <p:nvPr>
+            <p:ph type="sldNum" sz="quarter" idx="10"/>
+          </p:nvPr>
+        </p:nvSpPr>
+        <p:spPr/>
+        <p:txBody>
+          <a:bodyPr/>
+          <a:lstStyle/>
+          <a:p>
+            <a:fld id="{F7021451-1387-4CA6-816F-3879F97B5CBC}" type="slidenum">
+              <a:rPr lang="en-US"/>
+              <a:t>10</a:t>
+            </a:fld>
+            <a:endParaRPr lang="en-US"/>
+          </a:p>
+        </p:txBody>
+      </p:sp>
+    </p:spTree>
+    <p:extLst>
+      <p:ext uri="{BB962C8B-B14F-4D97-AF65-F5344CB8AC3E}">
+        <p14:creationId xmlns:p14="http://schemas.microsoft.com/office/powerpoint/2010/main" val="1024086991"/>
+      </p:ext>
+    </p:extLst>
+  </p:cSld>
+  <p:clrMapOvr>
+    <a:masterClrMapping/>
+  </p:clrMapOvr>
+</p:notes>
+</file>
+
 <file path=ppt/notesSlides/notesSlide2.xml><?xml version="1.0" encoding="utf-8"?>
 <p:notes xmlns:a="http://schemas.openxmlformats.org/drawingml/2006/main" xmlns:r="http://schemas.openxmlformats.org/officeDocument/2006/relationships" xmlns:p="http://schemas.openxmlformats.org/presentationml/2006/main">
   <p:cSld>
@@ -4999,7 +5089,7 @@
           <a:p>
             <a:r>
               <a:rPr lang="en-US" dirty="0"/>
-              <a:t>Mensaje de cierre: las medidas financieras alivian, pero el problema de fondo es el ingreso. La pieza azul, la primera, es la que sostiene todo lo demás.</a:t>
+              <a:t>Santa Fe ya tiene un plan en marcha para unificar deudas (Plan de Protección de los Ingresos, con el Banco Santa Fe) y tres proyectos en la Legislatura. El Código de Protección de Consumidores de Mahmud es el que más se parece a nuestra recomendación provincial. Verificar si el plan siguió abierto después del 30 de septiembre.</a:t>
             </a:r>
             <a:endParaRPr lang="en-US" dirty="0"/>
           </a:p>
@@ -6591,6 +6681,450 @@
 </p:sld>
 </file>
 
+<file path=ppt/slides/slide10.xml><?xml version="1.0" encoding="utf-8"?>
+<p:sld xmlns:a="http://schemas.openxmlformats.org/drawingml/2006/main" xmlns:r="http://schemas.openxmlformats.org/officeDocument/2006/relationships" xmlns:p="http://schemas.openxmlformats.org/presentationml/2006/main">
+  <p:cSld name="Slide 10">
+    <p:spTree>
+      <p:nvGrpSpPr>
+        <p:cNvPr id="1" name=""/>
+        <p:cNvGrpSpPr/>
+        <p:nvPr/>
+      </p:nvGrpSpPr>
+      <p:grpSpPr>
+        <a:xfrm>
+          <a:off x="0" y="0"/>
+          <a:ext cx="0" cy="0"/>
+          <a:chOff x="0" y="0"/>
+          <a:chExt cx="0" cy="0"/>
+        </a:xfrm>
+      </p:grpSpPr>
+      <p:sp>
+        <p:nvSpPr>
+          <p:cNvPr id="2" name="Text 1"/>
+          <p:cNvSpPr/>
+          <p:nvPr>
+            <p:ph idx="101" type="body" hasCustomPrompt="1"/>
+          </p:nvPr>
+        </p:nvSpPr>
+        <p:spPr>
+          <a:xfrm>
+            <a:off x="548640" y="457200"/>
+            <a:ext cx="9144000" cy="274320"/>
+          </a:xfrm>
+          <a:prstGeom prst="rect">
+            <a:avLst/>
+          </a:prstGeom>
+          <a:noFill/>
+          <a:ln/>
+        </p:spPr>
+        <p:txBody>
+          <a:bodyPr wrap="square" lIns="0" tIns="0" rIns="0" bIns="0" rtlCol="0" anchor="ctr"/>
+          <a:lstStyle/>
+          <a:p>
+            <a:pPr algn="l" indent="0" marL="0">
+              <a:buNone/>
+            </a:pPr>
+            <a:r>
+              <a:rPr lang="en-US" sz="1200" b="1" spc="150" kern="0" dirty="0">
+                <a:solidFill>
+                  <a:schemeClr val="accent5"/>
+                </a:solidFill>
+              </a:rPr>
+              <a:t>ADVERTENCIA DEL FABRICANTE</a:t>
+            </a:r>
+            <a:endParaRPr lang="en-US" sz="1200" dirty="0"/>
+          </a:p>
+        </p:txBody>
+      </p:sp>
+      <p:sp>
+        <p:nvSpPr>
+          <p:cNvPr id="3" name="Text 1"/>
+          <p:cNvSpPr/>
+          <p:nvPr>
+            <p:ph idx="102" type="title" hasCustomPrompt="1"/>
+          </p:nvPr>
+        </p:nvSpPr>
+        <p:spPr>
+          <a:xfrm>
+            <a:off x="548640" y="749808"/>
+            <a:ext cx="11094415" cy="685800"/>
+          </a:xfrm>
+          <a:prstGeom prst="rect">
+            <a:avLst/>
+          </a:prstGeom>
+          <a:noFill/>
+          <a:ln/>
+        </p:spPr>
+        <p:txBody>
+          <a:bodyPr wrap="square" lIns="0" tIns="0" rIns="0" bIns="0" rtlCol="0" anchor="t"/>
+          <a:lstStyle/>
+          <a:p>
+            <a:pPr algn="l" indent="0" marL="0">
+              <a:buNone/>
+            </a:pPr>
+            <a:r>
+              <a:rPr lang="en-US" sz="3200" b="1" dirty="0">
+                <a:solidFill>
+                  <a:schemeClr val="tx1"/>
+                </a:solidFill>
+              </a:rPr>
+              <a:t>Ninguna de estas piezas reemplaza a la primera</a:t>
+            </a:r>
+            <a:endParaRPr lang="en-US" sz="3200" dirty="0"/>
+          </a:p>
+        </p:txBody>
+      </p:sp>
+      <p:sp>
+        <p:nvSpPr>
+          <p:cNvPr id="4" name="Panel advertencia"/>
+          <p:cNvSpPr/>
+          <p:nvPr/>
+        </p:nvSpPr>
+        <p:spPr>
+          <a:xfrm>
+            <a:off x="548640" y="1783080"/>
+            <a:ext cx="11094415" cy="2377440"/>
+          </a:xfrm>
+          <a:prstGeom prst="roundRect">
+            <a:avLst>
+              <a:gd name="adj" fmla="val 6154"/>
+            </a:avLst>
+          </a:prstGeom>
+          <a:solidFill>
+            <a:schemeClr val="bg1"/>
+          </a:solidFill>
+          <a:ln w="12700">
+            <a:solidFill>
+              <a:schemeClr val="accent6"/>
+            </a:solidFill>
+            <a:prstDash val="solid"/>
+          </a:ln>
+        </p:spPr>
+      </p:sp>
+      <p:sp>
+        <p:nvSpPr>
+          <p:cNvPr id="5" name="Shape 3"/>
+          <p:cNvSpPr/>
+          <p:nvPr/>
+        </p:nvSpPr>
+        <p:spPr>
+          <a:xfrm>
+            <a:off x="1083308" y="2267712"/>
+            <a:ext cx="163275" cy="73152"/>
+          </a:xfrm>
+          <a:prstGeom prst="roundRect">
+            <a:avLst>
+              <a:gd name="adj" fmla="val 37500"/>
+            </a:avLst>
+          </a:prstGeom>
+          <a:solidFill>
+            <a:schemeClr val="accent3"/>
+          </a:solidFill>
+          <a:ln/>
+        </p:spPr>
+      </p:sp>
+      <p:sp>
+        <p:nvSpPr>
+          <p:cNvPr id="6" name="Shape 4"/>
+          <p:cNvSpPr/>
+          <p:nvPr/>
+        </p:nvSpPr>
+        <p:spPr>
+          <a:xfrm>
+            <a:off x="1346655" y="2267712"/>
+            <a:ext cx="163275" cy="73152"/>
+          </a:xfrm>
+          <a:prstGeom prst="roundRect">
+            <a:avLst>
+              <a:gd name="adj" fmla="val 37500"/>
+            </a:avLst>
+          </a:prstGeom>
+          <a:solidFill>
+            <a:schemeClr val="accent3"/>
+          </a:solidFill>
+          <a:ln/>
+        </p:spPr>
+      </p:sp>
+      <p:sp>
+        <p:nvSpPr>
+          <p:cNvPr id="7" name="Shape 5"/>
+          <p:cNvSpPr/>
+          <p:nvPr/>
+        </p:nvSpPr>
+        <p:spPr>
+          <a:xfrm>
+            <a:off x="1610002" y="2267712"/>
+            <a:ext cx="163275" cy="73152"/>
+          </a:xfrm>
+          <a:prstGeom prst="roundRect">
+            <a:avLst>
+              <a:gd name="adj" fmla="val 37500"/>
+            </a:avLst>
+          </a:prstGeom>
+          <a:solidFill>
+            <a:schemeClr val="accent3"/>
+          </a:solidFill>
+          <a:ln/>
+        </p:spPr>
+      </p:sp>
+      <p:sp>
+        <p:nvSpPr>
+          <p:cNvPr id="8" name="Shape 6"/>
+          <p:cNvSpPr/>
+          <p:nvPr/>
+        </p:nvSpPr>
+        <p:spPr>
+          <a:xfrm>
+            <a:off x="1873350" y="2267712"/>
+            <a:ext cx="163275" cy="73152"/>
+          </a:xfrm>
+          <a:prstGeom prst="roundRect">
+            <a:avLst>
+              <a:gd name="adj" fmla="val 37500"/>
+            </a:avLst>
+          </a:prstGeom>
+          <a:solidFill>
+            <a:schemeClr val="accent3"/>
+          </a:solidFill>
+          <a:ln/>
+        </p:spPr>
+      </p:sp>
+      <p:sp>
+        <p:nvSpPr>
+          <p:cNvPr id="9" name="Shape 7"/>
+          <p:cNvSpPr/>
+          <p:nvPr/>
+        </p:nvSpPr>
+        <p:spPr>
+          <a:xfrm>
+            <a:off x="2136697" y="2267712"/>
+            <a:ext cx="163275" cy="73152"/>
+          </a:xfrm>
+          <a:prstGeom prst="roundRect">
+            <a:avLst>
+              <a:gd name="adj" fmla="val 37500"/>
+            </a:avLst>
+          </a:prstGeom>
+          <a:solidFill>
+            <a:schemeClr val="accent3"/>
+          </a:solidFill>
+          <a:ln/>
+        </p:spPr>
+      </p:sp>
+      <p:sp>
+        <p:nvSpPr>
+          <p:cNvPr id="10" name="Shape 8"/>
+          <p:cNvSpPr/>
+          <p:nvPr/>
+        </p:nvSpPr>
+        <p:spPr>
+          <a:xfrm>
+            <a:off x="960120" y="2331720"/>
+            <a:ext cx="1463040" cy="548640"/>
+          </a:xfrm>
+          <a:prstGeom prst="roundRect">
+            <a:avLst>
+              <a:gd name="adj" fmla="val 8333"/>
+            </a:avLst>
+          </a:prstGeom>
+          <a:solidFill>
+            <a:schemeClr val="accent3"/>
+          </a:solidFill>
+          <a:ln/>
+        </p:spPr>
+      </p:sp>
+      <p:sp>
+        <p:nvSpPr>
+          <p:cNvPr id="11" name="Shape 9"/>
+          <p:cNvSpPr/>
+          <p:nvPr/>
+        </p:nvSpPr>
+        <p:spPr>
+          <a:xfrm>
+            <a:off x="987552" y="2807208"/>
+            <a:ext cx="1408176" cy="73152"/>
+          </a:xfrm>
+          <a:prstGeom prst="rect">
+            <a:avLst/>
+          </a:prstGeom>
+          <a:solidFill>
+            <a:srgbClr val="1F4E9E"/>
+          </a:solidFill>
+          <a:ln/>
+        </p:spPr>
+      </p:sp>
+      <p:sp>
+        <p:nvSpPr>
+          <p:cNvPr id="12" name="Text 10"/>
+          <p:cNvSpPr txBox="1"/>
+          <p:nvPr/>
+        </p:nvSpPr>
+        <p:spPr>
+          <a:xfrm>
+            <a:off x="2834640" y="2011680"/>
+            <a:ext cx="8442655" cy="1188720"/>
+          </a:xfrm>
+          <a:prstGeom prst="rect">
+            <a:avLst/>
+          </a:prstGeom>
+          <a:noFill/>
+          <a:ln/>
+        </p:spPr>
+        <p:txBody>
+          <a:bodyPr wrap="square" lIns="0" tIns="0" rIns="0" bIns="0" rtlCol="0" anchor="ctr"/>
+          <a:lstStyle/>
+          <a:p>
+            <a:pPr indent="0" marL="0">
+              <a:buNone/>
+            </a:pPr>
+            <a:r>
+              <a:rPr lang="en-US" sz="2800" b="1" dirty="0">
+                <a:solidFill>
+                  <a:schemeClr val="tx1"/>
+                </a:solidFill>
+              </a:rPr>
+              <a:t>Sin recuperación del ingreso real, ninguna solución financiera alcanza.</a:t>
+            </a:r>
+            <a:endParaRPr lang="en-US" sz="2800" dirty="0"/>
+          </a:p>
+        </p:txBody>
+      </p:sp>
+      <p:sp>
+        <p:nvSpPr>
+          <p:cNvPr id="13" name="Text 11"/>
+          <p:cNvSpPr txBox="1"/>
+          <p:nvPr/>
+        </p:nvSpPr>
+        <p:spPr>
+          <a:xfrm>
+            <a:off x="2834640" y="3246120"/>
+            <a:ext cx="8442655" cy="731520"/>
+          </a:xfrm>
+          <a:prstGeom prst="rect">
+            <a:avLst/>
+          </a:prstGeom>
+          <a:noFill/>
+          <a:ln/>
+        </p:spPr>
+        <p:txBody>
+          <a:bodyPr wrap="square" lIns="0" tIns="0" rIns="0" bIns="0" rtlCol="0" anchor="t"/>
+          <a:lstStyle/>
+          <a:p>
+            <a:pPr indent="0" marL="0">
+              <a:buNone/>
+            </a:pPr>
+            <a:r>
+              <a:rPr lang="en-US" sz="1700" dirty="0">
+                <a:solidFill>
+                  <a:schemeClr val="tx2"/>
+                </a:solidFill>
+              </a:rPr>
+              <a:t>Las medidas alivian a quien ya debe y ordenan el crédito. Pero si lo que entra no alcanza, el agujero se vuelve a abrir.</a:t>
+            </a:r>
+            <a:endParaRPr lang="en-US" sz="1700" dirty="0"/>
+          </a:p>
+        </p:txBody>
+      </p:sp>
+      <p:sp>
+        <p:nvSpPr>
+          <p:cNvPr id="14" name="Text 12"/>
+          <p:cNvSpPr txBox="1"/>
+          <p:nvPr/>
+        </p:nvSpPr>
+        <p:spPr>
+          <a:xfrm>
+            <a:off x="548640" y="4526280"/>
+            <a:ext cx="11094415" cy="365760"/>
+          </a:xfrm>
+          <a:prstGeom prst="rect">
+            <a:avLst/>
+          </a:prstGeom>
+          <a:noFill/>
+          <a:ln/>
+        </p:spPr>
+        <p:txBody>
+          <a:bodyPr wrap="square" lIns="0" tIns="0" rIns="0" bIns="0" rtlCol="0" anchor="ctr"/>
+          <a:lstStyle/>
+          <a:p>
+            <a:pPr indent="0" marL="0">
+              <a:buNone/>
+            </a:pPr>
+            <a:r>
+              <a:rPr lang="en-US" sz="1200" b="1" dirty="0">
+                <a:solidFill>
+                  <a:schemeClr val="accent5"/>
+                </a:solidFill>
+              </a:rPr>
+              <a:t>Fuentes: </a:t>
+            </a:r>
+            <a:pPr indent="0" marL="0">
+              <a:buNone/>
+            </a:pPr>
+            <a:r>
+              <a:rPr lang="en-US" sz="1200" dirty="0">
+                <a:solidFill>
+                  <a:schemeClr val="accent5"/>
+                </a:solidFill>
+              </a:rPr>
+              <a:t>BCRA (Informe sobre Bancos; BADLAR bancos privados), INDEC, Equilibra, First Capital Group y Max Capital.</a:t>
+            </a:r>
+            <a:endParaRPr lang="en-US" sz="1200" dirty="0"/>
+          </a:p>
+        </p:txBody>
+      </p:sp>
+      <p:sp>
+        <p:nvSpPr>
+          <p:cNvPr id="25" name="Slide Number Placeholder 0"/>
+          <p:cNvSpPr>
+            <a:spLocks noGrp="1"/>
+          </p:cNvSpPr>
+          <p:nvPr>
+            <p:ph type="sldNum" sz="quarter" idx="4294967295"/>
+          </p:nvPr>
+        </p:nvSpPr>
+        <p:spPr>
+          <a:xfrm>
+            <a:off x="11094415" y="6400800"/>
+            <a:ext cx="548640" cy="256032"/>
+          </a:xfrm>
+          <a:prstGeom prst="rect">
+            <a:avLst/>
+          </a:prstGeom>
+          <a:extLst>
+            <a:ext uri="{C572A759-6A51-4108-AA02-DFA0A04FC94B}">
+              <ma14:wrappingTextBoxFlag xmlns:ma14="http://schemas.microsoft.com/office/mac/drawingml/2011/main" val="0"/>
+            </a:ext>
+          </a:extLst>
+        </p:spPr>
+        <p:txBody>
+          <a:bodyPr lIns="0" tIns="0" rIns="0" bIns="0"/>
+          <a:lstStyle>
+            <a:lvl1pPr>
+              <a:defRPr sz="1000">
+                <a:solidFill>
+                  <a:schemeClr val="accent5"/>
+                </a:solidFill>
+              </a:defRPr>
+            </a:lvl1pPr>
+          </a:lstStyle>
+          <a:p>
+            <a:pPr algn="r"/>
+            <a:fld id="{F7021451-1387-4CA6-816F-3879F97B5CBC}" type="slidenum">
+              <a:rPr b="0" lang="en-US"/>
+              <a:t>10</a:t>
+            </a:fld>
+            <a:endParaRPr lang="en-US"/>
+          </a:p>
+        </p:txBody>
+      </p:sp>
+    </p:spTree>
+  </p:cSld>
+  <p:clrMapOvr>
+    <a:masterClrMapping/>
+  </p:clrMapOvr>
+</p:sld>
+</file>
+
 <file path=ppt/slides/slide2.xml><?xml version="1.0" encoding="utf-8"?>
 <p:sld xmlns:a="http://schemas.openxmlformats.org/drawingml/2006/main" xmlns:r="http://schemas.openxmlformats.org/officeDocument/2006/relationships" xmlns:p="http://schemas.openxmlformats.org/presentationml/2006/main">
   <p:cSld name="Slide 2">
@@ -15850,7 +16384,7 @@
                   <a:schemeClr val="accent5"/>
                 </a:solidFill>
               </a:rPr>
-              <a:t>ADVERTENCIA DEL FABRICANTE</a:t>
+              <a:t>EJEMPLO REAL · SANTA FE</a:t>
             </a:r>
             <a:endParaRPr lang="en-US" sz="1200" dirty="0"/>
           </a:p>
@@ -15888,7 +16422,7 @@
                   <a:schemeClr val="tx1"/>
                 </a:solidFill>
               </a:rPr>
-              <a:t>Ninguna de estas piezas reemplaza a la primera</a:t>
+              <a:t>En Santa Fe ya hay piezas en marcha</a:t>
             </a:r>
             <a:endParaRPr lang="en-US" sz="3200" dirty="0"/>
           </a:p>
@@ -15896,18 +16430,18 @@
       </p:sp>
       <p:sp>
         <p:nvSpPr>
-          <p:cNvPr id="4" name="Panel advertencia"/>
+          <p:cNvPr id="4" name="Panel plan vigente"/>
           <p:cNvSpPr/>
           <p:nvPr/>
         </p:nvSpPr>
         <p:spPr>
           <a:xfrm>
             <a:off x="548640" y="1783080"/>
-            <a:ext cx="11094415" cy="2377440"/>
-          </a:xfrm>
-          <a:prstGeom prst="roundRect">
-            <a:avLst>
-              <a:gd name="adj" fmla="val 6154"/>
+            <a:ext cx="5029200" cy="3200400"/>
+          </a:xfrm>
+          <a:prstGeom prst="roundRect">
+            <a:avLst>
+              <a:gd name="adj" fmla="val 4571"/>
             </a:avLst>
           </a:prstGeom>
           <a:solidFill>
@@ -15929,160 +16463,30 @@
         </p:nvSpPr>
         <p:spPr>
           <a:xfrm>
-            <a:off x="1083308" y="2267712"/>
-            <a:ext cx="163275" cy="73152"/>
-          </a:xfrm>
-          <a:prstGeom prst="roundRect">
-            <a:avLst>
-              <a:gd name="adj" fmla="val 37500"/>
-            </a:avLst>
-          </a:prstGeom>
-          <a:solidFill>
-            <a:schemeClr val="accent3"/>
-          </a:solidFill>
-          <a:ln/>
-        </p:spPr>
-      </p:sp>
-      <p:sp>
-        <p:nvSpPr>
-          <p:cNvPr id="6" name="Shape 4"/>
-          <p:cNvSpPr/>
-          <p:nvPr/>
-        </p:nvSpPr>
-        <p:spPr>
-          <a:xfrm>
-            <a:off x="1346655" y="2267712"/>
-            <a:ext cx="163275" cy="73152"/>
-          </a:xfrm>
-          <a:prstGeom prst="roundRect">
-            <a:avLst>
-              <a:gd name="adj" fmla="val 37500"/>
-            </a:avLst>
-          </a:prstGeom>
-          <a:solidFill>
-            <a:schemeClr val="accent3"/>
-          </a:solidFill>
-          <a:ln/>
-        </p:spPr>
-      </p:sp>
-      <p:sp>
-        <p:nvSpPr>
-          <p:cNvPr id="7" name="Shape 5"/>
-          <p:cNvSpPr/>
-          <p:nvPr/>
-        </p:nvSpPr>
-        <p:spPr>
-          <a:xfrm>
-            <a:off x="1610002" y="2267712"/>
-            <a:ext cx="163275" cy="73152"/>
-          </a:xfrm>
-          <a:prstGeom prst="roundRect">
-            <a:avLst>
-              <a:gd name="adj" fmla="val 37500"/>
-            </a:avLst>
-          </a:prstGeom>
-          <a:solidFill>
-            <a:schemeClr val="accent3"/>
-          </a:solidFill>
-          <a:ln/>
-        </p:spPr>
-      </p:sp>
-      <p:sp>
-        <p:nvSpPr>
-          <p:cNvPr id="8" name="Shape 6"/>
-          <p:cNvSpPr/>
-          <p:nvPr/>
-        </p:nvSpPr>
-        <p:spPr>
-          <a:xfrm>
-            <a:off x="1873350" y="2267712"/>
-            <a:ext cx="163275" cy="73152"/>
-          </a:xfrm>
-          <a:prstGeom prst="roundRect">
-            <a:avLst>
-              <a:gd name="adj" fmla="val 37500"/>
-            </a:avLst>
-          </a:prstGeom>
-          <a:solidFill>
-            <a:schemeClr val="accent3"/>
-          </a:solidFill>
-          <a:ln/>
-        </p:spPr>
-      </p:sp>
-      <p:sp>
-        <p:nvSpPr>
-          <p:cNvPr id="9" name="Shape 7"/>
-          <p:cNvSpPr/>
-          <p:nvPr/>
-        </p:nvSpPr>
-        <p:spPr>
-          <a:xfrm>
-            <a:off x="2136697" y="2267712"/>
-            <a:ext cx="163275" cy="73152"/>
-          </a:xfrm>
-          <a:prstGeom prst="roundRect">
-            <a:avLst>
-              <a:gd name="adj" fmla="val 37500"/>
-            </a:avLst>
-          </a:prstGeom>
-          <a:solidFill>
-            <a:schemeClr val="accent3"/>
-          </a:solidFill>
-          <a:ln/>
-        </p:spPr>
-      </p:sp>
-      <p:sp>
-        <p:nvSpPr>
-          <p:cNvPr id="10" name="Shape 8"/>
-          <p:cNvSpPr/>
-          <p:nvPr/>
-        </p:nvSpPr>
-        <p:spPr>
-          <a:xfrm>
-            <a:off x="960120" y="2331720"/>
-            <a:ext cx="1463040" cy="548640"/>
-          </a:xfrm>
-          <a:prstGeom prst="roundRect">
-            <a:avLst>
-              <a:gd name="adj" fmla="val 8333"/>
-            </a:avLst>
-          </a:prstGeom>
-          <a:solidFill>
-            <a:schemeClr val="accent3"/>
-          </a:solidFill>
-          <a:ln/>
-        </p:spPr>
-      </p:sp>
-      <p:sp>
-        <p:nvSpPr>
-          <p:cNvPr id="11" name="Shape 9"/>
-          <p:cNvSpPr/>
-          <p:nvPr/>
-        </p:nvSpPr>
-        <p:spPr>
-          <a:xfrm>
-            <a:off x="987552" y="2807208"/>
-            <a:ext cx="1408176" cy="73152"/>
-          </a:xfrm>
-          <a:prstGeom prst="rect">
-            <a:avLst/>
-          </a:prstGeom>
-          <a:solidFill>
-            <a:srgbClr val="1F4E9E"/>
-          </a:solidFill>
-          <a:ln/>
-        </p:spPr>
-      </p:sp>
-      <p:sp>
-        <p:nvSpPr>
-          <p:cNvPr id="12" name="Text 10"/>
+            <a:off x="822960" y="2103120"/>
+            <a:ext cx="329184" cy="201168"/>
+          </a:xfrm>
+          <a:prstGeom prst="roundRect">
+            <a:avLst>
+              <a:gd name="adj" fmla="val 18182"/>
+            </a:avLst>
+          </a:prstGeom>
+          <a:solidFill>
+            <a:schemeClr val="accent2"/>
+          </a:solidFill>
+          <a:ln/>
+        </p:spPr>
+      </p:sp>
+      <p:sp>
+        <p:nvSpPr>
+          <p:cNvPr id="6" name="Text 4"/>
           <p:cNvSpPr txBox="1"/>
           <p:nvPr/>
         </p:nvSpPr>
         <p:spPr>
           <a:xfrm>
-            <a:off x="2834640" y="2011680"/>
-            <a:ext cx="8442655" cy="1188720"/>
+            <a:off x="1280160" y="2029968"/>
+            <a:ext cx="2743200" cy="329184"/>
           </a:xfrm>
           <a:prstGeom prst="rect">
             <a:avLst/>
@@ -16098,27 +16502,63 @@
               <a:buNone/>
             </a:pPr>
             <a:r>
-              <a:rPr lang="en-US" sz="2800" b="1" dirty="0">
+              <a:rPr lang="en-US" sz="1100" b="1" spc="150" kern="0" dirty="0">
+                <a:solidFill>
+                  <a:schemeClr val="accent5"/>
+                </a:solidFill>
+              </a:rPr>
+              <a:t>YA FUNCIONA</a:t>
+            </a:r>
+            <a:endParaRPr lang="en-US" sz="1100" dirty="0"/>
+          </a:p>
+        </p:txBody>
+      </p:sp>
+      <p:sp>
+        <p:nvSpPr>
+          <p:cNvPr id="7" name="Text 5"/>
+          <p:cNvSpPr txBox="1"/>
+          <p:nvPr/>
+        </p:nvSpPr>
+        <p:spPr>
+          <a:xfrm>
+            <a:off x="822960" y="2468880"/>
+            <a:ext cx="4480560" cy="411480"/>
+          </a:xfrm>
+          <a:prstGeom prst="rect">
+            <a:avLst/>
+          </a:prstGeom>
+          <a:noFill/>
+          <a:ln/>
+        </p:spPr>
+        <p:txBody>
+          <a:bodyPr wrap="square" lIns="0" tIns="0" rIns="0" bIns="0" rtlCol="0" anchor="ctr"/>
+          <a:lstStyle/>
+          <a:p>
+            <a:pPr indent="0" marL="0">
+              <a:buNone/>
+            </a:pPr>
+            <a:r>
+              <a:rPr lang="en-US" sz="2000" b="1" dirty="0">
                 <a:solidFill>
                   <a:schemeClr val="tx1"/>
                 </a:solidFill>
               </a:rPr>
-              <a:t>Sin recuperación del ingreso real, ninguna solución financiera alcanza.</a:t>
+              <a:t>Plan de Protección de los Ingresos</a:t>
             </a:r>
-            <a:endParaRPr lang="en-US" sz="2800" dirty="0"/>
+            <a:endParaRPr lang="en-US" sz="2000" dirty="0"/>
           </a:p>
         </p:txBody>
       </p:sp>
       <p:sp>
         <p:nvSpPr>
-          <p:cNvPr id="13" name="Text 11"/>
+          <p:cNvPr id="8" name="Text 6"/>
           <p:cNvSpPr txBox="1"/>
           <p:nvPr/>
         </p:nvSpPr>
         <p:spPr>
           <a:xfrm>
-            <a:off x="2834640" y="3246120"/>
-            <a:ext cx="8442655" cy="731520"/>
+            <a:off x="822960" y="2926080"/>
+            <a:ext cx="4480560" cy="868680"/>
           </a:xfrm>
           <a:prstGeom prst="rect">
             <a:avLst/>
@@ -16134,27 +16574,27 @@
               <a:buNone/>
             </a:pPr>
             <a:r>
-              <a:rPr lang="en-US" sz="1700" dirty="0">
+              <a:rPr lang="en-US" sz="1500" dirty="0">
                 <a:solidFill>
                   <a:schemeClr val="tx2"/>
                 </a:solidFill>
               </a:rPr>
-              <a:t>Las medidas alivian a quien ya debe y ordenan el crédito. Pero si lo que entra no alcanza, el agujero se vuelve a abrir.</a:t>
+              <a:t>Gobierno provincial y Banco Santa Fe: varias deudas pasan a un solo préstamo de hasta 60 cuotas, con dos meses de gracia.</a:t>
             </a:r>
-            <a:endParaRPr lang="en-US" sz="1700" dirty="0"/>
+            <a:endParaRPr lang="en-US" sz="1500" dirty="0"/>
           </a:p>
         </p:txBody>
       </p:sp>
       <p:sp>
         <p:nvSpPr>
-          <p:cNvPr id="14" name="Text 12"/>
+          <p:cNvPr id="9" name="Text 7"/>
           <p:cNvSpPr txBox="1"/>
           <p:nvPr/>
         </p:nvSpPr>
         <p:spPr>
           <a:xfrm>
-            <a:off x="548640" y="4526280"/>
-            <a:ext cx="11094415" cy="365760"/>
+            <a:off x="822960" y="3886200"/>
+            <a:ext cx="2194560" cy="685800"/>
           </a:xfrm>
           <a:prstGeom prst="rect">
             <a:avLst/>
@@ -16170,25 +16610,419 @@
               <a:buNone/>
             </a:pPr>
             <a:r>
-              <a:rPr lang="en-US" sz="1200" b="1" dirty="0">
+              <a:rPr lang="en-US" sz="3600" b="1" dirty="0">
+                <a:solidFill>
+                  <a:schemeClr val="tx1"/>
+                </a:solidFill>
+              </a:rPr>
+              <a:t>+18.500</a:t>
+            </a:r>
+            <a:endParaRPr lang="en-US" sz="3600" dirty="0"/>
+          </a:p>
+        </p:txBody>
+      </p:sp>
+      <p:sp>
+        <p:nvSpPr>
+          <p:cNvPr id="10" name="Text 8"/>
+          <p:cNvSpPr txBox="1"/>
+          <p:nvPr/>
+        </p:nvSpPr>
+        <p:spPr>
+          <a:xfrm>
+            <a:off x="3063240" y="3931920"/>
+            <a:ext cx="2240280" cy="640080"/>
+          </a:xfrm>
+          <a:prstGeom prst="rect">
+            <a:avLst/>
+          </a:prstGeom>
+          <a:noFill/>
+          <a:ln/>
+        </p:spPr>
+        <p:txBody>
+          <a:bodyPr wrap="square" lIns="0" tIns="0" rIns="0" bIns="0" rtlCol="0" anchor="ctr"/>
+          <a:lstStyle/>
+          <a:p>
+            <a:pPr indent="0" marL="0">
+              <a:buNone/>
+            </a:pPr>
+            <a:r>
+              <a:rPr lang="en-US" sz="1400" dirty="0">
+                <a:solidFill>
+                  <a:schemeClr val="tx2"/>
+                </a:solidFill>
+              </a:rPr>
+              <a:t>adhesiones al 11 de agosto de 2026</a:t>
+            </a:r>
+            <a:endParaRPr lang="en-US" sz="1400" dirty="0"/>
+          </a:p>
+        </p:txBody>
+      </p:sp>
+      <p:sp>
+        <p:nvSpPr>
+          <p:cNvPr id="11" name="Panel proyectos"/>
+          <p:cNvSpPr/>
+          <p:nvPr/>
+        </p:nvSpPr>
+        <p:spPr>
+          <a:xfrm>
+            <a:off x="5852160" y="1783080"/>
+            <a:ext cx="5790895" cy="3200400"/>
+          </a:xfrm>
+          <a:prstGeom prst="roundRect">
+            <a:avLst>
+              <a:gd name="adj" fmla="val 4571"/>
+            </a:avLst>
+          </a:prstGeom>
+          <a:solidFill>
+            <a:schemeClr val="bg1"/>
+          </a:solidFill>
+          <a:ln w="12700">
+            <a:solidFill>
+              <a:schemeClr val="accent6"/>
+            </a:solidFill>
+            <a:prstDash val="solid"/>
+          </a:ln>
+        </p:spPr>
+      </p:sp>
+      <p:sp>
+        <p:nvSpPr>
+          <p:cNvPr id="12" name="Shape 10"/>
+          <p:cNvSpPr/>
+          <p:nvPr/>
+        </p:nvSpPr>
+        <p:spPr>
+          <a:xfrm>
+            <a:off x="6126480" y="2103120"/>
+            <a:ext cx="329184" cy="201168"/>
+          </a:xfrm>
+          <a:prstGeom prst="roundRect">
+            <a:avLst>
+              <a:gd name="adj" fmla="val 18182"/>
+            </a:avLst>
+          </a:prstGeom>
+          <a:solidFill>
+            <a:schemeClr val="accent3"/>
+          </a:solidFill>
+          <a:ln/>
+        </p:spPr>
+      </p:sp>
+      <p:sp>
+        <p:nvSpPr>
+          <p:cNvPr id="13" name="Text 11"/>
+          <p:cNvSpPr txBox="1"/>
+          <p:nvPr/>
+        </p:nvSpPr>
+        <p:spPr>
+          <a:xfrm>
+            <a:off x="6583680" y="2029968"/>
+            <a:ext cx="3657600" cy="329184"/>
+          </a:xfrm>
+          <a:prstGeom prst="rect">
+            <a:avLst/>
+          </a:prstGeom>
+          <a:noFill/>
+          <a:ln/>
+        </p:spPr>
+        <p:txBody>
+          <a:bodyPr wrap="square" lIns="0" tIns="0" rIns="0" bIns="0" rtlCol="0" anchor="ctr"/>
+          <a:lstStyle/>
+          <a:p>
+            <a:pPr indent="0" marL="0">
+              <a:buNone/>
+            </a:pPr>
+            <a:r>
+              <a:rPr lang="en-US" sz="1100" b="1" spc="150" kern="0" dirty="0">
                 <a:solidFill>
                   <a:schemeClr val="accent5"/>
                 </a:solidFill>
               </a:rPr>
-              <a:t>Fuentes: </a:t>
+              <a:t>EN LA LEGISLATURA</a:t>
+            </a:r>
+            <a:endParaRPr lang="en-US" sz="1100" dirty="0"/>
+          </a:p>
+        </p:txBody>
+      </p:sp>
+      <p:sp>
+        <p:nvSpPr>
+          <p:cNvPr id="14" name="Text 12"/>
+          <p:cNvSpPr txBox="1"/>
+          <p:nvPr/>
+        </p:nvSpPr>
+        <p:spPr>
+          <a:xfrm>
+            <a:off x="6126480" y="2514600"/>
+            <a:ext cx="5242255" cy="731520"/>
+          </a:xfrm>
+          <a:prstGeom prst="rect">
+            <a:avLst/>
+          </a:prstGeom>
+          <a:noFill/>
+          <a:ln/>
+        </p:spPr>
+        <p:txBody>
+          <a:bodyPr wrap="square" lIns="0" tIns="0" rIns="0" bIns="0" rtlCol="0" anchor="t"/>
+          <a:lstStyle/>
+          <a:p>
+            <a:pPr indent="0" marL="0">
+              <a:buNone/>
+            </a:pPr>
+            <a:r>
+              <a:rPr lang="en-US" sz="1400" b="1" dirty="0">
+                <a:solidFill>
+                  <a:schemeClr val="tx1"/>
+                </a:solidFill>
+              </a:rPr>
+              <a:t>Código de Protección de Consumidores</a:t>
             </a:r>
             <a:pPr indent="0" marL="0">
               <a:buNone/>
             </a:pPr>
             <a:r>
-              <a:rPr lang="en-US" sz="1200" dirty="0">
+              <a:rPr lang="en-US" sz="1400" dirty="0">
                 <a:solidFill>
                   <a:schemeClr val="accent5"/>
                 </a:solidFill>
               </a:rPr>
-              <a:t>BCRA (Informe sobre Bancos; BADLAR bancos privados), INDEC, Equilibra, First Capital Group y Max Capital.</a:t>
+              <a:t> (Gisel Mahmud): </a:t>
             </a:r>
-            <a:endParaRPr lang="en-US" sz="1200" dirty="0"/>
+            <a:pPr indent="0" marL="0">
+              <a:buNone/>
+            </a:pPr>
+            <a:r>
+              <a:rPr lang="en-US" sz="1400" dirty="0">
+                <a:solidFill>
+                  <a:schemeClr val="tx2"/>
+                </a:solidFill>
+              </a:rPr>
+              <a:t>renegociar todas las deudas de la familia juntas, con asesoramiento del Estado.</a:t>
+            </a:r>
+            <a:endParaRPr lang="en-US" sz="1400" dirty="0"/>
+          </a:p>
+        </p:txBody>
+      </p:sp>
+      <p:sp>
+        <p:nvSpPr>
+          <p:cNvPr id="15" name="Text 13"/>
+          <p:cNvSpPr txBox="1"/>
+          <p:nvPr/>
+        </p:nvSpPr>
+        <p:spPr>
+          <a:xfrm>
+            <a:off x="6126480" y="3291840"/>
+            <a:ext cx="5242255" cy="731520"/>
+          </a:xfrm>
+          <a:prstGeom prst="rect">
+            <a:avLst/>
+          </a:prstGeom>
+          <a:noFill/>
+          <a:ln/>
+        </p:spPr>
+        <p:txBody>
+          <a:bodyPr wrap="square" lIns="0" tIns="0" rIns="0" bIns="0" rtlCol="0" anchor="t"/>
+          <a:lstStyle/>
+          <a:p>
+            <a:pPr indent="0" marL="0">
+              <a:buNone/>
+            </a:pPr>
+            <a:r>
+              <a:rPr lang="en-US" sz="1400" b="1" dirty="0">
+                <a:solidFill>
+                  <a:schemeClr val="tx1"/>
+                </a:solidFill>
+              </a:rPr>
+              <a:t>Refinanciación de deudas</a:t>
+            </a:r>
+            <a:pPr indent="0" marL="0">
+              <a:buNone/>
+            </a:pPr>
+            <a:r>
+              <a:rPr lang="en-US" sz="1400" dirty="0">
+                <a:solidFill>
+                  <a:schemeClr val="accent5"/>
+                </a:solidFill>
+              </a:rPr>
+              <a:t> (Lucila De Ponti): </a:t>
+            </a:r>
+            <a:pPr indent="0" marL="0">
+              <a:buNone/>
+            </a:pPr>
+            <a:r>
+              <a:rPr lang="en-US" sz="1400" dirty="0">
+                <a:solidFill>
+                  <a:schemeClr val="tx2"/>
+                </a:solidFill>
+              </a:rPr>
+              <a:t>créditos a tasa fija de hasta 35% anual y 24 meses o más.</a:t>
+            </a:r>
+            <a:endParaRPr lang="en-US" sz="1400" dirty="0"/>
+          </a:p>
+        </p:txBody>
+      </p:sp>
+      <p:sp>
+        <p:nvSpPr>
+          <p:cNvPr id="16" name="Text 14"/>
+          <p:cNvSpPr txBox="1"/>
+          <p:nvPr/>
+        </p:nvSpPr>
+        <p:spPr>
+          <a:xfrm>
+            <a:off x="6126480" y="4069080"/>
+            <a:ext cx="5242255" cy="731520"/>
+          </a:xfrm>
+          <a:prstGeom prst="rect">
+            <a:avLst/>
+          </a:prstGeom>
+          <a:noFill/>
+          <a:ln/>
+        </p:spPr>
+        <p:txBody>
+          <a:bodyPr wrap="square" lIns="0" tIns="0" rIns="0" bIns="0" rtlCol="0" anchor="t"/>
+          <a:lstStyle/>
+          <a:p>
+            <a:pPr indent="0" marL="0">
+              <a:buNone/>
+            </a:pPr>
+            <a:r>
+              <a:rPr lang="en-US" sz="1400" b="1" dirty="0">
+                <a:solidFill>
+                  <a:schemeClr val="tx1"/>
+                </a:solidFill>
+              </a:rPr>
+              <a:t>Sistema provincial de asistencia</a:t>
+            </a:r>
+            <a:pPr indent="0" marL="0">
+              <a:buNone/>
+            </a:pPr>
+            <a:r>
+              <a:rPr lang="en-US" sz="1400" dirty="0">
+                <a:solidFill>
+                  <a:schemeClr val="accent5"/>
+                </a:solidFill>
+              </a:rPr>
+              <a:t> (Marcos Corach): </a:t>
+            </a:r>
+            <a:pPr indent="0" marL="0">
+              <a:buNone/>
+            </a:pPr>
+            <a:r>
+              <a:rPr lang="en-US" sz="1400" dirty="0">
+                <a:solidFill>
+                  <a:schemeClr val="tx2"/>
+                </a:solidFill>
+              </a:rPr>
+              <a:t>asesoramiento gratuito y una mesa de mediación con los acreedores.</a:t>
+            </a:r>
+            <a:endParaRPr lang="en-US" sz="1400" dirty="0"/>
+          </a:p>
+        </p:txBody>
+      </p:sp>
+      <p:sp>
+        <p:nvSpPr>
+          <p:cNvPr id="17" name="Ejemplo"/>
+          <p:cNvSpPr/>
+          <p:nvPr/>
+        </p:nvSpPr>
+        <p:spPr>
+          <a:xfrm>
+            <a:off x="548640" y="5321808"/>
+            <a:ext cx="11094415" cy="594360"/>
+          </a:xfrm>
+          <a:prstGeom prst="roundRect">
+            <a:avLst>
+              <a:gd name="adj" fmla="val 15385"/>
+            </a:avLst>
+          </a:prstGeom>
+          <a:solidFill>
+            <a:schemeClr val="bg1"/>
+          </a:solidFill>
+          <a:ln w="12700">
+            <a:solidFill>
+              <a:schemeClr val="accent6"/>
+            </a:solidFill>
+            <a:prstDash val="solid"/>
+          </a:ln>
+        </p:spPr>
+      </p:sp>
+      <p:sp>
+        <p:nvSpPr>
+          <p:cNvPr id="18" name="Text 16"/>
+          <p:cNvSpPr txBox="1"/>
+          <p:nvPr/>
+        </p:nvSpPr>
+        <p:spPr>
+          <a:xfrm>
+            <a:off x="731520" y="5431536"/>
+            <a:ext cx="10728655" cy="374904"/>
+          </a:xfrm>
+          <a:prstGeom prst="rect">
+            <a:avLst/>
+          </a:prstGeom>
+          <a:noFill/>
+          <a:ln/>
+        </p:spPr>
+        <p:txBody>
+          <a:bodyPr wrap="square" lIns="0" tIns="0" rIns="0" bIns="0" rtlCol="0" anchor="ctr"/>
+          <a:lstStyle/>
+          <a:p>
+            <a:pPr indent="0" marL="0">
+              <a:buNone/>
+            </a:pPr>
+            <a:r>
+              <a:rPr lang="en-US" sz="1500" b="1" dirty="0">
+                <a:solidFill>
+                  <a:schemeClr val="tx1"/>
+                </a:solidFill>
+              </a:rPr>
+              <a:t>Encaja con la pieza amarilla: </a:t>
+            </a:r>
+            <a:pPr indent="0" marL="0">
+              <a:buNone/>
+            </a:pPr>
+            <a:r>
+              <a:rPr lang="en-US" sz="1500" dirty="0">
+                <a:solidFill>
+                  <a:schemeClr val="tx2"/>
+                </a:solidFill>
+              </a:rPr>
+              <a:t>una defensa del consumidor provincial que pueda mediar y sancionar.</a:t>
+            </a:r>
+            <a:endParaRPr lang="en-US" sz="1500" dirty="0"/>
+          </a:p>
+        </p:txBody>
+      </p:sp>
+      <p:sp>
+        <p:nvSpPr>
+          <p:cNvPr id="19" name="Fuente"/>
+          <p:cNvSpPr txBox="1"/>
+          <p:nvPr/>
+        </p:nvSpPr>
+        <p:spPr>
+          <a:xfrm>
+            <a:off x="548640" y="6053328"/>
+            <a:ext cx="11094415" cy="237744"/>
+          </a:xfrm>
+          <a:prstGeom prst="rect">
+            <a:avLst/>
+          </a:prstGeom>
+          <a:noFill/>
+          <a:ln/>
+        </p:spPr>
+        <p:txBody>
+          <a:bodyPr wrap="square" lIns="0" tIns="0" rIns="0" bIns="0" rtlCol="0" anchor="ctr"/>
+          <a:lstStyle/>
+          <a:p>
+            <a:pPr indent="0" marL="0">
+              <a:buNone/>
+            </a:pPr>
+            <a:r>
+              <a:rPr lang="en-US" sz="1000" dirty="0">
+                <a:solidFill>
+                  <a:schemeClr val="accent5"/>
+                </a:solidFill>
+              </a:rPr>
+              <a:t>Fuentes: Gobierno de Santa Fe, La Capital, El Litoral, Infocielo y Parlamentario. Los tres proyectos no tienen aprobación según la prensa (octubre de 2026).</a:t>
+            </a:r>
+            <a:endParaRPr lang="en-US" sz="1000" dirty="0"/>
           </a:p>
         </p:txBody>
       </p:sp>

</xml_diff>

<commit_message>
Presentación pieza por pieza: diapositiva de la mora en Santa Fe (CEPA)
Co-Authored-By: Claude Opus 5.5 <noreply@anthropic.com>
Claude-Session: https://claude.ai/code/session_01LjZCUeZeukTqwmHG81QxgV
</commit_message>
<xml_diff>
--- a/presentaciones/crisis_fundar_ladrillos.pptx
+++ b/presentaciones/crisis_fundar_ladrillos.pptx
@@ -17,9 +17,10 @@
     <p:sldId id="265" r:id="rId11"/>
     <p:sldId id="266" r:id="rId12"/>
     <p:sldId id="267" r:id="rId13"/>
+    <p:sldId id="268" r:id="rId14"/>
   </p:sldIdLst>
   <p:notesMasterIdLst>
-    <p:notesMasterId r:id="rId14"/>
+    <p:notesMasterId r:id="rId15"/>
   </p:notesMasterIdLst>
   <p:sldSz cx="12192000" cy="6858000"/>
   <p:notesSz cx="6858000" cy="12192000"/>
@@ -118,12 +119,12 @@
   <p:extLst>
     <p:ext uri="{521415D9-36F7-43E2-AB2F-B90AF26B5E84}">
       <p14:sectionLst xmlns:p14="http://schemas.microsoft.com/office/powerpoint/2010/main">
-        <p14:section name="Portada" id="{2acda060-a109-9f16-3261-b78840ef292e}">
+        <p14:section name="Portada" id="{90510fab-2661-6b50-937a-fa8406b32688}">
           <p14:sldIdLst>
             <p14:sldId id="256"/>
           </p14:sldIdLst>
         </p14:section>
-        <p14:section name="Resumen" id="{d2af9421-fccd-1bb4-7aa4-1423655b6320}">
+        <p14:section name="Resumen" id="{1f4374c3-3d6d-fcd7-82ca-eb003cf0afb4}">
           <p14:sldIdLst>
             <p14:sldId id="257"/>
             <p14:sldId id="258"/>
@@ -131,7 +132,7 @@
             <p14:sldId id="260"/>
           </p14:sldIdLst>
         </p14:section>
-        <p14:section name="Cómo se armó" id="{a2ed6461-05e7-66a7-27e7-c4c17543da82}">
+        <p14:section name="Cómo se armó" id="{7358ca47-10fa-cd7d-86d1-19db1d991c20}">
           <p14:sldIdLst>
             <p14:sldId id="261"/>
             <p14:sldId id="262"/>
@@ -139,11 +140,12 @@
             <p14:sldId id="264"/>
           </p14:sldIdLst>
         </p14:section>
-        <p14:section name="Qué hacer" id="{4ec50715-9731-15db-1101-31f47c758c19}">
+        <p14:section name="Qué hacer" id="{23691bf2-c2f9-29a0-8442-5e1c949fcd5f}">
           <p14:sldIdLst>
             <p14:sldId id="265"/>
             <p14:sldId id="266"/>
             <p14:sldId id="267"/>
+            <p14:sldId id="268"/>
           </p14:sldIdLst>
         </p14:section>
       </p14:sectionLst>
@@ -4477,7 +4479,7 @@
           <a:p>
             <a:r>
               <a:rPr lang="en-US" dirty="0"/>
-              <a:t>Santa Fe ya tiene un plan en marcha para unificar deudas (Plan de Protección de los Ingresos, con el Banco Santa Fe) y tres proyectos en la Legislatura. El Código de Protección de Consumidores de Mahmud es el que más se parece a nuestra recomendación provincial. Verificar si el plan siguió abierto después del 30 de septiembre.</a:t>
+              <a:t>Santa Fe tenía 412.845 personas en mora en julio de 2026, el 25% de sus 1,63 millones de deudores. Por tasa está entre las más bajas (22 de 24), pero por cantidad es la tercera del país. 264.770 están en situación 5, irrecuperable. La mora en billeteras virtuales (31,2%) triplica la de los bancos (9,6%). Dato extra: el departamento Rosario es el más afectado de la provincia (17,1% según CEC, junio de 2026).</a:t>
             </a:r>
             <a:endParaRPr lang="en-US" dirty="0"/>
           </a:p>
@@ -4565,7 +4567,7 @@
           <a:p>
             <a:r>
               <a:rPr lang="en-US" dirty="0"/>
-              <a:t>Mensaje de cierre: las medidas financieras alivian, pero el problema de fondo es el ingreso. La pieza azul, la primera, es la que sostiene todo lo demás.</a:t>
+              <a:t>Santa Fe ya tiene un plan en marcha para unificar deudas (Plan de Protección de los Ingresos, con el Banco Santa Fe) y tres proyectos en la Legislatura. El Código de Protección de Consumidores de Mahmud es el que más se parece a nuestra recomendación provincial. Verificar si el plan siguió abierto después del 30 de septiembre.</a:t>
             </a:r>
             <a:endParaRPr lang="en-US" dirty="0"/>
           </a:p>
@@ -4589,6 +4591,94 @@
             <a:fld id="{F7021451-1387-4CA6-816F-3879F97B5CBC}" type="slidenum">
               <a:rPr lang="en-US"/>
               <a:t>12</a:t>
+            </a:fld>
+            <a:endParaRPr lang="en-US"/>
+          </a:p>
+        </p:txBody>
+      </p:sp>
+    </p:spTree>
+    <p:extLst>
+      <p:ext uri="{BB962C8B-B14F-4D97-AF65-F5344CB8AC3E}">
+        <p14:creationId xmlns:p14="http://schemas.microsoft.com/office/powerpoint/2010/main" val="1024086991"/>
+      </p:ext>
+    </p:extLst>
+  </p:cSld>
+  <p:clrMapOvr>
+    <a:masterClrMapping/>
+  </p:clrMapOvr>
+</p:notes>
+</file>
+
+<file path=ppt/notesSlides/notesSlide13.xml><?xml version="1.0" encoding="utf-8"?>
+<p:notes xmlns:a="http://schemas.openxmlformats.org/drawingml/2006/main" xmlns:r="http://schemas.openxmlformats.org/officeDocument/2006/relationships" xmlns:p="http://schemas.openxmlformats.org/presentationml/2006/main">
+  <p:cSld>
+    <p:spTree>
+      <p:nvGrpSpPr>
+        <p:cNvPr id="1" name=""/>
+        <p:cNvGrpSpPr/>
+        <p:nvPr/>
+      </p:nvGrpSpPr>
+      <p:grpSpPr>
+        <a:xfrm>
+          <a:off x="0" y="0"/>
+          <a:ext cx="0" cy="0"/>
+          <a:chOff x="0" y="0"/>
+          <a:chExt cx="0" cy="0"/>
+        </a:xfrm>
+      </p:grpSpPr>
+      <p:sp>
+        <p:nvSpPr>
+          <p:cNvPr id="2" name="Slide Image Placeholder 1"/>
+          <p:cNvSpPr>
+            <a:spLocks noGrp="1" noRot="1" noChangeAspect="1"/>
+          </p:cNvSpPr>
+          <p:nvPr>
+            <p:ph type="sldImg"/>
+          </p:nvPr>
+        </p:nvSpPr>
+        <p:spPr/>
+      </p:sp>
+      <p:sp>
+        <p:nvSpPr>
+          <p:cNvPr id="3" name="Notes Placeholder 2"/>
+          <p:cNvSpPr>
+            <a:spLocks noGrp="1"/>
+          </p:cNvSpPr>
+          <p:nvPr>
+            <p:ph type="body" idx="1"/>
+          </p:nvPr>
+        </p:nvSpPr>
+        <p:spPr/>
+        <p:txBody>
+          <a:bodyPr/>
+          <a:lstStyle/>
+          <a:p>
+            <a:r>
+              <a:rPr lang="en-US" dirty="0"/>
+              <a:t>Mensaje de cierre: las medidas financieras alivian, pero el problema de fondo es el ingreso. La pieza azul, la primera, es la que sostiene todo lo demás.</a:t>
+            </a:r>
+            <a:endParaRPr lang="en-US" dirty="0"/>
+          </a:p>
+        </p:txBody>
+      </p:sp>
+      <p:sp>
+        <p:nvSpPr>
+          <p:cNvPr id="4" name="Slide Number Placeholder 3"/>
+          <p:cNvSpPr>
+            <a:spLocks noGrp="1"/>
+          </p:cNvSpPr>
+          <p:nvPr>
+            <p:ph type="sldNum" sz="quarter" idx="10"/>
+          </p:nvPr>
+        </p:nvSpPr>
+        <p:spPr/>
+        <p:txBody>
+          <a:bodyPr/>
+          <a:lstStyle/>
+          <a:p>
+            <a:fld id="{F7021451-1387-4CA6-816F-3879F97B5CBC}" type="slidenum">
+              <a:rPr lang="en-US"/>
+              <a:t>13</a:t>
             </a:fld>
             <a:endParaRPr lang="en-US"/>
           </a:p>
@@ -7684,6 +7774,3488 @@
                   <a:schemeClr val="accent5"/>
                 </a:solidFill>
               </a:rPr>
+              <a:t>ZOOM · SANTA FE</a:t>
+            </a:r>
+            <a:endParaRPr lang="en-US" sz="1200" dirty="0"/>
+          </a:p>
+        </p:txBody>
+      </p:sp>
+      <p:sp>
+        <p:nvSpPr>
+          <p:cNvPr id="3" name="Text 1"/>
+          <p:cNvSpPr/>
+          <p:nvPr>
+            <p:ph idx="102" type="title" hasCustomPrompt="1"/>
+          </p:nvPr>
+        </p:nvSpPr>
+        <p:spPr>
+          <a:xfrm>
+            <a:off x="548640" y="749808"/>
+            <a:ext cx="11094415" cy="685800"/>
+          </a:xfrm>
+          <a:prstGeom prst="rect">
+            <a:avLst/>
+          </a:prstGeom>
+          <a:noFill/>
+          <a:ln/>
+        </p:spPr>
+        <p:txBody>
+          <a:bodyPr wrap="square" lIns="0" tIns="0" rIns="0" bIns="0" rtlCol="0" anchor="t"/>
+          <a:lstStyle/>
+          <a:p>
+            <a:pPr algn="l" indent="0" marL="0">
+              <a:buNone/>
+            </a:pPr>
+            <a:r>
+              <a:rPr lang="en-US" sz="3200" b="1" dirty="0">
+                <a:solidFill>
+                  <a:schemeClr val="tx1"/>
+                </a:solidFill>
+              </a:rPr>
+              <a:t>En Santa Fe, 1 de cada 4 deudores está en mora</a:t>
+            </a:r>
+            <a:endParaRPr lang="en-US" sz="3200" dirty="0"/>
+          </a:p>
+        </p:txBody>
+      </p:sp>
+      <p:sp>
+        <p:nvSpPr>
+          <p:cNvPr id="4" name="Panel ladrillos Santa Fe"/>
+          <p:cNvSpPr/>
+          <p:nvPr/>
+        </p:nvSpPr>
+        <p:spPr>
+          <a:xfrm>
+            <a:off x="548640" y="1783080"/>
+            <a:ext cx="5486400" cy="3383280"/>
+          </a:xfrm>
+          <a:prstGeom prst="roundRect">
+            <a:avLst>
+              <a:gd name="adj" fmla="val 4324"/>
+            </a:avLst>
+          </a:prstGeom>
+          <a:solidFill>
+            <a:schemeClr val="bg1"/>
+          </a:solidFill>
+          <a:ln w="12700">
+            <a:solidFill>
+              <a:schemeClr val="accent6"/>
+            </a:solidFill>
+            <a:prstDash val="solid"/>
+          </a:ln>
+        </p:spPr>
+      </p:sp>
+      <p:sp>
+        <p:nvSpPr>
+          <p:cNvPr id="5" name="Text 3"/>
+          <p:cNvSpPr txBox="1"/>
+          <p:nvPr/>
+        </p:nvSpPr>
+        <p:spPr>
+          <a:xfrm>
+            <a:off x="822960" y="2011680"/>
+            <a:ext cx="4937760" cy="292608"/>
+          </a:xfrm>
+          <a:prstGeom prst="rect">
+            <a:avLst/>
+          </a:prstGeom>
+          <a:noFill/>
+          <a:ln/>
+        </p:spPr>
+        <p:txBody>
+          <a:bodyPr wrap="square" lIns="0" tIns="0" rIns="0" bIns="0" rtlCol="0" anchor="ctr"/>
+          <a:lstStyle/>
+          <a:p>
+            <a:pPr indent="0" marL="0">
+              <a:buNone/>
+            </a:pPr>
+            <a:r>
+              <a:rPr lang="en-US" sz="1500" b="1" dirty="0">
+                <a:solidFill>
+                  <a:schemeClr val="tx1"/>
+                </a:solidFill>
+              </a:rPr>
+              <a:t>De cada 40 santafesinos con deudas…</a:t>
+            </a:r>
+            <a:endParaRPr lang="en-US" sz="1500" dirty="0"/>
+          </a:p>
+        </p:txBody>
+      </p:sp>
+      <p:sp>
+        <p:nvSpPr>
+          <p:cNvPr id="6" name="Shape 4"/>
+          <p:cNvSpPr/>
+          <p:nvPr/>
+        </p:nvSpPr>
+        <p:spPr>
+          <a:xfrm>
+            <a:off x="905320" y="2554834"/>
+            <a:ext cx="30047" cy="60350"/>
+          </a:xfrm>
+          <a:prstGeom prst="roundRect">
+            <a:avLst>
+              <a:gd name="adj" fmla="val 91297"/>
+            </a:avLst>
+          </a:prstGeom>
+          <a:solidFill>
+            <a:srgbClr val="9B2A21"/>
+          </a:solidFill>
+          <a:ln/>
+        </p:spPr>
+      </p:sp>
+      <p:sp>
+        <p:nvSpPr>
+          <p:cNvPr id="7" name="Shape 5"/>
+          <p:cNvSpPr/>
+          <p:nvPr/>
+        </p:nvSpPr>
+        <p:spPr>
+          <a:xfrm>
+            <a:off x="822960" y="2606040"/>
+            <a:ext cx="194767" cy="274320"/>
+          </a:xfrm>
+          <a:prstGeom prst="roundRect">
+            <a:avLst>
+              <a:gd name="adj" fmla="val 23474"/>
+            </a:avLst>
+          </a:prstGeom>
+          <a:solidFill>
+            <a:srgbClr val="9B2A21"/>
+          </a:solidFill>
+          <a:ln/>
+        </p:spPr>
+      </p:sp>
+      <p:sp>
+        <p:nvSpPr>
+          <p:cNvPr id="8" name="Shape 6"/>
+          <p:cNvSpPr/>
+          <p:nvPr/>
+        </p:nvSpPr>
+        <p:spPr>
+          <a:xfrm>
+            <a:off x="850392" y="2830982"/>
+            <a:ext cx="139903" cy="49378"/>
+          </a:xfrm>
+          <a:prstGeom prst="rect">
+            <a:avLst/>
+          </a:prstGeom>
+          <a:solidFill>
+            <a:srgbClr val="6E1D17"/>
+          </a:solidFill>
+          <a:ln/>
+        </p:spPr>
+      </p:sp>
+      <p:sp>
+        <p:nvSpPr>
+          <p:cNvPr id="9" name="Shape 7"/>
+          <p:cNvSpPr/>
+          <p:nvPr/>
+        </p:nvSpPr>
+        <p:spPr>
+          <a:xfrm>
+            <a:off x="1154951" y="2554834"/>
+            <a:ext cx="30047" cy="60350"/>
+          </a:xfrm>
+          <a:prstGeom prst="roundRect">
+            <a:avLst>
+              <a:gd name="adj" fmla="val 91297"/>
+            </a:avLst>
+          </a:prstGeom>
+          <a:solidFill>
+            <a:srgbClr val="9B2A21"/>
+          </a:solidFill>
+          <a:ln/>
+        </p:spPr>
+      </p:sp>
+      <p:sp>
+        <p:nvSpPr>
+          <p:cNvPr id="10" name="Shape 8"/>
+          <p:cNvSpPr/>
+          <p:nvPr/>
+        </p:nvSpPr>
+        <p:spPr>
+          <a:xfrm>
+            <a:off x="1072591" y="2606040"/>
+            <a:ext cx="194767" cy="274320"/>
+          </a:xfrm>
+          <a:prstGeom prst="roundRect">
+            <a:avLst>
+              <a:gd name="adj" fmla="val 23474"/>
+            </a:avLst>
+          </a:prstGeom>
+          <a:solidFill>
+            <a:srgbClr val="9B2A21"/>
+          </a:solidFill>
+          <a:ln/>
+        </p:spPr>
+      </p:sp>
+      <p:sp>
+        <p:nvSpPr>
+          <p:cNvPr id="11" name="Shape 9"/>
+          <p:cNvSpPr/>
+          <p:nvPr/>
+        </p:nvSpPr>
+        <p:spPr>
+          <a:xfrm>
+            <a:off x="1100023" y="2830982"/>
+            <a:ext cx="139903" cy="49378"/>
+          </a:xfrm>
+          <a:prstGeom prst="rect">
+            <a:avLst/>
+          </a:prstGeom>
+          <a:solidFill>
+            <a:srgbClr val="6E1D17"/>
+          </a:solidFill>
+          <a:ln/>
+        </p:spPr>
+      </p:sp>
+      <p:sp>
+        <p:nvSpPr>
+          <p:cNvPr id="12" name="Shape 10"/>
+          <p:cNvSpPr/>
+          <p:nvPr/>
+        </p:nvSpPr>
+        <p:spPr>
+          <a:xfrm>
+            <a:off x="1404582" y="2554834"/>
+            <a:ext cx="30047" cy="60350"/>
+          </a:xfrm>
+          <a:prstGeom prst="roundRect">
+            <a:avLst>
+              <a:gd name="adj" fmla="val 91297"/>
+            </a:avLst>
+          </a:prstGeom>
+          <a:solidFill>
+            <a:srgbClr val="9B2A21"/>
+          </a:solidFill>
+          <a:ln/>
+        </p:spPr>
+      </p:sp>
+      <p:sp>
+        <p:nvSpPr>
+          <p:cNvPr id="13" name="Shape 11"/>
+          <p:cNvSpPr/>
+          <p:nvPr/>
+        </p:nvSpPr>
+        <p:spPr>
+          <a:xfrm>
+            <a:off x="1322222" y="2606040"/>
+            <a:ext cx="194767" cy="274320"/>
+          </a:xfrm>
+          <a:prstGeom prst="roundRect">
+            <a:avLst>
+              <a:gd name="adj" fmla="val 23474"/>
+            </a:avLst>
+          </a:prstGeom>
+          <a:solidFill>
+            <a:srgbClr val="9B2A21"/>
+          </a:solidFill>
+          <a:ln/>
+        </p:spPr>
+      </p:sp>
+      <p:sp>
+        <p:nvSpPr>
+          <p:cNvPr id="14" name="Shape 12"/>
+          <p:cNvSpPr/>
+          <p:nvPr/>
+        </p:nvSpPr>
+        <p:spPr>
+          <a:xfrm>
+            <a:off x="1349654" y="2830982"/>
+            <a:ext cx="139903" cy="49378"/>
+          </a:xfrm>
+          <a:prstGeom prst="rect">
+            <a:avLst/>
+          </a:prstGeom>
+          <a:solidFill>
+            <a:srgbClr val="6E1D17"/>
+          </a:solidFill>
+          <a:ln/>
+        </p:spPr>
+      </p:sp>
+      <p:sp>
+        <p:nvSpPr>
+          <p:cNvPr id="15" name="Shape 13"/>
+          <p:cNvSpPr/>
+          <p:nvPr/>
+        </p:nvSpPr>
+        <p:spPr>
+          <a:xfrm>
+            <a:off x="1654214" y="2554834"/>
+            <a:ext cx="30047" cy="60350"/>
+          </a:xfrm>
+          <a:prstGeom prst="roundRect">
+            <a:avLst>
+              <a:gd name="adj" fmla="val 91297"/>
+            </a:avLst>
+          </a:prstGeom>
+          <a:solidFill>
+            <a:srgbClr val="9B2A21"/>
+          </a:solidFill>
+          <a:ln/>
+        </p:spPr>
+      </p:sp>
+      <p:sp>
+        <p:nvSpPr>
+          <p:cNvPr id="16" name="Shape 14"/>
+          <p:cNvSpPr/>
+          <p:nvPr/>
+        </p:nvSpPr>
+        <p:spPr>
+          <a:xfrm>
+            <a:off x="1571854" y="2606040"/>
+            <a:ext cx="194767" cy="274320"/>
+          </a:xfrm>
+          <a:prstGeom prst="roundRect">
+            <a:avLst>
+              <a:gd name="adj" fmla="val 23474"/>
+            </a:avLst>
+          </a:prstGeom>
+          <a:solidFill>
+            <a:srgbClr val="9B2A21"/>
+          </a:solidFill>
+          <a:ln/>
+        </p:spPr>
+      </p:sp>
+      <p:sp>
+        <p:nvSpPr>
+          <p:cNvPr id="17" name="Shape 15"/>
+          <p:cNvSpPr/>
+          <p:nvPr/>
+        </p:nvSpPr>
+        <p:spPr>
+          <a:xfrm>
+            <a:off x="1599286" y="2830982"/>
+            <a:ext cx="139903" cy="49378"/>
+          </a:xfrm>
+          <a:prstGeom prst="rect">
+            <a:avLst/>
+          </a:prstGeom>
+          <a:solidFill>
+            <a:srgbClr val="6E1D17"/>
+          </a:solidFill>
+          <a:ln/>
+        </p:spPr>
+      </p:sp>
+      <p:sp>
+        <p:nvSpPr>
+          <p:cNvPr id="18" name="Shape 16"/>
+          <p:cNvSpPr/>
+          <p:nvPr/>
+        </p:nvSpPr>
+        <p:spPr>
+          <a:xfrm>
+            <a:off x="1903845" y="2554834"/>
+            <a:ext cx="30047" cy="60350"/>
+          </a:xfrm>
+          <a:prstGeom prst="roundRect">
+            <a:avLst>
+              <a:gd name="adj" fmla="val 91297"/>
+            </a:avLst>
+          </a:prstGeom>
+          <a:solidFill>
+            <a:srgbClr val="9B2A21"/>
+          </a:solidFill>
+          <a:ln/>
+        </p:spPr>
+      </p:sp>
+      <p:sp>
+        <p:nvSpPr>
+          <p:cNvPr id="19" name="Shape 17"/>
+          <p:cNvSpPr/>
+          <p:nvPr/>
+        </p:nvSpPr>
+        <p:spPr>
+          <a:xfrm>
+            <a:off x="1821485" y="2606040"/>
+            <a:ext cx="194767" cy="274320"/>
+          </a:xfrm>
+          <a:prstGeom prst="roundRect">
+            <a:avLst>
+              <a:gd name="adj" fmla="val 23474"/>
+            </a:avLst>
+          </a:prstGeom>
+          <a:solidFill>
+            <a:srgbClr val="9B2A21"/>
+          </a:solidFill>
+          <a:ln/>
+        </p:spPr>
+      </p:sp>
+      <p:sp>
+        <p:nvSpPr>
+          <p:cNvPr id="20" name="Shape 18"/>
+          <p:cNvSpPr/>
+          <p:nvPr/>
+        </p:nvSpPr>
+        <p:spPr>
+          <a:xfrm>
+            <a:off x="1848917" y="2830982"/>
+            <a:ext cx="139903" cy="49378"/>
+          </a:xfrm>
+          <a:prstGeom prst="rect">
+            <a:avLst/>
+          </a:prstGeom>
+          <a:solidFill>
+            <a:srgbClr val="6E1D17"/>
+          </a:solidFill>
+          <a:ln/>
+        </p:spPr>
+      </p:sp>
+      <p:sp>
+        <p:nvSpPr>
+          <p:cNvPr id="21" name="Shape 19"/>
+          <p:cNvSpPr/>
+          <p:nvPr/>
+        </p:nvSpPr>
+        <p:spPr>
+          <a:xfrm>
+            <a:off x="2153476" y="2554834"/>
+            <a:ext cx="30047" cy="60350"/>
+          </a:xfrm>
+          <a:prstGeom prst="roundRect">
+            <a:avLst>
+              <a:gd name="adj" fmla="val 91297"/>
+            </a:avLst>
+          </a:prstGeom>
+          <a:solidFill>
+            <a:srgbClr val="9B2A21"/>
+          </a:solidFill>
+          <a:ln/>
+        </p:spPr>
+      </p:sp>
+      <p:sp>
+        <p:nvSpPr>
+          <p:cNvPr id="22" name="Shape 20"/>
+          <p:cNvSpPr/>
+          <p:nvPr/>
+        </p:nvSpPr>
+        <p:spPr>
+          <a:xfrm>
+            <a:off x="2071116" y="2606040"/>
+            <a:ext cx="194767" cy="274320"/>
+          </a:xfrm>
+          <a:prstGeom prst="roundRect">
+            <a:avLst>
+              <a:gd name="adj" fmla="val 23474"/>
+            </a:avLst>
+          </a:prstGeom>
+          <a:solidFill>
+            <a:srgbClr val="9B2A21"/>
+          </a:solidFill>
+          <a:ln/>
+        </p:spPr>
+      </p:sp>
+      <p:sp>
+        <p:nvSpPr>
+          <p:cNvPr id="23" name="Shape 21"/>
+          <p:cNvSpPr/>
+          <p:nvPr/>
+        </p:nvSpPr>
+        <p:spPr>
+          <a:xfrm>
+            <a:off x="2098548" y="2830982"/>
+            <a:ext cx="139903" cy="49378"/>
+          </a:xfrm>
+          <a:prstGeom prst="rect">
+            <a:avLst/>
+          </a:prstGeom>
+          <a:solidFill>
+            <a:srgbClr val="6E1D17"/>
+          </a:solidFill>
+          <a:ln/>
+        </p:spPr>
+      </p:sp>
+      <p:sp>
+        <p:nvSpPr>
+          <p:cNvPr id="24" name="Shape 22"/>
+          <p:cNvSpPr/>
+          <p:nvPr/>
+        </p:nvSpPr>
+        <p:spPr>
+          <a:xfrm>
+            <a:off x="2403107" y="2554834"/>
+            <a:ext cx="30047" cy="60350"/>
+          </a:xfrm>
+          <a:prstGeom prst="roundRect">
+            <a:avLst>
+              <a:gd name="adj" fmla="val 91297"/>
+            </a:avLst>
+          </a:prstGeom>
+          <a:solidFill>
+            <a:srgbClr val="D23A2F"/>
+          </a:solidFill>
+          <a:ln/>
+        </p:spPr>
+      </p:sp>
+      <p:sp>
+        <p:nvSpPr>
+          <p:cNvPr id="25" name="Shape 23"/>
+          <p:cNvSpPr/>
+          <p:nvPr/>
+        </p:nvSpPr>
+        <p:spPr>
+          <a:xfrm>
+            <a:off x="2320747" y="2606040"/>
+            <a:ext cx="194767" cy="274320"/>
+          </a:xfrm>
+          <a:prstGeom prst="roundRect">
+            <a:avLst>
+              <a:gd name="adj" fmla="val 23474"/>
+            </a:avLst>
+          </a:prstGeom>
+          <a:solidFill>
+            <a:srgbClr val="D23A2F"/>
+          </a:solidFill>
+          <a:ln/>
+        </p:spPr>
+      </p:sp>
+      <p:sp>
+        <p:nvSpPr>
+          <p:cNvPr id="26" name="Shape 24"/>
+          <p:cNvSpPr/>
+          <p:nvPr/>
+        </p:nvSpPr>
+        <p:spPr>
+          <a:xfrm>
+            <a:off x="2348179" y="2830982"/>
+            <a:ext cx="139903" cy="49378"/>
+          </a:xfrm>
+          <a:prstGeom prst="rect">
+            <a:avLst/>
+          </a:prstGeom>
+          <a:solidFill>
+            <a:srgbClr val="A92E25"/>
+          </a:solidFill>
+          <a:ln/>
+        </p:spPr>
+      </p:sp>
+      <p:sp>
+        <p:nvSpPr>
+          <p:cNvPr id="27" name="Shape 25"/>
+          <p:cNvSpPr/>
+          <p:nvPr/>
+        </p:nvSpPr>
+        <p:spPr>
+          <a:xfrm>
+            <a:off x="2652738" y="2554834"/>
+            <a:ext cx="30047" cy="60350"/>
+          </a:xfrm>
+          <a:prstGeom prst="roundRect">
+            <a:avLst>
+              <a:gd name="adj" fmla="val 91297"/>
+            </a:avLst>
+          </a:prstGeom>
+          <a:solidFill>
+            <a:srgbClr val="D23A2F"/>
+          </a:solidFill>
+          <a:ln/>
+        </p:spPr>
+      </p:sp>
+      <p:sp>
+        <p:nvSpPr>
+          <p:cNvPr id="28" name="Shape 26"/>
+          <p:cNvSpPr/>
+          <p:nvPr/>
+        </p:nvSpPr>
+        <p:spPr>
+          <a:xfrm>
+            <a:off x="2570378" y="2606040"/>
+            <a:ext cx="194767" cy="274320"/>
+          </a:xfrm>
+          <a:prstGeom prst="roundRect">
+            <a:avLst>
+              <a:gd name="adj" fmla="val 23474"/>
+            </a:avLst>
+          </a:prstGeom>
+          <a:solidFill>
+            <a:srgbClr val="D23A2F"/>
+          </a:solidFill>
+          <a:ln/>
+        </p:spPr>
+      </p:sp>
+      <p:sp>
+        <p:nvSpPr>
+          <p:cNvPr id="29" name="Shape 27"/>
+          <p:cNvSpPr/>
+          <p:nvPr/>
+        </p:nvSpPr>
+        <p:spPr>
+          <a:xfrm>
+            <a:off x="2597810" y="2830982"/>
+            <a:ext cx="139903" cy="49378"/>
+          </a:xfrm>
+          <a:prstGeom prst="rect">
+            <a:avLst/>
+          </a:prstGeom>
+          <a:solidFill>
+            <a:srgbClr val="A92E25"/>
+          </a:solidFill>
+          <a:ln/>
+        </p:spPr>
+      </p:sp>
+      <p:sp>
+        <p:nvSpPr>
+          <p:cNvPr id="30" name="Shape 28"/>
+          <p:cNvSpPr/>
+          <p:nvPr/>
+        </p:nvSpPr>
+        <p:spPr>
+          <a:xfrm>
+            <a:off x="2902370" y="2554834"/>
+            <a:ext cx="30047" cy="60350"/>
+          </a:xfrm>
+          <a:prstGeom prst="roundRect">
+            <a:avLst>
+              <a:gd name="adj" fmla="val 91297"/>
+            </a:avLst>
+          </a:prstGeom>
+          <a:solidFill>
+            <a:srgbClr val="D23A2F"/>
+          </a:solidFill>
+          <a:ln/>
+        </p:spPr>
+      </p:sp>
+      <p:sp>
+        <p:nvSpPr>
+          <p:cNvPr id="31" name="Shape 29"/>
+          <p:cNvSpPr/>
+          <p:nvPr/>
+        </p:nvSpPr>
+        <p:spPr>
+          <a:xfrm>
+            <a:off x="2820010" y="2606040"/>
+            <a:ext cx="194767" cy="274320"/>
+          </a:xfrm>
+          <a:prstGeom prst="roundRect">
+            <a:avLst>
+              <a:gd name="adj" fmla="val 23474"/>
+            </a:avLst>
+          </a:prstGeom>
+          <a:solidFill>
+            <a:srgbClr val="D23A2F"/>
+          </a:solidFill>
+          <a:ln/>
+        </p:spPr>
+      </p:sp>
+      <p:sp>
+        <p:nvSpPr>
+          <p:cNvPr id="32" name="Shape 30"/>
+          <p:cNvSpPr/>
+          <p:nvPr/>
+        </p:nvSpPr>
+        <p:spPr>
+          <a:xfrm>
+            <a:off x="2847442" y="2830982"/>
+            <a:ext cx="139903" cy="49378"/>
+          </a:xfrm>
+          <a:prstGeom prst="rect">
+            <a:avLst/>
+          </a:prstGeom>
+          <a:solidFill>
+            <a:srgbClr val="A92E25"/>
+          </a:solidFill>
+          <a:ln/>
+        </p:spPr>
+      </p:sp>
+      <p:sp>
+        <p:nvSpPr>
+          <p:cNvPr id="33" name="Shape 31"/>
+          <p:cNvSpPr/>
+          <p:nvPr/>
+        </p:nvSpPr>
+        <p:spPr>
+          <a:xfrm>
+            <a:off x="3152001" y="2554834"/>
+            <a:ext cx="30047" cy="60350"/>
+          </a:xfrm>
+          <a:prstGeom prst="roundRect">
+            <a:avLst>
+              <a:gd name="adj" fmla="val 91297"/>
+            </a:avLst>
+          </a:prstGeom>
+          <a:solidFill>
+            <a:srgbClr val="D23A2F"/>
+          </a:solidFill>
+          <a:ln/>
+        </p:spPr>
+      </p:sp>
+      <p:sp>
+        <p:nvSpPr>
+          <p:cNvPr id="34" name="Shape 32"/>
+          <p:cNvSpPr/>
+          <p:nvPr/>
+        </p:nvSpPr>
+        <p:spPr>
+          <a:xfrm>
+            <a:off x="3069641" y="2606040"/>
+            <a:ext cx="194767" cy="274320"/>
+          </a:xfrm>
+          <a:prstGeom prst="roundRect">
+            <a:avLst>
+              <a:gd name="adj" fmla="val 23474"/>
+            </a:avLst>
+          </a:prstGeom>
+          <a:solidFill>
+            <a:srgbClr val="D23A2F"/>
+          </a:solidFill>
+          <a:ln/>
+        </p:spPr>
+      </p:sp>
+      <p:sp>
+        <p:nvSpPr>
+          <p:cNvPr id="35" name="Shape 33"/>
+          <p:cNvSpPr/>
+          <p:nvPr/>
+        </p:nvSpPr>
+        <p:spPr>
+          <a:xfrm>
+            <a:off x="3097073" y="2830982"/>
+            <a:ext cx="139903" cy="49378"/>
+          </a:xfrm>
+          <a:prstGeom prst="rect">
+            <a:avLst/>
+          </a:prstGeom>
+          <a:solidFill>
+            <a:srgbClr val="A92E25"/>
+          </a:solidFill>
+          <a:ln/>
+        </p:spPr>
+      </p:sp>
+      <p:sp>
+        <p:nvSpPr>
+          <p:cNvPr id="36" name="Shape 34"/>
+          <p:cNvSpPr/>
+          <p:nvPr/>
+        </p:nvSpPr>
+        <p:spPr>
+          <a:xfrm>
+            <a:off x="3401632" y="2554834"/>
+            <a:ext cx="30047" cy="60350"/>
+          </a:xfrm>
+          <a:prstGeom prst="roundRect">
+            <a:avLst>
+              <a:gd name="adj" fmla="val 91297"/>
+            </a:avLst>
+          </a:prstGeom>
+          <a:solidFill>
+            <a:srgbClr val="9A9EA6"/>
+          </a:solidFill>
+          <a:ln/>
+        </p:spPr>
+      </p:sp>
+      <p:sp>
+        <p:nvSpPr>
+          <p:cNvPr id="37" name="Shape 35"/>
+          <p:cNvSpPr/>
+          <p:nvPr/>
+        </p:nvSpPr>
+        <p:spPr>
+          <a:xfrm>
+            <a:off x="3319272" y="2606040"/>
+            <a:ext cx="194767" cy="274320"/>
+          </a:xfrm>
+          <a:prstGeom prst="roundRect">
+            <a:avLst>
+              <a:gd name="adj" fmla="val 23474"/>
+            </a:avLst>
+          </a:prstGeom>
+          <a:solidFill>
+            <a:srgbClr val="9A9EA6"/>
+          </a:solidFill>
+          <a:ln/>
+        </p:spPr>
+      </p:sp>
+      <p:sp>
+        <p:nvSpPr>
+          <p:cNvPr id="38" name="Shape 36"/>
+          <p:cNvSpPr/>
+          <p:nvPr/>
+        </p:nvSpPr>
+        <p:spPr>
+          <a:xfrm>
+            <a:off x="3346704" y="2830982"/>
+            <a:ext cx="139903" cy="49378"/>
+          </a:xfrm>
+          <a:prstGeom prst="rect">
+            <a:avLst/>
+          </a:prstGeom>
+          <a:solidFill>
+            <a:srgbClr val="7D818A"/>
+          </a:solidFill>
+          <a:ln/>
+        </p:spPr>
+      </p:sp>
+      <p:sp>
+        <p:nvSpPr>
+          <p:cNvPr id="39" name="Shape 37"/>
+          <p:cNvSpPr/>
+          <p:nvPr/>
+        </p:nvSpPr>
+        <p:spPr>
+          <a:xfrm>
+            <a:off x="3651263" y="2554834"/>
+            <a:ext cx="30047" cy="60350"/>
+          </a:xfrm>
+          <a:prstGeom prst="roundRect">
+            <a:avLst>
+              <a:gd name="adj" fmla="val 91297"/>
+            </a:avLst>
+          </a:prstGeom>
+          <a:solidFill>
+            <a:srgbClr val="9A9EA6"/>
+          </a:solidFill>
+          <a:ln/>
+        </p:spPr>
+      </p:sp>
+      <p:sp>
+        <p:nvSpPr>
+          <p:cNvPr id="40" name="Shape 38"/>
+          <p:cNvSpPr/>
+          <p:nvPr/>
+        </p:nvSpPr>
+        <p:spPr>
+          <a:xfrm>
+            <a:off x="3568903" y="2606040"/>
+            <a:ext cx="194767" cy="274320"/>
+          </a:xfrm>
+          <a:prstGeom prst="roundRect">
+            <a:avLst>
+              <a:gd name="adj" fmla="val 23474"/>
+            </a:avLst>
+          </a:prstGeom>
+          <a:solidFill>
+            <a:srgbClr val="9A9EA6"/>
+          </a:solidFill>
+          <a:ln/>
+        </p:spPr>
+      </p:sp>
+      <p:sp>
+        <p:nvSpPr>
+          <p:cNvPr id="41" name="Shape 39"/>
+          <p:cNvSpPr/>
+          <p:nvPr/>
+        </p:nvSpPr>
+        <p:spPr>
+          <a:xfrm>
+            <a:off x="3596335" y="2830982"/>
+            <a:ext cx="139903" cy="49378"/>
+          </a:xfrm>
+          <a:prstGeom prst="rect">
+            <a:avLst/>
+          </a:prstGeom>
+          <a:solidFill>
+            <a:srgbClr val="7D818A"/>
+          </a:solidFill>
+          <a:ln/>
+        </p:spPr>
+      </p:sp>
+      <p:sp>
+        <p:nvSpPr>
+          <p:cNvPr id="42" name="Shape 40"/>
+          <p:cNvSpPr/>
+          <p:nvPr/>
+        </p:nvSpPr>
+        <p:spPr>
+          <a:xfrm>
+            <a:off x="3900894" y="2554834"/>
+            <a:ext cx="30047" cy="60350"/>
+          </a:xfrm>
+          <a:prstGeom prst="roundRect">
+            <a:avLst>
+              <a:gd name="adj" fmla="val 91297"/>
+            </a:avLst>
+          </a:prstGeom>
+          <a:solidFill>
+            <a:srgbClr val="9A9EA6"/>
+          </a:solidFill>
+          <a:ln/>
+        </p:spPr>
+      </p:sp>
+      <p:sp>
+        <p:nvSpPr>
+          <p:cNvPr id="43" name="Shape 41"/>
+          <p:cNvSpPr/>
+          <p:nvPr/>
+        </p:nvSpPr>
+        <p:spPr>
+          <a:xfrm>
+            <a:off x="3818534" y="2606040"/>
+            <a:ext cx="194767" cy="274320"/>
+          </a:xfrm>
+          <a:prstGeom prst="roundRect">
+            <a:avLst>
+              <a:gd name="adj" fmla="val 23474"/>
+            </a:avLst>
+          </a:prstGeom>
+          <a:solidFill>
+            <a:srgbClr val="9A9EA6"/>
+          </a:solidFill>
+          <a:ln/>
+        </p:spPr>
+      </p:sp>
+      <p:sp>
+        <p:nvSpPr>
+          <p:cNvPr id="44" name="Shape 42"/>
+          <p:cNvSpPr/>
+          <p:nvPr/>
+        </p:nvSpPr>
+        <p:spPr>
+          <a:xfrm>
+            <a:off x="3845966" y="2830982"/>
+            <a:ext cx="139903" cy="49378"/>
+          </a:xfrm>
+          <a:prstGeom prst="rect">
+            <a:avLst/>
+          </a:prstGeom>
+          <a:solidFill>
+            <a:srgbClr val="7D818A"/>
+          </a:solidFill>
+          <a:ln/>
+        </p:spPr>
+      </p:sp>
+      <p:sp>
+        <p:nvSpPr>
+          <p:cNvPr id="45" name="Shape 43"/>
+          <p:cNvSpPr/>
+          <p:nvPr/>
+        </p:nvSpPr>
+        <p:spPr>
+          <a:xfrm>
+            <a:off x="4150526" y="2554834"/>
+            <a:ext cx="30047" cy="60350"/>
+          </a:xfrm>
+          <a:prstGeom prst="roundRect">
+            <a:avLst>
+              <a:gd name="adj" fmla="val 91297"/>
+            </a:avLst>
+          </a:prstGeom>
+          <a:solidFill>
+            <a:srgbClr val="9A9EA6"/>
+          </a:solidFill>
+          <a:ln/>
+        </p:spPr>
+      </p:sp>
+      <p:sp>
+        <p:nvSpPr>
+          <p:cNvPr id="46" name="Shape 44"/>
+          <p:cNvSpPr/>
+          <p:nvPr/>
+        </p:nvSpPr>
+        <p:spPr>
+          <a:xfrm>
+            <a:off x="4068166" y="2606040"/>
+            <a:ext cx="194767" cy="274320"/>
+          </a:xfrm>
+          <a:prstGeom prst="roundRect">
+            <a:avLst>
+              <a:gd name="adj" fmla="val 23474"/>
+            </a:avLst>
+          </a:prstGeom>
+          <a:solidFill>
+            <a:srgbClr val="9A9EA6"/>
+          </a:solidFill>
+          <a:ln/>
+        </p:spPr>
+      </p:sp>
+      <p:sp>
+        <p:nvSpPr>
+          <p:cNvPr id="47" name="Shape 45"/>
+          <p:cNvSpPr/>
+          <p:nvPr/>
+        </p:nvSpPr>
+        <p:spPr>
+          <a:xfrm>
+            <a:off x="4095598" y="2830982"/>
+            <a:ext cx="139903" cy="49378"/>
+          </a:xfrm>
+          <a:prstGeom prst="rect">
+            <a:avLst/>
+          </a:prstGeom>
+          <a:solidFill>
+            <a:srgbClr val="7D818A"/>
+          </a:solidFill>
+          <a:ln/>
+        </p:spPr>
+      </p:sp>
+      <p:sp>
+        <p:nvSpPr>
+          <p:cNvPr id="48" name="Shape 46"/>
+          <p:cNvSpPr/>
+          <p:nvPr/>
+        </p:nvSpPr>
+        <p:spPr>
+          <a:xfrm>
+            <a:off x="4400157" y="2554834"/>
+            <a:ext cx="30047" cy="60350"/>
+          </a:xfrm>
+          <a:prstGeom prst="roundRect">
+            <a:avLst>
+              <a:gd name="adj" fmla="val 91297"/>
+            </a:avLst>
+          </a:prstGeom>
+          <a:solidFill>
+            <a:srgbClr val="9A9EA6"/>
+          </a:solidFill>
+          <a:ln/>
+        </p:spPr>
+      </p:sp>
+      <p:sp>
+        <p:nvSpPr>
+          <p:cNvPr id="49" name="Shape 47"/>
+          <p:cNvSpPr/>
+          <p:nvPr/>
+        </p:nvSpPr>
+        <p:spPr>
+          <a:xfrm>
+            <a:off x="4317797" y="2606040"/>
+            <a:ext cx="194767" cy="274320"/>
+          </a:xfrm>
+          <a:prstGeom prst="roundRect">
+            <a:avLst>
+              <a:gd name="adj" fmla="val 23474"/>
+            </a:avLst>
+          </a:prstGeom>
+          <a:solidFill>
+            <a:srgbClr val="9A9EA6"/>
+          </a:solidFill>
+          <a:ln/>
+        </p:spPr>
+      </p:sp>
+      <p:sp>
+        <p:nvSpPr>
+          <p:cNvPr id="50" name="Shape 48"/>
+          <p:cNvSpPr/>
+          <p:nvPr/>
+        </p:nvSpPr>
+        <p:spPr>
+          <a:xfrm>
+            <a:off x="4345229" y="2830982"/>
+            <a:ext cx="139903" cy="49378"/>
+          </a:xfrm>
+          <a:prstGeom prst="rect">
+            <a:avLst/>
+          </a:prstGeom>
+          <a:solidFill>
+            <a:srgbClr val="7D818A"/>
+          </a:solidFill>
+          <a:ln/>
+        </p:spPr>
+      </p:sp>
+      <p:sp>
+        <p:nvSpPr>
+          <p:cNvPr id="51" name="Shape 49"/>
+          <p:cNvSpPr/>
+          <p:nvPr/>
+        </p:nvSpPr>
+        <p:spPr>
+          <a:xfrm>
+            <a:off x="4649788" y="2554834"/>
+            <a:ext cx="30047" cy="60350"/>
+          </a:xfrm>
+          <a:prstGeom prst="roundRect">
+            <a:avLst>
+              <a:gd name="adj" fmla="val 91297"/>
+            </a:avLst>
+          </a:prstGeom>
+          <a:solidFill>
+            <a:srgbClr val="9A9EA6"/>
+          </a:solidFill>
+          <a:ln/>
+        </p:spPr>
+      </p:sp>
+      <p:sp>
+        <p:nvSpPr>
+          <p:cNvPr id="52" name="Shape 50"/>
+          <p:cNvSpPr/>
+          <p:nvPr/>
+        </p:nvSpPr>
+        <p:spPr>
+          <a:xfrm>
+            <a:off x="4567428" y="2606040"/>
+            <a:ext cx="194767" cy="274320"/>
+          </a:xfrm>
+          <a:prstGeom prst="roundRect">
+            <a:avLst>
+              <a:gd name="adj" fmla="val 23474"/>
+            </a:avLst>
+          </a:prstGeom>
+          <a:solidFill>
+            <a:srgbClr val="9A9EA6"/>
+          </a:solidFill>
+          <a:ln/>
+        </p:spPr>
+      </p:sp>
+      <p:sp>
+        <p:nvSpPr>
+          <p:cNvPr id="53" name="Shape 51"/>
+          <p:cNvSpPr/>
+          <p:nvPr/>
+        </p:nvSpPr>
+        <p:spPr>
+          <a:xfrm>
+            <a:off x="4594860" y="2830982"/>
+            <a:ext cx="139903" cy="49378"/>
+          </a:xfrm>
+          <a:prstGeom prst="rect">
+            <a:avLst/>
+          </a:prstGeom>
+          <a:solidFill>
+            <a:srgbClr val="7D818A"/>
+          </a:solidFill>
+          <a:ln/>
+        </p:spPr>
+      </p:sp>
+      <p:sp>
+        <p:nvSpPr>
+          <p:cNvPr id="54" name="Shape 52"/>
+          <p:cNvSpPr/>
+          <p:nvPr/>
+        </p:nvSpPr>
+        <p:spPr>
+          <a:xfrm>
+            <a:off x="4899419" y="2554834"/>
+            <a:ext cx="30047" cy="60350"/>
+          </a:xfrm>
+          <a:prstGeom prst="roundRect">
+            <a:avLst>
+              <a:gd name="adj" fmla="val 91297"/>
+            </a:avLst>
+          </a:prstGeom>
+          <a:solidFill>
+            <a:srgbClr val="9A9EA6"/>
+          </a:solidFill>
+          <a:ln/>
+        </p:spPr>
+      </p:sp>
+      <p:sp>
+        <p:nvSpPr>
+          <p:cNvPr id="55" name="Shape 53"/>
+          <p:cNvSpPr/>
+          <p:nvPr/>
+        </p:nvSpPr>
+        <p:spPr>
+          <a:xfrm>
+            <a:off x="4817059" y="2606040"/>
+            <a:ext cx="194767" cy="274320"/>
+          </a:xfrm>
+          <a:prstGeom prst="roundRect">
+            <a:avLst>
+              <a:gd name="adj" fmla="val 23474"/>
+            </a:avLst>
+          </a:prstGeom>
+          <a:solidFill>
+            <a:srgbClr val="9A9EA6"/>
+          </a:solidFill>
+          <a:ln/>
+        </p:spPr>
+      </p:sp>
+      <p:sp>
+        <p:nvSpPr>
+          <p:cNvPr id="56" name="Shape 54"/>
+          <p:cNvSpPr/>
+          <p:nvPr/>
+        </p:nvSpPr>
+        <p:spPr>
+          <a:xfrm>
+            <a:off x="4844491" y="2830982"/>
+            <a:ext cx="139903" cy="49378"/>
+          </a:xfrm>
+          <a:prstGeom prst="rect">
+            <a:avLst/>
+          </a:prstGeom>
+          <a:solidFill>
+            <a:srgbClr val="7D818A"/>
+          </a:solidFill>
+          <a:ln/>
+        </p:spPr>
+      </p:sp>
+      <p:sp>
+        <p:nvSpPr>
+          <p:cNvPr id="57" name="Shape 55"/>
+          <p:cNvSpPr/>
+          <p:nvPr/>
+        </p:nvSpPr>
+        <p:spPr>
+          <a:xfrm>
+            <a:off x="5149050" y="2554834"/>
+            <a:ext cx="30047" cy="60350"/>
+          </a:xfrm>
+          <a:prstGeom prst="roundRect">
+            <a:avLst>
+              <a:gd name="adj" fmla="val 91297"/>
+            </a:avLst>
+          </a:prstGeom>
+          <a:solidFill>
+            <a:srgbClr val="9A9EA6"/>
+          </a:solidFill>
+          <a:ln/>
+        </p:spPr>
+      </p:sp>
+      <p:sp>
+        <p:nvSpPr>
+          <p:cNvPr id="58" name="Shape 56"/>
+          <p:cNvSpPr/>
+          <p:nvPr/>
+        </p:nvSpPr>
+        <p:spPr>
+          <a:xfrm>
+            <a:off x="5066690" y="2606040"/>
+            <a:ext cx="194767" cy="274320"/>
+          </a:xfrm>
+          <a:prstGeom prst="roundRect">
+            <a:avLst>
+              <a:gd name="adj" fmla="val 23474"/>
+            </a:avLst>
+          </a:prstGeom>
+          <a:solidFill>
+            <a:srgbClr val="9A9EA6"/>
+          </a:solidFill>
+          <a:ln/>
+        </p:spPr>
+      </p:sp>
+      <p:sp>
+        <p:nvSpPr>
+          <p:cNvPr id="59" name="Shape 57"/>
+          <p:cNvSpPr/>
+          <p:nvPr/>
+        </p:nvSpPr>
+        <p:spPr>
+          <a:xfrm>
+            <a:off x="5094122" y="2830982"/>
+            <a:ext cx="139903" cy="49378"/>
+          </a:xfrm>
+          <a:prstGeom prst="rect">
+            <a:avLst/>
+          </a:prstGeom>
+          <a:solidFill>
+            <a:srgbClr val="7D818A"/>
+          </a:solidFill>
+          <a:ln/>
+        </p:spPr>
+      </p:sp>
+      <p:sp>
+        <p:nvSpPr>
+          <p:cNvPr id="60" name="Shape 58"/>
+          <p:cNvSpPr/>
+          <p:nvPr/>
+        </p:nvSpPr>
+        <p:spPr>
+          <a:xfrm>
+            <a:off x="5398682" y="2554834"/>
+            <a:ext cx="30047" cy="60350"/>
+          </a:xfrm>
+          <a:prstGeom prst="roundRect">
+            <a:avLst>
+              <a:gd name="adj" fmla="val 91297"/>
+            </a:avLst>
+          </a:prstGeom>
+          <a:solidFill>
+            <a:srgbClr val="9A9EA6"/>
+          </a:solidFill>
+          <a:ln/>
+        </p:spPr>
+      </p:sp>
+      <p:sp>
+        <p:nvSpPr>
+          <p:cNvPr id="61" name="Shape 59"/>
+          <p:cNvSpPr/>
+          <p:nvPr/>
+        </p:nvSpPr>
+        <p:spPr>
+          <a:xfrm>
+            <a:off x="5316322" y="2606040"/>
+            <a:ext cx="194767" cy="274320"/>
+          </a:xfrm>
+          <a:prstGeom prst="roundRect">
+            <a:avLst>
+              <a:gd name="adj" fmla="val 23474"/>
+            </a:avLst>
+          </a:prstGeom>
+          <a:solidFill>
+            <a:srgbClr val="9A9EA6"/>
+          </a:solidFill>
+          <a:ln/>
+        </p:spPr>
+      </p:sp>
+      <p:sp>
+        <p:nvSpPr>
+          <p:cNvPr id="62" name="Shape 60"/>
+          <p:cNvSpPr/>
+          <p:nvPr/>
+        </p:nvSpPr>
+        <p:spPr>
+          <a:xfrm>
+            <a:off x="5343754" y="2830982"/>
+            <a:ext cx="139903" cy="49378"/>
+          </a:xfrm>
+          <a:prstGeom prst="rect">
+            <a:avLst/>
+          </a:prstGeom>
+          <a:solidFill>
+            <a:srgbClr val="7D818A"/>
+          </a:solidFill>
+          <a:ln/>
+        </p:spPr>
+      </p:sp>
+      <p:sp>
+        <p:nvSpPr>
+          <p:cNvPr id="63" name="Shape 61"/>
+          <p:cNvSpPr/>
+          <p:nvPr/>
+        </p:nvSpPr>
+        <p:spPr>
+          <a:xfrm>
+            <a:off x="5648313" y="2554834"/>
+            <a:ext cx="30047" cy="60350"/>
+          </a:xfrm>
+          <a:prstGeom prst="roundRect">
+            <a:avLst>
+              <a:gd name="adj" fmla="val 91297"/>
+            </a:avLst>
+          </a:prstGeom>
+          <a:solidFill>
+            <a:srgbClr val="9A9EA6"/>
+          </a:solidFill>
+          <a:ln/>
+        </p:spPr>
+      </p:sp>
+      <p:sp>
+        <p:nvSpPr>
+          <p:cNvPr id="64" name="Shape 62"/>
+          <p:cNvSpPr/>
+          <p:nvPr/>
+        </p:nvSpPr>
+        <p:spPr>
+          <a:xfrm>
+            <a:off x="5565953" y="2606040"/>
+            <a:ext cx="194767" cy="274320"/>
+          </a:xfrm>
+          <a:prstGeom prst="roundRect">
+            <a:avLst>
+              <a:gd name="adj" fmla="val 23474"/>
+            </a:avLst>
+          </a:prstGeom>
+          <a:solidFill>
+            <a:srgbClr val="9A9EA6"/>
+          </a:solidFill>
+          <a:ln/>
+        </p:spPr>
+      </p:sp>
+      <p:sp>
+        <p:nvSpPr>
+          <p:cNvPr id="65" name="Shape 63"/>
+          <p:cNvSpPr/>
+          <p:nvPr/>
+        </p:nvSpPr>
+        <p:spPr>
+          <a:xfrm>
+            <a:off x="5593385" y="2830982"/>
+            <a:ext cx="139903" cy="49378"/>
+          </a:xfrm>
+          <a:prstGeom prst="rect">
+            <a:avLst/>
+          </a:prstGeom>
+          <a:solidFill>
+            <a:srgbClr val="7D818A"/>
+          </a:solidFill>
+          <a:ln/>
+        </p:spPr>
+      </p:sp>
+      <p:sp>
+        <p:nvSpPr>
+          <p:cNvPr id="66" name="Shape 64"/>
+          <p:cNvSpPr/>
+          <p:nvPr/>
+        </p:nvSpPr>
+        <p:spPr>
+          <a:xfrm>
+            <a:off x="905320" y="2975458"/>
+            <a:ext cx="30047" cy="60350"/>
+          </a:xfrm>
+          <a:prstGeom prst="roundRect">
+            <a:avLst>
+              <a:gd name="adj" fmla="val 91297"/>
+            </a:avLst>
+          </a:prstGeom>
+          <a:solidFill>
+            <a:srgbClr val="9A9EA6"/>
+          </a:solidFill>
+          <a:ln/>
+        </p:spPr>
+      </p:sp>
+      <p:sp>
+        <p:nvSpPr>
+          <p:cNvPr id="67" name="Shape 65"/>
+          <p:cNvSpPr/>
+          <p:nvPr/>
+        </p:nvSpPr>
+        <p:spPr>
+          <a:xfrm>
+            <a:off x="822960" y="3026664"/>
+            <a:ext cx="194767" cy="274320"/>
+          </a:xfrm>
+          <a:prstGeom prst="roundRect">
+            <a:avLst>
+              <a:gd name="adj" fmla="val 23474"/>
+            </a:avLst>
+          </a:prstGeom>
+          <a:solidFill>
+            <a:srgbClr val="9A9EA6"/>
+          </a:solidFill>
+          <a:ln/>
+        </p:spPr>
+      </p:sp>
+      <p:sp>
+        <p:nvSpPr>
+          <p:cNvPr id="68" name="Shape 66"/>
+          <p:cNvSpPr/>
+          <p:nvPr/>
+        </p:nvSpPr>
+        <p:spPr>
+          <a:xfrm>
+            <a:off x="850392" y="3251606"/>
+            <a:ext cx="139903" cy="49378"/>
+          </a:xfrm>
+          <a:prstGeom prst="rect">
+            <a:avLst/>
+          </a:prstGeom>
+          <a:solidFill>
+            <a:srgbClr val="7D818A"/>
+          </a:solidFill>
+          <a:ln/>
+        </p:spPr>
+      </p:sp>
+      <p:sp>
+        <p:nvSpPr>
+          <p:cNvPr id="69" name="Shape 67"/>
+          <p:cNvSpPr/>
+          <p:nvPr/>
+        </p:nvSpPr>
+        <p:spPr>
+          <a:xfrm>
+            <a:off x="1154951" y="2975458"/>
+            <a:ext cx="30047" cy="60350"/>
+          </a:xfrm>
+          <a:prstGeom prst="roundRect">
+            <a:avLst>
+              <a:gd name="adj" fmla="val 91297"/>
+            </a:avLst>
+          </a:prstGeom>
+          <a:solidFill>
+            <a:srgbClr val="9A9EA6"/>
+          </a:solidFill>
+          <a:ln/>
+        </p:spPr>
+      </p:sp>
+      <p:sp>
+        <p:nvSpPr>
+          <p:cNvPr id="70" name="Shape 68"/>
+          <p:cNvSpPr/>
+          <p:nvPr/>
+        </p:nvSpPr>
+        <p:spPr>
+          <a:xfrm>
+            <a:off x="1072591" y="3026664"/>
+            <a:ext cx="194767" cy="274320"/>
+          </a:xfrm>
+          <a:prstGeom prst="roundRect">
+            <a:avLst>
+              <a:gd name="adj" fmla="val 23474"/>
+            </a:avLst>
+          </a:prstGeom>
+          <a:solidFill>
+            <a:srgbClr val="9A9EA6"/>
+          </a:solidFill>
+          <a:ln/>
+        </p:spPr>
+      </p:sp>
+      <p:sp>
+        <p:nvSpPr>
+          <p:cNvPr id="71" name="Shape 69"/>
+          <p:cNvSpPr/>
+          <p:nvPr/>
+        </p:nvSpPr>
+        <p:spPr>
+          <a:xfrm>
+            <a:off x="1100023" y="3251606"/>
+            <a:ext cx="139903" cy="49378"/>
+          </a:xfrm>
+          <a:prstGeom prst="rect">
+            <a:avLst/>
+          </a:prstGeom>
+          <a:solidFill>
+            <a:srgbClr val="7D818A"/>
+          </a:solidFill>
+          <a:ln/>
+        </p:spPr>
+      </p:sp>
+      <p:sp>
+        <p:nvSpPr>
+          <p:cNvPr id="72" name="Shape 70"/>
+          <p:cNvSpPr/>
+          <p:nvPr/>
+        </p:nvSpPr>
+        <p:spPr>
+          <a:xfrm>
+            <a:off x="1404582" y="2975458"/>
+            <a:ext cx="30047" cy="60350"/>
+          </a:xfrm>
+          <a:prstGeom prst="roundRect">
+            <a:avLst>
+              <a:gd name="adj" fmla="val 91297"/>
+            </a:avLst>
+          </a:prstGeom>
+          <a:solidFill>
+            <a:srgbClr val="9A9EA6"/>
+          </a:solidFill>
+          <a:ln/>
+        </p:spPr>
+      </p:sp>
+      <p:sp>
+        <p:nvSpPr>
+          <p:cNvPr id="73" name="Shape 71"/>
+          <p:cNvSpPr/>
+          <p:nvPr/>
+        </p:nvSpPr>
+        <p:spPr>
+          <a:xfrm>
+            <a:off x="1322222" y="3026664"/>
+            <a:ext cx="194767" cy="274320"/>
+          </a:xfrm>
+          <a:prstGeom prst="roundRect">
+            <a:avLst>
+              <a:gd name="adj" fmla="val 23474"/>
+            </a:avLst>
+          </a:prstGeom>
+          <a:solidFill>
+            <a:srgbClr val="9A9EA6"/>
+          </a:solidFill>
+          <a:ln/>
+        </p:spPr>
+      </p:sp>
+      <p:sp>
+        <p:nvSpPr>
+          <p:cNvPr id="74" name="Shape 72"/>
+          <p:cNvSpPr/>
+          <p:nvPr/>
+        </p:nvSpPr>
+        <p:spPr>
+          <a:xfrm>
+            <a:off x="1349654" y="3251606"/>
+            <a:ext cx="139903" cy="49378"/>
+          </a:xfrm>
+          <a:prstGeom prst="rect">
+            <a:avLst/>
+          </a:prstGeom>
+          <a:solidFill>
+            <a:srgbClr val="7D818A"/>
+          </a:solidFill>
+          <a:ln/>
+        </p:spPr>
+      </p:sp>
+      <p:sp>
+        <p:nvSpPr>
+          <p:cNvPr id="75" name="Shape 73"/>
+          <p:cNvSpPr/>
+          <p:nvPr/>
+        </p:nvSpPr>
+        <p:spPr>
+          <a:xfrm>
+            <a:off x="1654214" y="2975458"/>
+            <a:ext cx="30047" cy="60350"/>
+          </a:xfrm>
+          <a:prstGeom prst="roundRect">
+            <a:avLst>
+              <a:gd name="adj" fmla="val 91297"/>
+            </a:avLst>
+          </a:prstGeom>
+          <a:solidFill>
+            <a:srgbClr val="9A9EA6"/>
+          </a:solidFill>
+          <a:ln/>
+        </p:spPr>
+      </p:sp>
+      <p:sp>
+        <p:nvSpPr>
+          <p:cNvPr id="76" name="Shape 74"/>
+          <p:cNvSpPr/>
+          <p:nvPr/>
+        </p:nvSpPr>
+        <p:spPr>
+          <a:xfrm>
+            <a:off x="1571854" y="3026664"/>
+            <a:ext cx="194767" cy="274320"/>
+          </a:xfrm>
+          <a:prstGeom prst="roundRect">
+            <a:avLst>
+              <a:gd name="adj" fmla="val 23474"/>
+            </a:avLst>
+          </a:prstGeom>
+          <a:solidFill>
+            <a:srgbClr val="9A9EA6"/>
+          </a:solidFill>
+          <a:ln/>
+        </p:spPr>
+      </p:sp>
+      <p:sp>
+        <p:nvSpPr>
+          <p:cNvPr id="77" name="Shape 75"/>
+          <p:cNvSpPr/>
+          <p:nvPr/>
+        </p:nvSpPr>
+        <p:spPr>
+          <a:xfrm>
+            <a:off x="1599286" y="3251606"/>
+            <a:ext cx="139903" cy="49378"/>
+          </a:xfrm>
+          <a:prstGeom prst="rect">
+            <a:avLst/>
+          </a:prstGeom>
+          <a:solidFill>
+            <a:srgbClr val="7D818A"/>
+          </a:solidFill>
+          <a:ln/>
+        </p:spPr>
+      </p:sp>
+      <p:sp>
+        <p:nvSpPr>
+          <p:cNvPr id="78" name="Shape 76"/>
+          <p:cNvSpPr/>
+          <p:nvPr/>
+        </p:nvSpPr>
+        <p:spPr>
+          <a:xfrm>
+            <a:off x="1903845" y="2975458"/>
+            <a:ext cx="30047" cy="60350"/>
+          </a:xfrm>
+          <a:prstGeom prst="roundRect">
+            <a:avLst>
+              <a:gd name="adj" fmla="val 91297"/>
+            </a:avLst>
+          </a:prstGeom>
+          <a:solidFill>
+            <a:srgbClr val="9A9EA6"/>
+          </a:solidFill>
+          <a:ln/>
+        </p:spPr>
+      </p:sp>
+      <p:sp>
+        <p:nvSpPr>
+          <p:cNvPr id="79" name="Shape 77"/>
+          <p:cNvSpPr/>
+          <p:nvPr/>
+        </p:nvSpPr>
+        <p:spPr>
+          <a:xfrm>
+            <a:off x="1821485" y="3026664"/>
+            <a:ext cx="194767" cy="274320"/>
+          </a:xfrm>
+          <a:prstGeom prst="roundRect">
+            <a:avLst>
+              <a:gd name="adj" fmla="val 23474"/>
+            </a:avLst>
+          </a:prstGeom>
+          <a:solidFill>
+            <a:srgbClr val="9A9EA6"/>
+          </a:solidFill>
+          <a:ln/>
+        </p:spPr>
+      </p:sp>
+      <p:sp>
+        <p:nvSpPr>
+          <p:cNvPr id="80" name="Shape 78"/>
+          <p:cNvSpPr/>
+          <p:nvPr/>
+        </p:nvSpPr>
+        <p:spPr>
+          <a:xfrm>
+            <a:off x="1848917" y="3251606"/>
+            <a:ext cx="139903" cy="49378"/>
+          </a:xfrm>
+          <a:prstGeom prst="rect">
+            <a:avLst/>
+          </a:prstGeom>
+          <a:solidFill>
+            <a:srgbClr val="7D818A"/>
+          </a:solidFill>
+          <a:ln/>
+        </p:spPr>
+      </p:sp>
+      <p:sp>
+        <p:nvSpPr>
+          <p:cNvPr id="81" name="Shape 79"/>
+          <p:cNvSpPr/>
+          <p:nvPr/>
+        </p:nvSpPr>
+        <p:spPr>
+          <a:xfrm>
+            <a:off x="2153476" y="2975458"/>
+            <a:ext cx="30047" cy="60350"/>
+          </a:xfrm>
+          <a:prstGeom prst="roundRect">
+            <a:avLst>
+              <a:gd name="adj" fmla="val 91297"/>
+            </a:avLst>
+          </a:prstGeom>
+          <a:solidFill>
+            <a:srgbClr val="9A9EA6"/>
+          </a:solidFill>
+          <a:ln/>
+        </p:spPr>
+      </p:sp>
+      <p:sp>
+        <p:nvSpPr>
+          <p:cNvPr id="82" name="Shape 80"/>
+          <p:cNvSpPr/>
+          <p:nvPr/>
+        </p:nvSpPr>
+        <p:spPr>
+          <a:xfrm>
+            <a:off x="2071116" y="3026664"/>
+            <a:ext cx="194767" cy="274320"/>
+          </a:xfrm>
+          <a:prstGeom prst="roundRect">
+            <a:avLst>
+              <a:gd name="adj" fmla="val 23474"/>
+            </a:avLst>
+          </a:prstGeom>
+          <a:solidFill>
+            <a:srgbClr val="9A9EA6"/>
+          </a:solidFill>
+          <a:ln/>
+        </p:spPr>
+      </p:sp>
+      <p:sp>
+        <p:nvSpPr>
+          <p:cNvPr id="83" name="Shape 81"/>
+          <p:cNvSpPr/>
+          <p:nvPr/>
+        </p:nvSpPr>
+        <p:spPr>
+          <a:xfrm>
+            <a:off x="2098548" y="3251606"/>
+            <a:ext cx="139903" cy="49378"/>
+          </a:xfrm>
+          <a:prstGeom prst="rect">
+            <a:avLst/>
+          </a:prstGeom>
+          <a:solidFill>
+            <a:srgbClr val="7D818A"/>
+          </a:solidFill>
+          <a:ln/>
+        </p:spPr>
+      </p:sp>
+      <p:sp>
+        <p:nvSpPr>
+          <p:cNvPr id="84" name="Shape 82"/>
+          <p:cNvSpPr/>
+          <p:nvPr/>
+        </p:nvSpPr>
+        <p:spPr>
+          <a:xfrm>
+            <a:off x="2403107" y="2975458"/>
+            <a:ext cx="30047" cy="60350"/>
+          </a:xfrm>
+          <a:prstGeom prst="roundRect">
+            <a:avLst>
+              <a:gd name="adj" fmla="val 91297"/>
+            </a:avLst>
+          </a:prstGeom>
+          <a:solidFill>
+            <a:srgbClr val="9A9EA6"/>
+          </a:solidFill>
+          <a:ln/>
+        </p:spPr>
+      </p:sp>
+      <p:sp>
+        <p:nvSpPr>
+          <p:cNvPr id="85" name="Shape 83"/>
+          <p:cNvSpPr/>
+          <p:nvPr/>
+        </p:nvSpPr>
+        <p:spPr>
+          <a:xfrm>
+            <a:off x="2320747" y="3026664"/>
+            <a:ext cx="194767" cy="274320"/>
+          </a:xfrm>
+          <a:prstGeom prst="roundRect">
+            <a:avLst>
+              <a:gd name="adj" fmla="val 23474"/>
+            </a:avLst>
+          </a:prstGeom>
+          <a:solidFill>
+            <a:srgbClr val="9A9EA6"/>
+          </a:solidFill>
+          <a:ln/>
+        </p:spPr>
+      </p:sp>
+      <p:sp>
+        <p:nvSpPr>
+          <p:cNvPr id="86" name="Shape 84"/>
+          <p:cNvSpPr/>
+          <p:nvPr/>
+        </p:nvSpPr>
+        <p:spPr>
+          <a:xfrm>
+            <a:off x="2348179" y="3251606"/>
+            <a:ext cx="139903" cy="49378"/>
+          </a:xfrm>
+          <a:prstGeom prst="rect">
+            <a:avLst/>
+          </a:prstGeom>
+          <a:solidFill>
+            <a:srgbClr val="7D818A"/>
+          </a:solidFill>
+          <a:ln/>
+        </p:spPr>
+      </p:sp>
+      <p:sp>
+        <p:nvSpPr>
+          <p:cNvPr id="87" name="Shape 85"/>
+          <p:cNvSpPr/>
+          <p:nvPr/>
+        </p:nvSpPr>
+        <p:spPr>
+          <a:xfrm>
+            <a:off x="2652738" y="2975458"/>
+            <a:ext cx="30047" cy="60350"/>
+          </a:xfrm>
+          <a:prstGeom prst="roundRect">
+            <a:avLst>
+              <a:gd name="adj" fmla="val 91297"/>
+            </a:avLst>
+          </a:prstGeom>
+          <a:solidFill>
+            <a:srgbClr val="9A9EA6"/>
+          </a:solidFill>
+          <a:ln/>
+        </p:spPr>
+      </p:sp>
+      <p:sp>
+        <p:nvSpPr>
+          <p:cNvPr id="88" name="Shape 86"/>
+          <p:cNvSpPr/>
+          <p:nvPr/>
+        </p:nvSpPr>
+        <p:spPr>
+          <a:xfrm>
+            <a:off x="2570378" y="3026664"/>
+            <a:ext cx="194767" cy="274320"/>
+          </a:xfrm>
+          <a:prstGeom prst="roundRect">
+            <a:avLst>
+              <a:gd name="adj" fmla="val 23474"/>
+            </a:avLst>
+          </a:prstGeom>
+          <a:solidFill>
+            <a:srgbClr val="9A9EA6"/>
+          </a:solidFill>
+          <a:ln/>
+        </p:spPr>
+      </p:sp>
+      <p:sp>
+        <p:nvSpPr>
+          <p:cNvPr id="89" name="Shape 87"/>
+          <p:cNvSpPr/>
+          <p:nvPr/>
+        </p:nvSpPr>
+        <p:spPr>
+          <a:xfrm>
+            <a:off x="2597810" y="3251606"/>
+            <a:ext cx="139903" cy="49378"/>
+          </a:xfrm>
+          <a:prstGeom prst="rect">
+            <a:avLst/>
+          </a:prstGeom>
+          <a:solidFill>
+            <a:srgbClr val="7D818A"/>
+          </a:solidFill>
+          <a:ln/>
+        </p:spPr>
+      </p:sp>
+      <p:sp>
+        <p:nvSpPr>
+          <p:cNvPr id="90" name="Shape 88"/>
+          <p:cNvSpPr/>
+          <p:nvPr/>
+        </p:nvSpPr>
+        <p:spPr>
+          <a:xfrm>
+            <a:off x="2902370" y="2975458"/>
+            <a:ext cx="30047" cy="60350"/>
+          </a:xfrm>
+          <a:prstGeom prst="roundRect">
+            <a:avLst>
+              <a:gd name="adj" fmla="val 91297"/>
+            </a:avLst>
+          </a:prstGeom>
+          <a:solidFill>
+            <a:srgbClr val="9A9EA6"/>
+          </a:solidFill>
+          <a:ln/>
+        </p:spPr>
+      </p:sp>
+      <p:sp>
+        <p:nvSpPr>
+          <p:cNvPr id="91" name="Shape 89"/>
+          <p:cNvSpPr/>
+          <p:nvPr/>
+        </p:nvSpPr>
+        <p:spPr>
+          <a:xfrm>
+            <a:off x="2820010" y="3026664"/>
+            <a:ext cx="194767" cy="274320"/>
+          </a:xfrm>
+          <a:prstGeom prst="roundRect">
+            <a:avLst>
+              <a:gd name="adj" fmla="val 23474"/>
+            </a:avLst>
+          </a:prstGeom>
+          <a:solidFill>
+            <a:srgbClr val="9A9EA6"/>
+          </a:solidFill>
+          <a:ln/>
+        </p:spPr>
+      </p:sp>
+      <p:sp>
+        <p:nvSpPr>
+          <p:cNvPr id="92" name="Shape 90"/>
+          <p:cNvSpPr/>
+          <p:nvPr/>
+        </p:nvSpPr>
+        <p:spPr>
+          <a:xfrm>
+            <a:off x="2847442" y="3251606"/>
+            <a:ext cx="139903" cy="49378"/>
+          </a:xfrm>
+          <a:prstGeom prst="rect">
+            <a:avLst/>
+          </a:prstGeom>
+          <a:solidFill>
+            <a:srgbClr val="7D818A"/>
+          </a:solidFill>
+          <a:ln/>
+        </p:spPr>
+      </p:sp>
+      <p:sp>
+        <p:nvSpPr>
+          <p:cNvPr id="93" name="Shape 91"/>
+          <p:cNvSpPr/>
+          <p:nvPr/>
+        </p:nvSpPr>
+        <p:spPr>
+          <a:xfrm>
+            <a:off x="3152001" y="2975458"/>
+            <a:ext cx="30047" cy="60350"/>
+          </a:xfrm>
+          <a:prstGeom prst="roundRect">
+            <a:avLst>
+              <a:gd name="adj" fmla="val 91297"/>
+            </a:avLst>
+          </a:prstGeom>
+          <a:solidFill>
+            <a:srgbClr val="9A9EA6"/>
+          </a:solidFill>
+          <a:ln/>
+        </p:spPr>
+      </p:sp>
+      <p:sp>
+        <p:nvSpPr>
+          <p:cNvPr id="94" name="Shape 92"/>
+          <p:cNvSpPr/>
+          <p:nvPr/>
+        </p:nvSpPr>
+        <p:spPr>
+          <a:xfrm>
+            <a:off x="3069641" y="3026664"/>
+            <a:ext cx="194767" cy="274320"/>
+          </a:xfrm>
+          <a:prstGeom prst="roundRect">
+            <a:avLst>
+              <a:gd name="adj" fmla="val 23474"/>
+            </a:avLst>
+          </a:prstGeom>
+          <a:solidFill>
+            <a:srgbClr val="9A9EA6"/>
+          </a:solidFill>
+          <a:ln/>
+        </p:spPr>
+      </p:sp>
+      <p:sp>
+        <p:nvSpPr>
+          <p:cNvPr id="95" name="Shape 93"/>
+          <p:cNvSpPr/>
+          <p:nvPr/>
+        </p:nvSpPr>
+        <p:spPr>
+          <a:xfrm>
+            <a:off x="3097073" y="3251606"/>
+            <a:ext cx="139903" cy="49378"/>
+          </a:xfrm>
+          <a:prstGeom prst="rect">
+            <a:avLst/>
+          </a:prstGeom>
+          <a:solidFill>
+            <a:srgbClr val="7D818A"/>
+          </a:solidFill>
+          <a:ln/>
+        </p:spPr>
+      </p:sp>
+      <p:sp>
+        <p:nvSpPr>
+          <p:cNvPr id="96" name="Shape 94"/>
+          <p:cNvSpPr/>
+          <p:nvPr/>
+        </p:nvSpPr>
+        <p:spPr>
+          <a:xfrm>
+            <a:off x="3401632" y="2975458"/>
+            <a:ext cx="30047" cy="60350"/>
+          </a:xfrm>
+          <a:prstGeom prst="roundRect">
+            <a:avLst>
+              <a:gd name="adj" fmla="val 91297"/>
+            </a:avLst>
+          </a:prstGeom>
+          <a:solidFill>
+            <a:srgbClr val="9A9EA6"/>
+          </a:solidFill>
+          <a:ln/>
+        </p:spPr>
+      </p:sp>
+      <p:sp>
+        <p:nvSpPr>
+          <p:cNvPr id="97" name="Shape 95"/>
+          <p:cNvSpPr/>
+          <p:nvPr/>
+        </p:nvSpPr>
+        <p:spPr>
+          <a:xfrm>
+            <a:off x="3319272" y="3026664"/>
+            <a:ext cx="194767" cy="274320"/>
+          </a:xfrm>
+          <a:prstGeom prst="roundRect">
+            <a:avLst>
+              <a:gd name="adj" fmla="val 23474"/>
+            </a:avLst>
+          </a:prstGeom>
+          <a:solidFill>
+            <a:srgbClr val="9A9EA6"/>
+          </a:solidFill>
+          <a:ln/>
+        </p:spPr>
+      </p:sp>
+      <p:sp>
+        <p:nvSpPr>
+          <p:cNvPr id="98" name="Shape 96"/>
+          <p:cNvSpPr/>
+          <p:nvPr/>
+        </p:nvSpPr>
+        <p:spPr>
+          <a:xfrm>
+            <a:off x="3346704" y="3251606"/>
+            <a:ext cx="139903" cy="49378"/>
+          </a:xfrm>
+          <a:prstGeom prst="rect">
+            <a:avLst/>
+          </a:prstGeom>
+          <a:solidFill>
+            <a:srgbClr val="7D818A"/>
+          </a:solidFill>
+          <a:ln/>
+        </p:spPr>
+      </p:sp>
+      <p:sp>
+        <p:nvSpPr>
+          <p:cNvPr id="99" name="Shape 97"/>
+          <p:cNvSpPr/>
+          <p:nvPr/>
+        </p:nvSpPr>
+        <p:spPr>
+          <a:xfrm>
+            <a:off x="3651263" y="2975458"/>
+            <a:ext cx="30047" cy="60350"/>
+          </a:xfrm>
+          <a:prstGeom prst="roundRect">
+            <a:avLst>
+              <a:gd name="adj" fmla="val 91297"/>
+            </a:avLst>
+          </a:prstGeom>
+          <a:solidFill>
+            <a:srgbClr val="9A9EA6"/>
+          </a:solidFill>
+          <a:ln/>
+        </p:spPr>
+      </p:sp>
+      <p:sp>
+        <p:nvSpPr>
+          <p:cNvPr id="100" name="Shape 98"/>
+          <p:cNvSpPr/>
+          <p:nvPr/>
+        </p:nvSpPr>
+        <p:spPr>
+          <a:xfrm>
+            <a:off x="3568903" y="3026664"/>
+            <a:ext cx="194767" cy="274320"/>
+          </a:xfrm>
+          <a:prstGeom prst="roundRect">
+            <a:avLst>
+              <a:gd name="adj" fmla="val 23474"/>
+            </a:avLst>
+          </a:prstGeom>
+          <a:solidFill>
+            <a:srgbClr val="9A9EA6"/>
+          </a:solidFill>
+          <a:ln/>
+        </p:spPr>
+      </p:sp>
+      <p:sp>
+        <p:nvSpPr>
+          <p:cNvPr id="101" name="Shape 99"/>
+          <p:cNvSpPr/>
+          <p:nvPr/>
+        </p:nvSpPr>
+        <p:spPr>
+          <a:xfrm>
+            <a:off x="3596335" y="3251606"/>
+            <a:ext cx="139903" cy="49378"/>
+          </a:xfrm>
+          <a:prstGeom prst="rect">
+            <a:avLst/>
+          </a:prstGeom>
+          <a:solidFill>
+            <a:srgbClr val="7D818A"/>
+          </a:solidFill>
+          <a:ln/>
+        </p:spPr>
+      </p:sp>
+      <p:sp>
+        <p:nvSpPr>
+          <p:cNvPr id="102" name="Shape 100"/>
+          <p:cNvSpPr/>
+          <p:nvPr/>
+        </p:nvSpPr>
+        <p:spPr>
+          <a:xfrm>
+            <a:off x="3900894" y="2975458"/>
+            <a:ext cx="30047" cy="60350"/>
+          </a:xfrm>
+          <a:prstGeom prst="roundRect">
+            <a:avLst>
+              <a:gd name="adj" fmla="val 91297"/>
+            </a:avLst>
+          </a:prstGeom>
+          <a:solidFill>
+            <a:srgbClr val="9A9EA6"/>
+          </a:solidFill>
+          <a:ln/>
+        </p:spPr>
+      </p:sp>
+      <p:sp>
+        <p:nvSpPr>
+          <p:cNvPr id="103" name="Shape 101"/>
+          <p:cNvSpPr/>
+          <p:nvPr/>
+        </p:nvSpPr>
+        <p:spPr>
+          <a:xfrm>
+            <a:off x="3818534" y="3026664"/>
+            <a:ext cx="194767" cy="274320"/>
+          </a:xfrm>
+          <a:prstGeom prst="roundRect">
+            <a:avLst>
+              <a:gd name="adj" fmla="val 23474"/>
+            </a:avLst>
+          </a:prstGeom>
+          <a:solidFill>
+            <a:srgbClr val="9A9EA6"/>
+          </a:solidFill>
+          <a:ln/>
+        </p:spPr>
+      </p:sp>
+      <p:sp>
+        <p:nvSpPr>
+          <p:cNvPr id="104" name="Shape 102"/>
+          <p:cNvSpPr/>
+          <p:nvPr/>
+        </p:nvSpPr>
+        <p:spPr>
+          <a:xfrm>
+            <a:off x="3845966" y="3251606"/>
+            <a:ext cx="139903" cy="49378"/>
+          </a:xfrm>
+          <a:prstGeom prst="rect">
+            <a:avLst/>
+          </a:prstGeom>
+          <a:solidFill>
+            <a:srgbClr val="7D818A"/>
+          </a:solidFill>
+          <a:ln/>
+        </p:spPr>
+      </p:sp>
+      <p:sp>
+        <p:nvSpPr>
+          <p:cNvPr id="105" name="Shape 103"/>
+          <p:cNvSpPr/>
+          <p:nvPr/>
+        </p:nvSpPr>
+        <p:spPr>
+          <a:xfrm>
+            <a:off x="4150526" y="2975458"/>
+            <a:ext cx="30047" cy="60350"/>
+          </a:xfrm>
+          <a:prstGeom prst="roundRect">
+            <a:avLst>
+              <a:gd name="adj" fmla="val 91297"/>
+            </a:avLst>
+          </a:prstGeom>
+          <a:solidFill>
+            <a:srgbClr val="9A9EA6"/>
+          </a:solidFill>
+          <a:ln/>
+        </p:spPr>
+      </p:sp>
+      <p:sp>
+        <p:nvSpPr>
+          <p:cNvPr id="106" name="Shape 104"/>
+          <p:cNvSpPr/>
+          <p:nvPr/>
+        </p:nvSpPr>
+        <p:spPr>
+          <a:xfrm>
+            <a:off x="4068166" y="3026664"/>
+            <a:ext cx="194767" cy="274320"/>
+          </a:xfrm>
+          <a:prstGeom prst="roundRect">
+            <a:avLst>
+              <a:gd name="adj" fmla="val 23474"/>
+            </a:avLst>
+          </a:prstGeom>
+          <a:solidFill>
+            <a:srgbClr val="9A9EA6"/>
+          </a:solidFill>
+          <a:ln/>
+        </p:spPr>
+      </p:sp>
+      <p:sp>
+        <p:nvSpPr>
+          <p:cNvPr id="107" name="Shape 105"/>
+          <p:cNvSpPr/>
+          <p:nvPr/>
+        </p:nvSpPr>
+        <p:spPr>
+          <a:xfrm>
+            <a:off x="4095598" y="3251606"/>
+            <a:ext cx="139903" cy="49378"/>
+          </a:xfrm>
+          <a:prstGeom prst="rect">
+            <a:avLst/>
+          </a:prstGeom>
+          <a:solidFill>
+            <a:srgbClr val="7D818A"/>
+          </a:solidFill>
+          <a:ln/>
+        </p:spPr>
+      </p:sp>
+      <p:sp>
+        <p:nvSpPr>
+          <p:cNvPr id="108" name="Shape 106"/>
+          <p:cNvSpPr/>
+          <p:nvPr/>
+        </p:nvSpPr>
+        <p:spPr>
+          <a:xfrm>
+            <a:off x="4400157" y="2975458"/>
+            <a:ext cx="30047" cy="60350"/>
+          </a:xfrm>
+          <a:prstGeom prst="roundRect">
+            <a:avLst>
+              <a:gd name="adj" fmla="val 91297"/>
+            </a:avLst>
+          </a:prstGeom>
+          <a:solidFill>
+            <a:srgbClr val="9A9EA6"/>
+          </a:solidFill>
+          <a:ln/>
+        </p:spPr>
+      </p:sp>
+      <p:sp>
+        <p:nvSpPr>
+          <p:cNvPr id="109" name="Shape 107"/>
+          <p:cNvSpPr/>
+          <p:nvPr/>
+        </p:nvSpPr>
+        <p:spPr>
+          <a:xfrm>
+            <a:off x="4317797" y="3026664"/>
+            <a:ext cx="194767" cy="274320"/>
+          </a:xfrm>
+          <a:prstGeom prst="roundRect">
+            <a:avLst>
+              <a:gd name="adj" fmla="val 23474"/>
+            </a:avLst>
+          </a:prstGeom>
+          <a:solidFill>
+            <a:srgbClr val="9A9EA6"/>
+          </a:solidFill>
+          <a:ln/>
+        </p:spPr>
+      </p:sp>
+      <p:sp>
+        <p:nvSpPr>
+          <p:cNvPr id="110" name="Shape 108"/>
+          <p:cNvSpPr/>
+          <p:nvPr/>
+        </p:nvSpPr>
+        <p:spPr>
+          <a:xfrm>
+            <a:off x="4345229" y="3251606"/>
+            <a:ext cx="139903" cy="49378"/>
+          </a:xfrm>
+          <a:prstGeom prst="rect">
+            <a:avLst/>
+          </a:prstGeom>
+          <a:solidFill>
+            <a:srgbClr val="7D818A"/>
+          </a:solidFill>
+          <a:ln/>
+        </p:spPr>
+      </p:sp>
+      <p:sp>
+        <p:nvSpPr>
+          <p:cNvPr id="111" name="Shape 109"/>
+          <p:cNvSpPr/>
+          <p:nvPr/>
+        </p:nvSpPr>
+        <p:spPr>
+          <a:xfrm>
+            <a:off x="4649788" y="2975458"/>
+            <a:ext cx="30047" cy="60350"/>
+          </a:xfrm>
+          <a:prstGeom prst="roundRect">
+            <a:avLst>
+              <a:gd name="adj" fmla="val 91297"/>
+            </a:avLst>
+          </a:prstGeom>
+          <a:solidFill>
+            <a:srgbClr val="9A9EA6"/>
+          </a:solidFill>
+          <a:ln/>
+        </p:spPr>
+      </p:sp>
+      <p:sp>
+        <p:nvSpPr>
+          <p:cNvPr id="112" name="Shape 110"/>
+          <p:cNvSpPr/>
+          <p:nvPr/>
+        </p:nvSpPr>
+        <p:spPr>
+          <a:xfrm>
+            <a:off x="4567428" y="3026664"/>
+            <a:ext cx="194767" cy="274320"/>
+          </a:xfrm>
+          <a:prstGeom prst="roundRect">
+            <a:avLst>
+              <a:gd name="adj" fmla="val 23474"/>
+            </a:avLst>
+          </a:prstGeom>
+          <a:solidFill>
+            <a:srgbClr val="9A9EA6"/>
+          </a:solidFill>
+          <a:ln/>
+        </p:spPr>
+      </p:sp>
+      <p:sp>
+        <p:nvSpPr>
+          <p:cNvPr id="113" name="Shape 111"/>
+          <p:cNvSpPr/>
+          <p:nvPr/>
+        </p:nvSpPr>
+        <p:spPr>
+          <a:xfrm>
+            <a:off x="4594860" y="3251606"/>
+            <a:ext cx="139903" cy="49378"/>
+          </a:xfrm>
+          <a:prstGeom prst="rect">
+            <a:avLst/>
+          </a:prstGeom>
+          <a:solidFill>
+            <a:srgbClr val="7D818A"/>
+          </a:solidFill>
+          <a:ln/>
+        </p:spPr>
+      </p:sp>
+      <p:sp>
+        <p:nvSpPr>
+          <p:cNvPr id="114" name="Shape 112"/>
+          <p:cNvSpPr/>
+          <p:nvPr/>
+        </p:nvSpPr>
+        <p:spPr>
+          <a:xfrm>
+            <a:off x="4899419" y="2975458"/>
+            <a:ext cx="30047" cy="60350"/>
+          </a:xfrm>
+          <a:prstGeom prst="roundRect">
+            <a:avLst>
+              <a:gd name="adj" fmla="val 91297"/>
+            </a:avLst>
+          </a:prstGeom>
+          <a:solidFill>
+            <a:srgbClr val="9A9EA6"/>
+          </a:solidFill>
+          <a:ln/>
+        </p:spPr>
+      </p:sp>
+      <p:sp>
+        <p:nvSpPr>
+          <p:cNvPr id="115" name="Shape 113"/>
+          <p:cNvSpPr/>
+          <p:nvPr/>
+        </p:nvSpPr>
+        <p:spPr>
+          <a:xfrm>
+            <a:off x="4817059" y="3026664"/>
+            <a:ext cx="194767" cy="274320"/>
+          </a:xfrm>
+          <a:prstGeom prst="roundRect">
+            <a:avLst>
+              <a:gd name="adj" fmla="val 23474"/>
+            </a:avLst>
+          </a:prstGeom>
+          <a:solidFill>
+            <a:srgbClr val="9A9EA6"/>
+          </a:solidFill>
+          <a:ln/>
+        </p:spPr>
+      </p:sp>
+      <p:sp>
+        <p:nvSpPr>
+          <p:cNvPr id="116" name="Shape 114"/>
+          <p:cNvSpPr/>
+          <p:nvPr/>
+        </p:nvSpPr>
+        <p:spPr>
+          <a:xfrm>
+            <a:off x="4844491" y="3251606"/>
+            <a:ext cx="139903" cy="49378"/>
+          </a:xfrm>
+          <a:prstGeom prst="rect">
+            <a:avLst/>
+          </a:prstGeom>
+          <a:solidFill>
+            <a:srgbClr val="7D818A"/>
+          </a:solidFill>
+          <a:ln/>
+        </p:spPr>
+      </p:sp>
+      <p:sp>
+        <p:nvSpPr>
+          <p:cNvPr id="117" name="Shape 115"/>
+          <p:cNvSpPr/>
+          <p:nvPr/>
+        </p:nvSpPr>
+        <p:spPr>
+          <a:xfrm>
+            <a:off x="5149050" y="2975458"/>
+            <a:ext cx="30047" cy="60350"/>
+          </a:xfrm>
+          <a:prstGeom prst="roundRect">
+            <a:avLst>
+              <a:gd name="adj" fmla="val 91297"/>
+            </a:avLst>
+          </a:prstGeom>
+          <a:solidFill>
+            <a:srgbClr val="9A9EA6"/>
+          </a:solidFill>
+          <a:ln/>
+        </p:spPr>
+      </p:sp>
+      <p:sp>
+        <p:nvSpPr>
+          <p:cNvPr id="118" name="Shape 116"/>
+          <p:cNvSpPr/>
+          <p:nvPr/>
+        </p:nvSpPr>
+        <p:spPr>
+          <a:xfrm>
+            <a:off x="5066690" y="3026664"/>
+            <a:ext cx="194767" cy="274320"/>
+          </a:xfrm>
+          <a:prstGeom prst="roundRect">
+            <a:avLst>
+              <a:gd name="adj" fmla="val 23474"/>
+            </a:avLst>
+          </a:prstGeom>
+          <a:solidFill>
+            <a:srgbClr val="9A9EA6"/>
+          </a:solidFill>
+          <a:ln/>
+        </p:spPr>
+      </p:sp>
+      <p:sp>
+        <p:nvSpPr>
+          <p:cNvPr id="119" name="Shape 117"/>
+          <p:cNvSpPr/>
+          <p:nvPr/>
+        </p:nvSpPr>
+        <p:spPr>
+          <a:xfrm>
+            <a:off x="5094122" y="3251606"/>
+            <a:ext cx="139903" cy="49378"/>
+          </a:xfrm>
+          <a:prstGeom prst="rect">
+            <a:avLst/>
+          </a:prstGeom>
+          <a:solidFill>
+            <a:srgbClr val="7D818A"/>
+          </a:solidFill>
+          <a:ln/>
+        </p:spPr>
+      </p:sp>
+      <p:sp>
+        <p:nvSpPr>
+          <p:cNvPr id="120" name="Shape 118"/>
+          <p:cNvSpPr/>
+          <p:nvPr/>
+        </p:nvSpPr>
+        <p:spPr>
+          <a:xfrm>
+            <a:off x="5398682" y="2975458"/>
+            <a:ext cx="30047" cy="60350"/>
+          </a:xfrm>
+          <a:prstGeom prst="roundRect">
+            <a:avLst>
+              <a:gd name="adj" fmla="val 91297"/>
+            </a:avLst>
+          </a:prstGeom>
+          <a:solidFill>
+            <a:srgbClr val="9A9EA6"/>
+          </a:solidFill>
+          <a:ln/>
+        </p:spPr>
+      </p:sp>
+      <p:sp>
+        <p:nvSpPr>
+          <p:cNvPr id="121" name="Shape 119"/>
+          <p:cNvSpPr/>
+          <p:nvPr/>
+        </p:nvSpPr>
+        <p:spPr>
+          <a:xfrm>
+            <a:off x="5316322" y="3026664"/>
+            <a:ext cx="194767" cy="274320"/>
+          </a:xfrm>
+          <a:prstGeom prst="roundRect">
+            <a:avLst>
+              <a:gd name="adj" fmla="val 23474"/>
+            </a:avLst>
+          </a:prstGeom>
+          <a:solidFill>
+            <a:srgbClr val="9A9EA6"/>
+          </a:solidFill>
+          <a:ln/>
+        </p:spPr>
+      </p:sp>
+      <p:sp>
+        <p:nvSpPr>
+          <p:cNvPr id="122" name="Shape 120"/>
+          <p:cNvSpPr/>
+          <p:nvPr/>
+        </p:nvSpPr>
+        <p:spPr>
+          <a:xfrm>
+            <a:off x="5343754" y="3251606"/>
+            <a:ext cx="139903" cy="49378"/>
+          </a:xfrm>
+          <a:prstGeom prst="rect">
+            <a:avLst/>
+          </a:prstGeom>
+          <a:solidFill>
+            <a:srgbClr val="7D818A"/>
+          </a:solidFill>
+          <a:ln/>
+        </p:spPr>
+      </p:sp>
+      <p:sp>
+        <p:nvSpPr>
+          <p:cNvPr id="123" name="Shape 121"/>
+          <p:cNvSpPr/>
+          <p:nvPr/>
+        </p:nvSpPr>
+        <p:spPr>
+          <a:xfrm>
+            <a:off x="5648313" y="2975458"/>
+            <a:ext cx="30047" cy="60350"/>
+          </a:xfrm>
+          <a:prstGeom prst="roundRect">
+            <a:avLst>
+              <a:gd name="adj" fmla="val 91297"/>
+            </a:avLst>
+          </a:prstGeom>
+          <a:solidFill>
+            <a:srgbClr val="9A9EA6"/>
+          </a:solidFill>
+          <a:ln/>
+        </p:spPr>
+      </p:sp>
+      <p:sp>
+        <p:nvSpPr>
+          <p:cNvPr id="124" name="Shape 122"/>
+          <p:cNvSpPr/>
+          <p:nvPr/>
+        </p:nvSpPr>
+        <p:spPr>
+          <a:xfrm>
+            <a:off x="5565953" y="3026664"/>
+            <a:ext cx="194767" cy="274320"/>
+          </a:xfrm>
+          <a:prstGeom prst="roundRect">
+            <a:avLst>
+              <a:gd name="adj" fmla="val 23474"/>
+            </a:avLst>
+          </a:prstGeom>
+          <a:solidFill>
+            <a:srgbClr val="9A9EA6"/>
+          </a:solidFill>
+          <a:ln/>
+        </p:spPr>
+      </p:sp>
+      <p:sp>
+        <p:nvSpPr>
+          <p:cNvPr id="125" name="Shape 123"/>
+          <p:cNvSpPr/>
+          <p:nvPr/>
+        </p:nvSpPr>
+        <p:spPr>
+          <a:xfrm>
+            <a:off x="5593385" y="3251606"/>
+            <a:ext cx="139903" cy="49378"/>
+          </a:xfrm>
+          <a:prstGeom prst="rect">
+            <a:avLst/>
+          </a:prstGeom>
+          <a:solidFill>
+            <a:srgbClr val="7D818A"/>
+          </a:solidFill>
+          <a:ln/>
+        </p:spPr>
+      </p:sp>
+      <p:sp>
+        <p:nvSpPr>
+          <p:cNvPr id="126" name="Shape 124"/>
+          <p:cNvSpPr/>
+          <p:nvPr/>
+        </p:nvSpPr>
+        <p:spPr>
+          <a:xfrm>
+            <a:off x="822960" y="3648456"/>
+            <a:ext cx="237744" cy="237744"/>
+          </a:xfrm>
+          <a:prstGeom prst="roundRect">
+            <a:avLst>
+              <a:gd name="adj" fmla="val 15385"/>
+            </a:avLst>
+          </a:prstGeom>
+          <a:solidFill>
+            <a:srgbClr val="9B2A21"/>
+          </a:solidFill>
+          <a:ln/>
+        </p:spPr>
+      </p:sp>
+      <p:sp>
+        <p:nvSpPr>
+          <p:cNvPr id="127" name="Text 125"/>
+          <p:cNvSpPr txBox="1"/>
+          <p:nvPr/>
+        </p:nvSpPr>
+        <p:spPr>
+          <a:xfrm>
+            <a:off x="1188720" y="3611880"/>
+            <a:ext cx="4572000" cy="310896"/>
+          </a:xfrm>
+          <a:prstGeom prst="rect">
+            <a:avLst/>
+          </a:prstGeom>
+          <a:noFill/>
+          <a:ln/>
+        </p:spPr>
+        <p:txBody>
+          <a:bodyPr wrap="square" lIns="0" tIns="0" rIns="0" bIns="0" rtlCol="0" anchor="ctr"/>
+          <a:lstStyle/>
+          <a:p>
+            <a:pPr indent="0" marL="0">
+              <a:buNone/>
+            </a:pPr>
+            <a:r>
+              <a:rPr lang="en-US" sz="1300" b="1" dirty="0">
+                <a:solidFill>
+                  <a:schemeClr val="tx1"/>
+                </a:solidFill>
+              </a:rPr>
+              <a:t>6 en mora irrecuperable</a:t>
+            </a:r>
+            <a:pPr indent="0" marL="0">
+              <a:buNone/>
+            </a:pPr>
+            <a:r>
+              <a:rPr lang="en-US" sz="1300" dirty="0">
+                <a:solidFill>
+                  <a:schemeClr val="tx2"/>
+                </a:solidFill>
+              </a:rPr>
+              <a:t>  ·  situación 5</a:t>
+            </a:r>
+            <a:endParaRPr lang="en-US" sz="1300" dirty="0"/>
+          </a:p>
+        </p:txBody>
+      </p:sp>
+      <p:sp>
+        <p:nvSpPr>
+          <p:cNvPr id="128" name="Shape 126"/>
+          <p:cNvSpPr/>
+          <p:nvPr/>
+        </p:nvSpPr>
+        <p:spPr>
+          <a:xfrm>
+            <a:off x="822960" y="4105656"/>
+            <a:ext cx="237744" cy="237744"/>
+          </a:xfrm>
+          <a:prstGeom prst="roundRect">
+            <a:avLst>
+              <a:gd name="adj" fmla="val 15385"/>
+            </a:avLst>
+          </a:prstGeom>
+          <a:solidFill>
+            <a:schemeClr val="accent1"/>
+          </a:solidFill>
+          <a:ln/>
+        </p:spPr>
+      </p:sp>
+      <p:sp>
+        <p:nvSpPr>
+          <p:cNvPr id="129" name="Text 127"/>
+          <p:cNvSpPr txBox="1"/>
+          <p:nvPr/>
+        </p:nvSpPr>
+        <p:spPr>
+          <a:xfrm>
+            <a:off x="1188720" y="4069080"/>
+            <a:ext cx="4572000" cy="310896"/>
+          </a:xfrm>
+          <a:prstGeom prst="rect">
+            <a:avLst/>
+          </a:prstGeom>
+          <a:noFill/>
+          <a:ln/>
+        </p:spPr>
+        <p:txBody>
+          <a:bodyPr wrap="square" lIns="0" tIns="0" rIns="0" bIns="0" rtlCol="0" anchor="ctr"/>
+          <a:lstStyle/>
+          <a:p>
+            <a:pPr indent="0" marL="0">
+              <a:buNone/>
+            </a:pPr>
+            <a:r>
+              <a:rPr lang="en-US" sz="1300" b="1" dirty="0">
+                <a:solidFill>
+                  <a:schemeClr val="tx1"/>
+                </a:solidFill>
+              </a:rPr>
+              <a:t>4 en mora con chance de cobro</a:t>
+            </a:r>
+            <a:pPr indent="0" marL="0">
+              <a:buNone/>
+            </a:pPr>
+            <a:r>
+              <a:rPr lang="en-US" sz="1300" dirty="0">
+                <a:solidFill>
+                  <a:schemeClr val="tx2"/>
+                </a:solidFill>
+              </a:rPr>
+              <a:t>  ·  situaciones 3 y 4</a:t>
+            </a:r>
+            <a:endParaRPr lang="en-US" sz="1300" dirty="0"/>
+          </a:p>
+        </p:txBody>
+      </p:sp>
+      <p:sp>
+        <p:nvSpPr>
+          <p:cNvPr id="130" name="Shape 128"/>
+          <p:cNvSpPr/>
+          <p:nvPr/>
+        </p:nvSpPr>
+        <p:spPr>
+          <a:xfrm>
+            <a:off x="822960" y="4562856"/>
+            <a:ext cx="237744" cy="237744"/>
+          </a:xfrm>
+          <a:prstGeom prst="roundRect">
+            <a:avLst>
+              <a:gd name="adj" fmla="val 15385"/>
+            </a:avLst>
+          </a:prstGeom>
+          <a:solidFill>
+            <a:schemeClr val="accent4"/>
+          </a:solidFill>
+          <a:ln/>
+        </p:spPr>
+      </p:sp>
+      <p:sp>
+        <p:nvSpPr>
+          <p:cNvPr id="131" name="Text 129"/>
+          <p:cNvSpPr txBox="1"/>
+          <p:nvPr/>
+        </p:nvSpPr>
+        <p:spPr>
+          <a:xfrm>
+            <a:off x="1188720" y="4526280"/>
+            <a:ext cx="4572000" cy="310896"/>
+          </a:xfrm>
+          <a:prstGeom prst="rect">
+            <a:avLst/>
+          </a:prstGeom>
+          <a:noFill/>
+          <a:ln/>
+        </p:spPr>
+        <p:txBody>
+          <a:bodyPr wrap="square" lIns="0" tIns="0" rIns="0" bIns="0" rtlCol="0" anchor="ctr"/>
+          <a:lstStyle/>
+          <a:p>
+            <a:pPr indent="0" marL="0">
+              <a:buNone/>
+            </a:pPr>
+            <a:r>
+              <a:rPr lang="en-US" sz="1300" b="1" dirty="0">
+                <a:solidFill>
+                  <a:schemeClr val="tx1"/>
+                </a:solidFill>
+              </a:rPr>
+              <a:t>30 al día</a:t>
+            </a:r>
+            <a:pPr indent="0" marL="0">
+              <a:buNone/>
+            </a:pPr>
+            <a:endParaRPr lang="en-US" sz="1300" dirty="0"/>
+          </a:p>
+        </p:txBody>
+      </p:sp>
+      <p:sp>
+        <p:nvSpPr>
+          <p:cNvPr id="132" name="Dato Santa Fe 1"/>
+          <p:cNvSpPr/>
+          <p:nvPr/>
+        </p:nvSpPr>
+        <p:spPr>
+          <a:xfrm>
+            <a:off x="6309360" y="1783080"/>
+            <a:ext cx="2575408" cy="1600200"/>
+          </a:xfrm>
+          <a:prstGeom prst="roundRect">
+            <a:avLst>
+              <a:gd name="adj" fmla="val 9143"/>
+            </a:avLst>
+          </a:prstGeom>
+          <a:solidFill>
+            <a:schemeClr val="bg1"/>
+          </a:solidFill>
+          <a:ln w="12700">
+            <a:solidFill>
+              <a:schemeClr val="accent6"/>
+            </a:solidFill>
+            <a:prstDash val="solid"/>
+          </a:ln>
+        </p:spPr>
+      </p:sp>
+      <p:sp>
+        <p:nvSpPr>
+          <p:cNvPr id="133" name="Text 131"/>
+          <p:cNvSpPr txBox="1"/>
+          <p:nvPr/>
+        </p:nvSpPr>
+        <p:spPr>
+          <a:xfrm>
+            <a:off x="6537960" y="1965960"/>
+            <a:ext cx="2118208" cy="548640"/>
+          </a:xfrm>
+          <a:prstGeom prst="rect">
+            <a:avLst/>
+          </a:prstGeom>
+          <a:noFill/>
+          <a:ln/>
+        </p:spPr>
+        <p:txBody>
+          <a:bodyPr wrap="square" lIns="0" tIns="0" rIns="0" bIns="0" rtlCol="0" anchor="ctr">
+            <a:normAutofit/>
+          </a:bodyPr>
+          <a:lstStyle/>
+          <a:p>
+            <a:pPr indent="0" marL="0">
+              <a:buNone/>
+            </a:pPr>
+            <a:r>
+              <a:rPr lang="en-US" sz="2600" b="1" dirty="0">
+                <a:solidFill>
+                  <a:schemeClr val="tx1"/>
+                </a:solidFill>
+              </a:rPr>
+              <a:t>412.845</a:t>
+            </a:r>
+            <a:endParaRPr lang="en-US" sz="2600" dirty="0"/>
+          </a:p>
+        </p:txBody>
+      </p:sp>
+      <p:sp>
+        <p:nvSpPr>
+          <p:cNvPr id="134" name="Text 132"/>
+          <p:cNvSpPr txBox="1"/>
+          <p:nvPr/>
+        </p:nvSpPr>
+        <p:spPr>
+          <a:xfrm>
+            <a:off x="6537960" y="2560320"/>
+            <a:ext cx="2118208" cy="731520"/>
+          </a:xfrm>
+          <a:prstGeom prst="rect">
+            <a:avLst/>
+          </a:prstGeom>
+          <a:noFill/>
+          <a:ln/>
+        </p:spPr>
+        <p:txBody>
+          <a:bodyPr wrap="square" lIns="0" tIns="0" rIns="0" bIns="0" rtlCol="0" anchor="t"/>
+          <a:lstStyle/>
+          <a:p>
+            <a:pPr indent="0" marL="0">
+              <a:buNone/>
+            </a:pPr>
+            <a:r>
+              <a:rPr lang="en-US" sz="1300" dirty="0">
+                <a:solidFill>
+                  <a:schemeClr val="tx2"/>
+                </a:solidFill>
+              </a:rPr>
+              <a:t>personas en mora. Tercera provincia en cantidad, detrás de Buenos Aires y Córdoba.</a:t>
+            </a:r>
+            <a:endParaRPr lang="en-US" sz="1300" dirty="0"/>
+          </a:p>
+        </p:txBody>
+      </p:sp>
+      <p:sp>
+        <p:nvSpPr>
+          <p:cNvPr id="135" name="Dato Santa Fe 2"/>
+          <p:cNvSpPr/>
+          <p:nvPr/>
+        </p:nvSpPr>
+        <p:spPr>
+          <a:xfrm>
+            <a:off x="9067648" y="1783080"/>
+            <a:ext cx="2575408" cy="1600200"/>
+          </a:xfrm>
+          <a:prstGeom prst="roundRect">
+            <a:avLst>
+              <a:gd name="adj" fmla="val 9143"/>
+            </a:avLst>
+          </a:prstGeom>
+          <a:solidFill>
+            <a:schemeClr val="bg1"/>
+          </a:solidFill>
+          <a:ln w="12700">
+            <a:solidFill>
+              <a:schemeClr val="accent6"/>
+            </a:solidFill>
+            <a:prstDash val="solid"/>
+          </a:ln>
+        </p:spPr>
+      </p:sp>
+      <p:sp>
+        <p:nvSpPr>
+          <p:cNvPr id="136" name="Text 134"/>
+          <p:cNvSpPr txBox="1"/>
+          <p:nvPr/>
+        </p:nvSpPr>
+        <p:spPr>
+          <a:xfrm>
+            <a:off x="9296248" y="1965960"/>
+            <a:ext cx="2118208" cy="548640"/>
+          </a:xfrm>
+          <a:prstGeom prst="rect">
+            <a:avLst/>
+          </a:prstGeom>
+          <a:noFill/>
+          <a:ln/>
+        </p:spPr>
+        <p:txBody>
+          <a:bodyPr wrap="square" lIns="0" tIns="0" rIns="0" bIns="0" rtlCol="0" anchor="ctr">
+            <a:normAutofit/>
+          </a:bodyPr>
+          <a:lstStyle/>
+          <a:p>
+            <a:pPr indent="0" marL="0">
+              <a:buNone/>
+            </a:pPr>
+            <a:r>
+              <a:rPr lang="en-US" sz="2600" b="1" dirty="0">
+                <a:solidFill>
+                  <a:schemeClr val="tx1"/>
+                </a:solidFill>
+              </a:rPr>
+              <a:t>13%</a:t>
+            </a:r>
+            <a:endParaRPr lang="en-US" sz="2600" dirty="0"/>
+          </a:p>
+        </p:txBody>
+      </p:sp>
+      <p:sp>
+        <p:nvSpPr>
+          <p:cNvPr id="137" name="Text 135"/>
+          <p:cNvSpPr txBox="1"/>
+          <p:nvPr/>
+        </p:nvSpPr>
+        <p:spPr>
+          <a:xfrm>
+            <a:off x="9296248" y="2560320"/>
+            <a:ext cx="2118208" cy="731520"/>
+          </a:xfrm>
+          <a:prstGeom prst="rect">
+            <a:avLst/>
+          </a:prstGeom>
+          <a:noFill/>
+          <a:ln/>
+        </p:spPr>
+        <p:txBody>
+          <a:bodyPr wrap="square" lIns="0" tIns="0" rIns="0" bIns="0" rtlCol="0" anchor="t"/>
+          <a:lstStyle/>
+          <a:p>
+            <a:pPr indent="0" marL="0">
+              <a:buNone/>
+            </a:pPr>
+            <a:r>
+              <a:rPr lang="en-US" sz="1300" dirty="0">
+                <a:solidFill>
+                  <a:schemeClr val="tx2"/>
+                </a:solidFill>
+              </a:rPr>
+              <a:t>de la plata prestada está en mora: apenas debajo del 13,9% nacional.</a:t>
+            </a:r>
+            <a:endParaRPr lang="en-US" sz="1300" dirty="0"/>
+          </a:p>
+        </p:txBody>
+      </p:sp>
+      <p:sp>
+        <p:nvSpPr>
+          <p:cNvPr id="138" name="Dato Santa Fe 3"/>
+          <p:cNvSpPr/>
+          <p:nvPr/>
+        </p:nvSpPr>
+        <p:spPr>
+          <a:xfrm>
+            <a:off x="6309360" y="3566160"/>
+            <a:ext cx="2575408" cy="1600200"/>
+          </a:xfrm>
+          <a:prstGeom prst="roundRect">
+            <a:avLst>
+              <a:gd name="adj" fmla="val 9143"/>
+            </a:avLst>
+          </a:prstGeom>
+          <a:solidFill>
+            <a:schemeClr val="bg1"/>
+          </a:solidFill>
+          <a:ln w="12700">
+            <a:solidFill>
+              <a:schemeClr val="accent6"/>
+            </a:solidFill>
+            <a:prstDash val="solid"/>
+          </a:ln>
+        </p:spPr>
+      </p:sp>
+      <p:sp>
+        <p:nvSpPr>
+          <p:cNvPr id="139" name="Text 137"/>
+          <p:cNvSpPr txBox="1"/>
+          <p:nvPr/>
+        </p:nvSpPr>
+        <p:spPr>
+          <a:xfrm>
+            <a:off x="6537960" y="3749040"/>
+            <a:ext cx="2118208" cy="548640"/>
+          </a:xfrm>
+          <a:prstGeom prst="rect">
+            <a:avLst/>
+          </a:prstGeom>
+          <a:noFill/>
+          <a:ln/>
+        </p:spPr>
+        <p:txBody>
+          <a:bodyPr wrap="square" lIns="0" tIns="0" rIns="0" bIns="0" rtlCol="0" anchor="ctr">
+            <a:normAutofit/>
+          </a:bodyPr>
+          <a:lstStyle/>
+          <a:p>
+            <a:pPr indent="0" marL="0">
+              <a:buNone/>
+            </a:pPr>
+            <a:r>
+              <a:rPr lang="en-US" sz="2600" b="1" dirty="0">
+                <a:solidFill>
+                  <a:schemeClr val="tx1"/>
+                </a:solidFill>
+              </a:rPr>
+              <a:t>31% vs. 10%</a:t>
+            </a:r>
+            <a:endParaRPr lang="en-US" sz="2600" dirty="0"/>
+          </a:p>
+        </p:txBody>
+      </p:sp>
+      <p:sp>
+        <p:nvSpPr>
+          <p:cNvPr id="140" name="Text 138"/>
+          <p:cNvSpPr txBox="1"/>
+          <p:nvPr/>
+        </p:nvSpPr>
+        <p:spPr>
+          <a:xfrm>
+            <a:off x="6537960" y="4343400"/>
+            <a:ext cx="2118208" cy="731520"/>
+          </a:xfrm>
+          <a:prstGeom prst="rect">
+            <a:avLst/>
+          </a:prstGeom>
+          <a:noFill/>
+          <a:ln/>
+        </p:spPr>
+        <p:txBody>
+          <a:bodyPr wrap="square" lIns="0" tIns="0" rIns="0" bIns="0" rtlCol="0" anchor="t"/>
+          <a:lstStyle/>
+          <a:p>
+            <a:pPr indent="0" marL="0">
+              <a:buNone/>
+            </a:pPr>
+            <a:r>
+              <a:rPr lang="en-US" sz="1300" dirty="0">
+                <a:solidFill>
+                  <a:schemeClr val="tx2"/>
+                </a:solidFill>
+              </a:rPr>
+              <a:t>mora en billeteras virtuales contra mora en bancos, en la provincia.</a:t>
+            </a:r>
+            <a:endParaRPr lang="en-US" sz="1300" dirty="0"/>
+          </a:p>
+        </p:txBody>
+      </p:sp>
+      <p:sp>
+        <p:nvSpPr>
+          <p:cNvPr id="141" name="Dato Santa Fe 4"/>
+          <p:cNvSpPr/>
+          <p:nvPr/>
+        </p:nvSpPr>
+        <p:spPr>
+          <a:xfrm>
+            <a:off x="9067648" y="3566160"/>
+            <a:ext cx="2575408" cy="1600200"/>
+          </a:xfrm>
+          <a:prstGeom prst="roundRect">
+            <a:avLst>
+              <a:gd name="adj" fmla="val 9143"/>
+            </a:avLst>
+          </a:prstGeom>
+          <a:solidFill>
+            <a:schemeClr val="bg1"/>
+          </a:solidFill>
+          <a:ln w="12700">
+            <a:solidFill>
+              <a:schemeClr val="accent6"/>
+            </a:solidFill>
+            <a:prstDash val="solid"/>
+          </a:ln>
+        </p:spPr>
+      </p:sp>
+      <p:sp>
+        <p:nvSpPr>
+          <p:cNvPr id="142" name="Text 140"/>
+          <p:cNvSpPr txBox="1"/>
+          <p:nvPr/>
+        </p:nvSpPr>
+        <p:spPr>
+          <a:xfrm>
+            <a:off x="9296248" y="3749040"/>
+            <a:ext cx="2118208" cy="548640"/>
+          </a:xfrm>
+          <a:prstGeom prst="rect">
+            <a:avLst/>
+          </a:prstGeom>
+          <a:noFill/>
+          <a:ln/>
+        </p:spPr>
+        <p:txBody>
+          <a:bodyPr wrap="square" lIns="0" tIns="0" rIns="0" bIns="0" rtlCol="0" anchor="ctr">
+            <a:normAutofit/>
+          </a:bodyPr>
+          <a:lstStyle/>
+          <a:p>
+            <a:pPr indent="0" marL="0">
+              <a:buNone/>
+            </a:pPr>
+            <a:r>
+              <a:rPr lang="en-US" sz="2600" b="1" dirty="0">
+                <a:solidFill>
+                  <a:schemeClr val="tx1"/>
+                </a:solidFill>
+              </a:rPr>
+              <a:t>$2,3 millones</a:t>
+            </a:r>
+            <a:endParaRPr lang="en-US" sz="2600" dirty="0"/>
+          </a:p>
+        </p:txBody>
+      </p:sp>
+      <p:sp>
+        <p:nvSpPr>
+          <p:cNvPr id="143" name="Text 141"/>
+          <p:cNvSpPr txBox="1"/>
+          <p:nvPr/>
+        </p:nvSpPr>
+        <p:spPr>
+          <a:xfrm>
+            <a:off x="9296248" y="4343400"/>
+            <a:ext cx="2118208" cy="731520"/>
+          </a:xfrm>
+          <a:prstGeom prst="rect">
+            <a:avLst/>
+          </a:prstGeom>
+          <a:noFill/>
+          <a:ln/>
+        </p:spPr>
+        <p:txBody>
+          <a:bodyPr wrap="square" lIns="0" tIns="0" rIns="0" bIns="0" rtlCol="0" anchor="t"/>
+          <a:lstStyle/>
+          <a:p>
+            <a:pPr indent="0" marL="0">
+              <a:buNone/>
+            </a:pPr>
+            <a:r>
+              <a:rPr lang="en-US" sz="1300" dirty="0">
+                <a:solidFill>
+                  <a:schemeClr val="tx2"/>
+                </a:solidFill>
+              </a:rPr>
+              <a:t>deuda promedio en mora; en el país, $2,6 millones.</a:t>
+            </a:r>
+            <a:endParaRPr lang="en-US" sz="1300" dirty="0"/>
+          </a:p>
+        </p:txBody>
+      </p:sp>
+      <p:sp>
+        <p:nvSpPr>
+          <p:cNvPr id="144" name="Ejemplo"/>
+          <p:cNvSpPr/>
+          <p:nvPr/>
+        </p:nvSpPr>
+        <p:spPr>
+          <a:xfrm>
+            <a:off x="548640" y="5321808"/>
+            <a:ext cx="11094415" cy="594360"/>
+          </a:xfrm>
+          <a:prstGeom prst="roundRect">
+            <a:avLst>
+              <a:gd name="adj" fmla="val 15385"/>
+            </a:avLst>
+          </a:prstGeom>
+          <a:solidFill>
+            <a:schemeClr val="bg1"/>
+          </a:solidFill>
+          <a:ln w="12700">
+            <a:solidFill>
+              <a:schemeClr val="accent6"/>
+            </a:solidFill>
+            <a:prstDash val="solid"/>
+          </a:ln>
+        </p:spPr>
+      </p:sp>
+      <p:sp>
+        <p:nvSpPr>
+          <p:cNvPr id="145" name="Text 143"/>
+          <p:cNvSpPr txBox="1"/>
+          <p:nvPr/>
+        </p:nvSpPr>
+        <p:spPr>
+          <a:xfrm>
+            <a:off x="731520" y="5431536"/>
+            <a:ext cx="10728655" cy="374904"/>
+          </a:xfrm>
+          <a:prstGeom prst="rect">
+            <a:avLst/>
+          </a:prstGeom>
+          <a:noFill/>
+          <a:ln/>
+        </p:spPr>
+        <p:txBody>
+          <a:bodyPr wrap="square" lIns="0" tIns="0" rIns="0" bIns="0" rtlCol="0" anchor="ctr"/>
+          <a:lstStyle/>
+          <a:p>
+            <a:pPr indent="0" marL="0">
+              <a:buNone/>
+            </a:pPr>
+            <a:r>
+              <a:rPr lang="en-US" sz="1500" b="1" dirty="0">
+                <a:solidFill>
+                  <a:schemeClr val="tx1"/>
+                </a:solidFill>
+              </a:rPr>
+              <a:t>Baja en proporción, grande en cantidad: </a:t>
+            </a:r>
+            <a:pPr indent="0" marL="0">
+              <a:buNone/>
+            </a:pPr>
+            <a:r>
+              <a:rPr lang="en-US" sz="1500" dirty="0">
+                <a:solidFill>
+                  <a:schemeClr val="tx2"/>
+                </a:solidFill>
+              </a:rPr>
+              <a:t>22.ª de 24 jurisdicciones por tasa de mora, 3.ª por cantidad de personas.</a:t>
+            </a:r>
+            <a:endParaRPr lang="en-US" sz="1500" dirty="0"/>
+          </a:p>
+        </p:txBody>
+      </p:sp>
+      <p:sp>
+        <p:nvSpPr>
+          <p:cNvPr id="146" name="Fuente"/>
+          <p:cNvSpPr txBox="1"/>
+          <p:nvPr/>
+        </p:nvSpPr>
+        <p:spPr>
+          <a:xfrm>
+            <a:off x="548640" y="6053328"/>
+            <a:ext cx="11094415" cy="237744"/>
+          </a:xfrm>
+          <a:prstGeom prst="rect">
+            <a:avLst/>
+          </a:prstGeom>
+          <a:noFill/>
+          <a:ln/>
+        </p:spPr>
+        <p:txBody>
+          <a:bodyPr wrap="square" lIns="0" tIns="0" rIns="0" bIns="0" rtlCol="0" anchor="ctr"/>
+          <a:lstStyle/>
+          <a:p>
+            <a:pPr indent="0" marL="0">
+              <a:buNone/>
+            </a:pPr>
+            <a:r>
+              <a:rPr lang="en-US" sz="1000" dirty="0">
+                <a:solidFill>
+                  <a:schemeClr val="accent5"/>
+                </a:solidFill>
+              </a:rPr>
+              <a:t>Fuente: CEPA en base a la Central de Deudores del BCRA (julio de 2026). Mora: atrasos de más de 90 días por persona (CUIT). Ladrillos redondeados: 25% = 10/40 y 64% de los morosos ≈ 6/10.</a:t>
+            </a:r>
+            <a:endParaRPr lang="en-US" sz="1000" dirty="0"/>
+          </a:p>
+        </p:txBody>
+      </p:sp>
+      <p:sp>
+        <p:nvSpPr>
+          <p:cNvPr id="25" name="Slide Number Placeholder 0"/>
+          <p:cNvSpPr>
+            <a:spLocks noGrp="1"/>
+          </p:cNvSpPr>
+          <p:nvPr>
+            <p:ph type="sldNum" sz="quarter" idx="4294967295"/>
+          </p:nvPr>
+        </p:nvSpPr>
+        <p:spPr>
+          <a:xfrm>
+            <a:off x="11094415" y="6400800"/>
+            <a:ext cx="548640" cy="256032"/>
+          </a:xfrm>
+          <a:prstGeom prst="rect">
+            <a:avLst/>
+          </a:prstGeom>
+          <a:extLst>
+            <a:ext uri="{C572A759-6A51-4108-AA02-DFA0A04FC94B}">
+              <ma14:wrappingTextBoxFlag xmlns:ma14="http://schemas.microsoft.com/office/mac/drawingml/2011/main" val="0"/>
+            </a:ext>
+          </a:extLst>
+        </p:spPr>
+        <p:txBody>
+          <a:bodyPr lIns="0" tIns="0" rIns="0" bIns="0"/>
+          <a:lstStyle>
+            <a:lvl1pPr>
+              <a:defRPr sz="1000">
+                <a:solidFill>
+                  <a:schemeClr val="accent5"/>
+                </a:solidFill>
+              </a:defRPr>
+            </a:lvl1pPr>
+          </a:lstStyle>
+          <a:p>
+            <a:pPr algn="r"/>
+            <a:fld id="{F7021451-1387-4CA6-816F-3879F97B5CBC}" type="slidenum">
+              <a:rPr b="0" lang="en-US"/>
+              <a:t>11</a:t>
+            </a:fld>
+            <a:endParaRPr lang="en-US"/>
+          </a:p>
+        </p:txBody>
+      </p:sp>
+    </p:spTree>
+  </p:cSld>
+  <p:clrMapOvr>
+    <a:masterClrMapping/>
+  </p:clrMapOvr>
+</p:sld>
+</file>
+
+<file path=ppt/slides/slide12.xml><?xml version="1.0" encoding="utf-8"?>
+<p:sld xmlns:a="http://schemas.openxmlformats.org/drawingml/2006/main" xmlns:r="http://schemas.openxmlformats.org/officeDocument/2006/relationships" xmlns:p="http://schemas.openxmlformats.org/presentationml/2006/main">
+  <p:cSld name="Slide 12">
+    <p:spTree>
+      <p:nvGrpSpPr>
+        <p:cNvPr id="1" name=""/>
+        <p:cNvGrpSpPr/>
+        <p:nvPr/>
+      </p:nvGrpSpPr>
+      <p:grpSpPr>
+        <a:xfrm>
+          <a:off x="0" y="0"/>
+          <a:ext cx="0" cy="0"/>
+          <a:chOff x="0" y="0"/>
+          <a:chExt cx="0" cy="0"/>
+        </a:xfrm>
+      </p:grpSpPr>
+      <p:sp>
+        <p:nvSpPr>
+          <p:cNvPr id="2" name="Text 1"/>
+          <p:cNvSpPr/>
+          <p:nvPr>
+            <p:ph idx="101" type="body" hasCustomPrompt="1"/>
+          </p:nvPr>
+        </p:nvSpPr>
+        <p:spPr>
+          <a:xfrm>
+            <a:off x="548640" y="457200"/>
+            <a:ext cx="9144000" cy="274320"/>
+          </a:xfrm>
+          <a:prstGeom prst="rect">
+            <a:avLst/>
+          </a:prstGeom>
+          <a:noFill/>
+          <a:ln/>
+        </p:spPr>
+        <p:txBody>
+          <a:bodyPr wrap="square" lIns="0" tIns="0" rIns="0" bIns="0" rtlCol="0" anchor="ctr"/>
+          <a:lstStyle/>
+          <a:p>
+            <a:pPr algn="l" indent="0" marL="0">
+              <a:buNone/>
+            </a:pPr>
+            <a:r>
+              <a:rPr lang="en-US" sz="1200" b="1" spc="150" kern="0" dirty="0">
+                <a:solidFill>
+                  <a:schemeClr val="accent5"/>
+                </a:solidFill>
+              </a:rPr>
               <a:t>EJEMPLO REAL · SANTA FE</a:t>
             </a:r>
             <a:endParaRPr lang="en-US" sz="1200" dirty="0"/>
@@ -8365,7 +11937,7 @@
             <a:pPr algn="r"/>
             <a:fld id="{F7021451-1387-4CA6-816F-3879F97B5CBC}" type="slidenum">
               <a:rPr b="0" lang="en-US"/>
-              <a:t>11</a:t>
+              <a:t>12</a:t>
             </a:fld>
             <a:endParaRPr lang="en-US"/>
           </a:p>
@@ -8379,9 +11951,9 @@
 </p:sld>
 </file>
 
-<file path=ppt/slides/slide12.xml><?xml version="1.0" encoding="utf-8"?>
+<file path=ppt/slides/slide13.xml><?xml version="1.0" encoding="utf-8"?>
 <p:sld xmlns:a="http://schemas.openxmlformats.org/drawingml/2006/main" xmlns:r="http://schemas.openxmlformats.org/officeDocument/2006/relationships" xmlns:p="http://schemas.openxmlformats.org/presentationml/2006/main">
-  <p:cSld name="Slide 12">
+  <p:cSld name="Slide 13">
     <p:spTree>
       <p:nvGrpSpPr>
         <p:cNvPr id="1" name=""/>
@@ -8764,7 +12336,7 @@
                   <a:schemeClr val="accent5"/>
                 </a:solidFill>
               </a:rPr>
-              <a:t>BCRA (Informe sobre Bancos; BADLAR bancos privados; Central de Deudores, procesada por Mati Fernández), INDEC (Censo 2022), Equilibra, EcoGo-Universidad Austral, IPYPP, UCA, First Capital Group y Max Capital.</a:t>
+              <a:t>BCRA (Informe sobre Bancos; BADLAR bancos privados; Central de Deudores, procesada por Mati Fernández), INDEC (Censo 2022), CEPA, Equilibra, EcoGo-Universidad Austral, IPYPP, UCA, First Capital Group y Max Capital.</a:t>
             </a:r>
             <a:endParaRPr lang="en-US" sz="1200" dirty="0"/>
           </a:p>
@@ -8809,7 +12381,7 @@
             <a:pPr algn="r"/>
             <a:fld id="{F7021451-1387-4CA6-816F-3879F97B5CBC}" type="slidenum">
               <a:rPr b="0" lang="en-US"/>
-              <a:t>12</a:t>
+              <a:t>13</a:t>
             </a:fld>
             <a:endParaRPr lang="en-US"/>
           </a:p>

</xml_diff>

<commit_message>
Presentación pieza por pieza: mapa de mora con distribución por provincia
Co-Authored-By: Claude Opus 5.5 <noreply@anthropic.com>
Claude-Session: https://claude.ai/code/session_01LjZCUeZeukTqwmHG81QxgV
</commit_message>
<xml_diff>
--- a/presentaciones/crisis_fundar_ladrillos.pptx
+++ b/presentaciones/crisis_fundar_ladrillos.pptx
@@ -119,12 +119,12 @@
   <p:extLst>
     <p:ext uri="{521415D9-36F7-43E2-AB2F-B90AF26B5E84}">
       <p14:sectionLst xmlns:p14="http://schemas.microsoft.com/office/powerpoint/2010/main">
-        <p14:section name="Portada" id="{90510fab-2661-6b50-937a-fa8406b32688}">
+        <p14:section name="Portada" id="{0aefa645-b75c-454d-1229-6e01b3e72149}">
           <p14:sldIdLst>
             <p14:sldId id="256"/>
           </p14:sldIdLst>
         </p14:section>
-        <p14:section name="Resumen" id="{1f4374c3-3d6d-fcd7-82ca-eb003cf0afb4}">
+        <p14:section name="Resumen" id="{f44beaa1-39d2-a9d8-7fc2-c5ab296c06ab}">
           <p14:sldIdLst>
             <p14:sldId id="257"/>
             <p14:sldId id="258"/>
@@ -132,7 +132,7 @@
             <p14:sldId id="260"/>
           </p14:sldIdLst>
         </p14:section>
-        <p14:section name="Cómo se armó" id="{7358ca47-10fa-cd7d-86d1-19db1d991c20}">
+        <p14:section name="Cómo se armó" id="{7343b347-42d9-15a4-41e8-9cd1e54c0430}">
           <p14:sldIdLst>
             <p14:sldId id="261"/>
             <p14:sldId id="262"/>
@@ -140,7 +140,7 @@
             <p14:sldId id="264"/>
           </p14:sldIdLst>
         </p14:section>
-        <p14:section name="Qué hacer" id="{23691bf2-c2f9-29a0-8442-5e1c949fcd5f}">
+        <p14:section name="Qué hacer" id="{82f1e497-1847-ece5-b8a6-c6a5676b24d2}">
           <p14:sldIdLst>
             <p14:sldId id="265"/>
             <p14:sldId id="266"/>
@@ -17949,7 +17949,7 @@
       </p:sp>
       <p:pic>
         <p:nvPicPr>
-          <p:cNvPr id="4" name="Image 0" descr="Mapa de Argentina hecho de cuadraditos: 59 rojos (en mora), 158 grises (con deudas al día) y 245 claros (sin deudas registradas)">    </p:cNvPr>
+          <p:cNvPr id="4" name="Image 0" descr="Mapa de Argentina por provincias con 460 cuadraditos ubicados según la población de cada provincia: 59 rojos (en mora), 158 grises (con deudas al día) y 243 claros (sin deudas registradas). CABA aparece ampliada al costado.">    </p:cNvPr>
           <p:cNvPicPr>
             <a:picLocks noChangeAspect="1"/>
           </p:cNvPicPr>
@@ -17964,7 +17964,7 @@
         <p:spPr>
           <a:xfrm>
             <a:off x="777240" y="1600200"/>
-            <a:ext cx="2096913" cy="4343400"/>
+            <a:ext cx="2687320" cy="4206240"/>
           </a:xfrm>
           <a:prstGeom prst="rect">
             <a:avLst/>
@@ -17979,7 +17979,7 @@
         </p:nvSpPr>
         <p:spPr>
           <a:xfrm>
-            <a:off x="3331353" y="1737360"/>
+            <a:off x="3647440" y="1737360"/>
             <a:ext cx="237744" cy="237744"/>
           </a:xfrm>
           <a:prstGeom prst="roundRect">
@@ -18001,8 +18001,8 @@
         </p:nvSpPr>
         <p:spPr>
           <a:xfrm>
-            <a:off x="3678825" y="1664208"/>
-            <a:ext cx="2359087" cy="548640"/>
+            <a:off x="3994912" y="1664208"/>
+            <a:ext cx="2253725" cy="548640"/>
           </a:xfrm>
           <a:prstGeom prst="rect">
             <a:avLst/>
@@ -18051,7 +18051,7 @@
         </p:nvSpPr>
         <p:spPr>
           <a:xfrm>
-            <a:off x="6101920" y="1737360"/>
+            <a:off x="6312645" y="1737360"/>
             <a:ext cx="237744" cy="237744"/>
           </a:xfrm>
           <a:prstGeom prst="roundRect">
@@ -18073,8 +18073,8 @@
         </p:nvSpPr>
         <p:spPr>
           <a:xfrm>
-            <a:off x="6449392" y="1664208"/>
-            <a:ext cx="2359087" cy="548640"/>
+            <a:off x="6660117" y="1664208"/>
+            <a:ext cx="2253725" cy="548640"/>
           </a:xfrm>
           <a:prstGeom prst="rect">
             <a:avLst/>
@@ -18123,7 +18123,7 @@
         </p:nvSpPr>
         <p:spPr>
           <a:xfrm>
-            <a:off x="8872488" y="1737360"/>
+            <a:off x="8977850" y="1737360"/>
             <a:ext cx="237744" cy="237744"/>
           </a:xfrm>
           <a:prstGeom prst="roundRect">
@@ -18145,8 +18145,8 @@
         </p:nvSpPr>
         <p:spPr>
           <a:xfrm>
-            <a:off x="9219960" y="1664208"/>
-            <a:ext cx="2359087" cy="548640"/>
+            <a:off x="9325322" y="1664208"/>
+            <a:ext cx="2253725" cy="548640"/>
           </a:xfrm>
           <a:prstGeom prst="rect">
             <a:avLst/>
@@ -18195,8 +18195,8 @@
         </p:nvSpPr>
         <p:spPr>
           <a:xfrm>
-            <a:off x="3331353" y="2331720"/>
-            <a:ext cx="8311702" cy="274320"/>
+            <a:off x="3647440" y="2331720"/>
+            <a:ext cx="7995615" cy="274320"/>
           </a:xfrm>
           <a:prstGeom prst="rect">
             <a:avLst/>
@@ -18217,7 +18217,7 @@
                   <a:schemeClr val="accent5"/>
                 </a:solidFill>
               </a:rPr>
-              <a:t>Cada cuadradito ≈ 100.000 habitantes. Los rojos están repartidos al azar: la mora está en todo el país.</a:t>
+              <a:t>Cada cuadradito ≈ 100.000 habitantes, en su provincia y cerca de sus ciudades. CABA, ampliada.</a:t>
             </a:r>
             <a:endParaRPr lang="en-US" sz="1200" dirty="0"/>
           </a:p>
@@ -18231,8 +18231,8 @@
         </p:nvSpPr>
         <p:spPr>
           <a:xfrm>
-            <a:off x="3331353" y="2788920"/>
-            <a:ext cx="2587687" cy="2240280"/>
+            <a:off x="3647440" y="2788920"/>
+            <a:ext cx="2482325" cy="2240280"/>
           </a:xfrm>
           <a:prstGeom prst="roundRect">
             <a:avLst>
@@ -18258,8 +18258,8 @@
         </p:nvSpPr>
         <p:spPr>
           <a:xfrm>
-            <a:off x="3559953" y="2990088"/>
-            <a:ext cx="2130487" cy="274320"/>
+            <a:off x="3876040" y="2990088"/>
+            <a:ext cx="2025125" cy="274320"/>
           </a:xfrm>
           <a:prstGeom prst="rect">
             <a:avLst/>
@@ -18294,8 +18294,8 @@
         </p:nvSpPr>
         <p:spPr>
           <a:xfrm>
-            <a:off x="3559953" y="3291840"/>
-            <a:ext cx="2130487" cy="548640"/>
+            <a:off x="3876040" y="3291840"/>
+            <a:ext cx="2025125" cy="548640"/>
           </a:xfrm>
           <a:prstGeom prst="rect">
             <a:avLst/>
@@ -18332,8 +18332,8 @@
         </p:nvSpPr>
         <p:spPr>
           <a:xfrm>
-            <a:off x="3559953" y="3886200"/>
-            <a:ext cx="2130487" cy="1005840"/>
+            <a:off x="3876040" y="3886200"/>
+            <a:ext cx="2025125" cy="1005840"/>
           </a:xfrm>
           <a:prstGeom prst="rect">
             <a:avLst/>
@@ -18368,8 +18368,8 @@
         </p:nvSpPr>
         <p:spPr>
           <a:xfrm>
-            <a:off x="6193360" y="2788920"/>
-            <a:ext cx="2587687" cy="2240280"/>
+            <a:off x="6404085" y="2788920"/>
+            <a:ext cx="2482325" cy="2240280"/>
           </a:xfrm>
           <a:prstGeom prst="roundRect">
             <a:avLst>
@@ -18395,8 +18395,8 @@
         </p:nvSpPr>
         <p:spPr>
           <a:xfrm>
-            <a:off x="6421960" y="2990088"/>
-            <a:ext cx="2130487" cy="274320"/>
+            <a:off x="6632685" y="2990088"/>
+            <a:ext cx="2025125" cy="274320"/>
           </a:xfrm>
           <a:prstGeom prst="rect">
             <a:avLst/>
@@ -18431,8 +18431,8 @@
         </p:nvSpPr>
         <p:spPr>
           <a:xfrm>
-            <a:off x="6421960" y="3291840"/>
-            <a:ext cx="2130487" cy="548640"/>
+            <a:off x="6632685" y="3291840"/>
+            <a:ext cx="2025125" cy="548640"/>
           </a:xfrm>
           <a:prstGeom prst="rect">
             <a:avLst/>
@@ -18455,7 +18455,7 @@
                   <a:schemeClr val="tx1"/>
                 </a:solidFill>
               </a:rPr>
-              <a:t>$17,8 billones</a:t>
+              <a:t>$17,8</a:t>
             </a:r>
             <a:endParaRPr lang="en-US" sz="2600" dirty="0"/>
           </a:p>
@@ -18469,8 +18469,8 @@
         </p:nvSpPr>
         <p:spPr>
           <a:xfrm>
-            <a:off x="6421960" y="3886200"/>
-            <a:ext cx="2130487" cy="1005840"/>
+            <a:off x="6632685" y="3886200"/>
+            <a:ext cx="2025125" cy="1005840"/>
           </a:xfrm>
           <a:prstGeom prst="rect">
             <a:avLst/>
@@ -18491,7 +18491,7 @@
                   <a:schemeClr val="tx2"/>
                 </a:solidFill>
               </a:rPr>
-              <a:t>están en mora: el 15,5% de todo lo que deben las personas.</a:t>
+              <a:t>billones están en mora: el 15,5% de todo lo que deben las personas.</a:t>
             </a:r>
             <a:endParaRPr lang="en-US" sz="1300" dirty="0"/>
           </a:p>
@@ -18505,8 +18505,8 @@
         </p:nvSpPr>
         <p:spPr>
           <a:xfrm>
-            <a:off x="9055368" y="2788920"/>
-            <a:ext cx="2587687" cy="2240280"/>
+            <a:off x="9160730" y="2788920"/>
+            <a:ext cx="2482325" cy="2240280"/>
           </a:xfrm>
           <a:prstGeom prst="roundRect">
             <a:avLst>
@@ -18532,8 +18532,8 @@
         </p:nvSpPr>
         <p:spPr>
           <a:xfrm>
-            <a:off x="9283968" y="2990088"/>
-            <a:ext cx="2130487" cy="274320"/>
+            <a:off x="9389330" y="2990088"/>
+            <a:ext cx="2025125" cy="274320"/>
           </a:xfrm>
           <a:prstGeom prst="rect">
             <a:avLst/>
@@ -18568,8 +18568,8 @@
         </p:nvSpPr>
         <p:spPr>
           <a:xfrm>
-            <a:off x="9283968" y="3291840"/>
-            <a:ext cx="2130487" cy="548640"/>
+            <a:off x="9389330" y="3291840"/>
+            <a:ext cx="2025125" cy="548640"/>
           </a:xfrm>
           <a:prstGeom prst="rect">
             <a:avLst/>
@@ -18606,8 +18606,8 @@
         </p:nvSpPr>
         <p:spPr>
           <a:xfrm>
-            <a:off x="9283968" y="3886200"/>
-            <a:ext cx="2130487" cy="1005840"/>
+            <a:off x="9389330" y="3886200"/>
+            <a:ext cx="2025125" cy="1005840"/>
           </a:xfrm>
           <a:prstGeom prst="rect">
             <a:avLst/>
@@ -18642,8 +18642,8 @@
         </p:nvSpPr>
         <p:spPr>
           <a:xfrm>
-            <a:off x="3331353" y="5212080"/>
-            <a:ext cx="8311702" cy="685800"/>
+            <a:off x="3647440" y="5212080"/>
+            <a:ext cx="7995615" cy="685800"/>
           </a:xfrm>
           <a:prstGeom prst="roundRect">
             <a:avLst>
@@ -18669,8 +18669,8 @@
         </p:nvSpPr>
         <p:spPr>
           <a:xfrm>
-            <a:off x="3514233" y="5321808"/>
-            <a:ext cx="7945942" cy="466344"/>
+            <a:off x="3830320" y="5321808"/>
+            <a:ext cx="7629855" cy="466344"/>
           </a:xfrm>
           <a:prstGeom prst="rect">
             <a:avLst/>
@@ -18691,7 +18691,7 @@
                   <a:schemeClr val="tx1"/>
                 </a:solidFill>
               </a:rPr>
-              <a:t>Deudas chicas, problema grande: </a:t>
+              <a:t>Deudas chicas: </a:t>
             </a:r>
             <a:pPr indent="0" marL="0">
               <a:buNone/>
@@ -18738,7 +18738,7 @@
                   <a:schemeClr val="accent5"/>
                 </a:solidFill>
               </a:rPr>
-              <a:t>Fuentes: análisis de Mati Fernández sobre la Central de Deudores del BCRA (junio de 2026); INDEC, Censo 2022; IPYPP en base a EPH; UCA. Cuadraditos redondeados. Mapa con Islas Malvinas.</a:t>
+              <a:t>Fuentes: Mati Fernández y CEPA sobre la Central de Deudores del BCRA (2026); INDEC, Censo 2022; IPYPP; UCA. Morosos por provincia: CEPA para Buenos Aires, Córdoba, Santa Fe, CABA y Chaco; el resto, estimado por población y tasa de mora (EcoGo-Austral).</a:t>
             </a:r>
             <a:endParaRPr lang="en-US" sz="1000" dirty="0"/>
           </a:p>

</xml_diff>

<commit_message>
Mapa de mora: mostrar la mora en provincias con menos de 50.000 morosos
Co-Authored-By: Claude Opus 5.5 <noreply@anthropic.com>
Claude-Session: https://claude.ai/code/session_01LjZCUeZeukTqwmHG81QxgV
</commit_message>
<xml_diff>
--- a/presentaciones/crisis_fundar_ladrillos.pptx
+++ b/presentaciones/crisis_fundar_ladrillos.pptx
@@ -119,12 +119,12 @@
   <p:extLst>
     <p:ext uri="{521415D9-36F7-43E2-AB2F-B90AF26B5E84}">
       <p14:sectionLst xmlns:p14="http://schemas.microsoft.com/office/powerpoint/2010/main">
-        <p14:section name="Portada" id="{0aefa645-b75c-454d-1229-6e01b3e72149}">
+        <p14:section name="Portada" id="{e893bce1-9e8d-f9e5-b679-2fe0cfb5e35d}">
           <p14:sldIdLst>
             <p14:sldId id="256"/>
           </p14:sldIdLst>
         </p14:section>
-        <p14:section name="Resumen" id="{f44beaa1-39d2-a9d8-7fc2-c5ab296c06ab}">
+        <p14:section name="Resumen" id="{48b2aa8c-184b-633f-3e7c-5f6959e72951}">
           <p14:sldIdLst>
             <p14:sldId id="257"/>
             <p14:sldId id="258"/>
@@ -132,7 +132,7 @@
             <p14:sldId id="260"/>
           </p14:sldIdLst>
         </p14:section>
-        <p14:section name="Cómo se armó" id="{7343b347-42d9-15a4-41e8-9cd1e54c0430}">
+        <p14:section name="Cómo se armó" id="{8147bdbd-1472-1030-9946-3d13ad014d18}">
           <p14:sldIdLst>
             <p14:sldId id="261"/>
             <p14:sldId id="262"/>
@@ -140,7 +140,7 @@
             <p14:sldId id="264"/>
           </p14:sldIdLst>
         </p14:section>
-        <p14:section name="Qué hacer" id="{82f1e497-1847-ece5-b8a6-c6a5676b24d2}">
+        <p14:section name="Qué hacer" id="{8dbbd4b5-8b0d-3ca5-b08c-1740c3489a83}">
           <p14:sldIdLst>
             <p14:sldId id="265"/>
             <p14:sldId id="266"/>
@@ -18195,8 +18195,8 @@
         </p:nvSpPr>
         <p:spPr>
           <a:xfrm>
-            <a:off x="3647440" y="2331720"/>
-            <a:ext cx="7995615" cy="274320"/>
+            <a:off x="3647440" y="2240280"/>
+            <a:ext cx="7995615" cy="457200"/>
           </a:xfrm>
           <a:prstGeom prst="rect">
             <a:avLst/>
@@ -18217,7 +18217,7 @@
                   <a:schemeClr val="accent5"/>
                 </a:solidFill>
               </a:rPr>
-              <a:t>Cada cuadradito ≈ 100.000 habitantes, en su provincia y cerca de sus ciudades. CABA, ampliada.</a:t>
+              <a:t>Cada cuadradito ≈ 100.000 habitantes, cerca de sus ciudades; CABA, ampliada. Donde hay menos de 50.000 morosos (La Pampa, Santa Cruz y Tierra del Fuego), el rojo ocupa solo una parte del cuadradito.</a:t>
             </a:r>
             <a:endParaRPr lang="en-US" sz="1200" dirty="0"/>
           </a:p>

</xml_diff>

<commit_message>
Diapositiva de Santa Fe: comparar con el promedio nacional de deudores en mora
Co-Authored-By: Claude Opus 5.5 <noreply@anthropic.com>
Claude-Session: https://claude.ai/code/session_01LjZCUeZeukTqwmHG81QxgV
</commit_message>
<xml_diff>
--- a/presentaciones/crisis_fundar_ladrillos.pptx
+++ b/presentaciones/crisis_fundar_ladrillos.pptx
@@ -119,12 +119,12 @@
   <p:extLst>
     <p:ext uri="{521415D9-36F7-43E2-AB2F-B90AF26B5E84}">
       <p14:sectionLst xmlns:p14="http://schemas.microsoft.com/office/powerpoint/2010/main">
-        <p14:section name="Portada" id="{e893bce1-9e8d-f9e5-b679-2fe0cfb5e35d}">
+        <p14:section name="Portada" id="{f899ba4f-4c7b-43f8-8721-d4bef4534aa4}">
           <p14:sldIdLst>
             <p14:sldId id="256"/>
           </p14:sldIdLst>
         </p14:section>
-        <p14:section name="Resumen" id="{48b2aa8c-184b-633f-3e7c-5f6959e72951}">
+        <p14:section name="Resumen" id="{73bcf9cd-5884-b244-8153-7dd55a039d23}">
           <p14:sldIdLst>
             <p14:sldId id="257"/>
             <p14:sldId id="258"/>
@@ -132,7 +132,7 @@
             <p14:sldId id="260"/>
           </p14:sldIdLst>
         </p14:section>
-        <p14:section name="Cómo se armó" id="{8147bdbd-1472-1030-9946-3d13ad014d18}">
+        <p14:section name="Cómo se armó" id="{b8ec1ffe-fc6f-3474-9494-413acabc8b1e}">
           <p14:sldIdLst>
             <p14:sldId id="261"/>
             <p14:sldId id="262"/>
@@ -140,7 +140,7 @@
             <p14:sldId id="264"/>
           </p14:sldIdLst>
         </p14:section>
-        <p14:section name="Qué hacer" id="{8dbbd4b5-8b0d-3ca5-b08c-1740c3489a83}">
+        <p14:section name="Qué hacer" id="{0da8c131-5149-a64d-a559-dee82e5d6f7f}">
           <p14:sldIdLst>
             <p14:sldId id="265"/>
             <p14:sldId id="266"/>
@@ -7853,8 +7853,8 @@
         </p:nvSpPr>
         <p:spPr>
           <a:xfrm>
-            <a:off x="822960" y="2011680"/>
-            <a:ext cx="4937760" cy="292608"/>
+            <a:off x="822960" y="1938528"/>
+            <a:ext cx="4937760" cy="512064"/>
           </a:xfrm>
           <a:prstGeom prst="rect">
             <a:avLst/>
@@ -7863,21 +7863,35 @@
           <a:ln/>
         </p:spPr>
         <p:txBody>
-          <a:bodyPr wrap="square" lIns="0" tIns="0" rIns="0" bIns="0" rtlCol="0" anchor="ctr"/>
+          <a:bodyPr wrap="square" lIns="0" tIns="0" rIns="0" bIns="0" rtlCol="0" anchor="t"/>
           <a:lstStyle/>
           <a:p>
             <a:pPr indent="0" marL="0">
               <a:buNone/>
             </a:pPr>
             <a:r>
-              <a:rPr lang="en-US" sz="1500" b="1" dirty="0">
+              <a:rPr lang="en-US" sz="1400" b="1" dirty="0">
                 <a:solidFill>
                   <a:schemeClr val="tx1"/>
                 </a:solidFill>
               </a:rPr>
-              <a:t>De cada 40 santafesinos con deudas…</a:t>
+              <a:t>De cada 40 santafesinos con deudas, 10 están en mora.</a:t>
             </a:r>
-            <a:endParaRPr lang="en-US" sz="1500" dirty="0"/>
+            <a:endParaRPr lang="en-US" sz="1400" dirty="0"/>
+          </a:p>
+          <a:p>
+            <a:pPr indent="0" marL="0">
+              <a:buNone/>
+            </a:pPr>
+            <a:r>
+              <a:rPr lang="en-US" sz="1400" dirty="0">
+                <a:solidFill>
+                  <a:schemeClr val="tx2"/>
+                </a:solidFill>
+              </a:rPr>
+              <a:t>En el país son 11 de cada 40 (27%).</a:t>
+            </a:r>
+            <a:endParaRPr lang="en-US" sz="1400" dirty="0"/>
           </a:p>
         </p:txBody>
       </p:sp>
@@ -11101,7 +11115,7 @@
                   <a:schemeClr val="tx1"/>
                 </a:solidFill>
               </a:rPr>
-              <a:t>Baja en proporción, grande en cantidad: </a:t>
+              <a:t>Algo mejor que el promedio, pero grande en cantidad: </a:t>
             </a:r>
             <a:pPr indent="0" marL="0">
               <a:buNone/>
@@ -11112,7 +11126,7 @@
                   <a:schemeClr val="tx2"/>
                 </a:solidFill>
               </a:rPr>
-              <a:t>22.ª de 24 jurisdicciones por tasa de mora, 3.ª por cantidad de personas.</a:t>
+              <a:t>es la tercera provincia con más morosos del país.</a:t>
             </a:r>
             <a:endParaRPr lang="en-US" sz="1500" dirty="0"/>
           </a:p>

</xml_diff>

<commit_message>
Diapositiva 2: serie única de mora con bancos, fintech y billeteras (EcoGo-Austral)
Co-Authored-By: Claude Opus 5.5 <noreply@anthropic.com>
Claude-Session: https://claude.ai/code/session_01LjZCUeZeukTqwmHG81QxgV
</commit_message>
<xml_diff>
--- a/presentaciones/crisis_fundar_ladrillos.pptx
+++ b/presentaciones/crisis_fundar_ladrillos.pptx
@@ -119,12 +119,12 @@
   <p:extLst>
     <p:ext uri="{521415D9-36F7-43E2-AB2F-B90AF26B5E84}">
       <p14:sectionLst xmlns:p14="http://schemas.microsoft.com/office/powerpoint/2010/main">
-        <p14:section name="Portada" id="{bdb98bda-62db-5385-0b26-06338280dc0a}">
+        <p14:section name="Portada" id="{4c9c26c7-bf61-557c-50f0-f57f48584aea}">
           <p14:sldIdLst>
             <p14:sldId id="256"/>
           </p14:sldIdLst>
         </p14:section>
-        <p14:section name="Resumen" id="{5e416cd8-3fb4-f43d-8ba3-f861d7902569}">
+        <p14:section name="Resumen" id="{cfedb59a-bca9-5a7d-5c8d-e0e82d4daa2b}">
           <p14:sldIdLst>
             <p14:sldId id="257"/>
             <p14:sldId id="258"/>
@@ -132,7 +132,7 @@
             <p14:sldId id="260"/>
           </p14:sldIdLst>
         </p14:section>
-        <p14:section name="Cómo se armó" id="{55eb4c87-9176-af88-7e81-5edb5c223f69}">
+        <p14:section name="Cómo se armó" id="{bc1141d1-d027-34aa-32c9-032b973ab47e}">
           <p14:sldIdLst>
             <p14:sldId id="261"/>
             <p14:sldId id="262"/>
@@ -140,7 +140,7 @@
             <p14:sldId id="264"/>
           </p14:sldIdLst>
         </p14:section>
-        <p14:section name="Qué hacer" id="{d74a1d58-96e9-6230-8d6e-79d66703e582}">
+        <p14:section name="Qué hacer" id="{243554f9-a5b3-1997-737b-b19cb83b252b}">
           <p14:sldIdLst>
             <p14:sldId id="265"/>
             <p14:sldId id="266"/>
@@ -4743,7 +4743,7 @@
           <a:p>
             <a:r>
               <a:rPr lang="en-US" dirty="0"/>
-              <a:t>El resultado final: en dos años la mora de las familias con los bancos pasó de 2,8% a 12,8% de lo prestado. Antes era uno de cada 40 pesos; hoy, uno de cada ocho. Si se suma la deuda con fintech y billeteras, la mora llega a 15,5%: algo más de 6 de cada 40 pesos. El resto de la presentación muestra cómo se llegó acá.</a:t>
+              <a:t>El resultado final: en 18 meses la mora del crédito a personas (bancos, fintech y billeteras) pasó de 3,6% a 17,5% de lo prestado. Antes era uno de cada 40 pesos; hoy, más de uno de cada seis. Una sola serie (EcoGo y Universidad Austral), así que los tres momentos son comparables. El resto de la presentación muestra cómo se llegó acá.</a:t>
             </a:r>
             <a:endParaRPr lang="en-US" dirty="0"/>
           </a:p>
@@ -4831,7 +4831,7 @@
           <a:p>
             <a:r>
               <a:rPr lang="en-US" dirty="0"/>
-              <a:t>5,86 millones de personas tenían al menos una deuda en mora en junio de 2026: uno de cada ocho habitantes y el 27% de quienes tienen deudas registradas en la Central de Deudores. Deben $17,8 billones, el 15,5% de lo que deben las personas. No hay un dato público de hogares en mora; sí sabemos que 6 de cada 10 hogares usan alguna forma de financiamiento (IPYPP, EPH).</a:t>
+              <a:t>5,86 millones de personas tenían al menos una deuda en mora en junio de 2026: uno de cada ocho habitantes y el 27% de quienes tienen deudas registradas en la Central de Deudores. Deben $17,8 billones. No hay un dato público de hogares en mora; sí sabemos que 6 de cada 10 hogares usan alguna forma de financiamiento (IPYPP, EPH).</a:t>
             </a:r>
             <a:endParaRPr lang="en-US" dirty="0"/>
           </a:p>
@@ -12496,7 +12496,7 @@
                   <a:schemeClr val="tx1"/>
                 </a:solidFill>
               </a:rPr>
-              <a:t>Bancos: 1 de cada 8 pesos prestados está en mora</a:t>
+              <a:t>Hoy, más de 1 de cada 6 pesos prestados está en mora</a:t>
             </a:r>
             <a:endParaRPr lang="en-US" sz="3200" dirty="0"/>
           </a:p>
@@ -12532,7 +12532,7 @@
                   <a:schemeClr val="tx2"/>
                 </a:solidFill>
               </a:rPr>
-              <a:t>La mora es la parte de lo prestado que no se paga hace más de 90 días. Cada fila es la deuda de las familias, partida en 40 ladrillos iguales; el rojo es lo que está en mora.</a:t>
+              <a:t>La mora es la parte de lo prestado que no se paga hace más de 90 días. Cada fila es toda la deuda de las personas con bancos, fintech y billeteras, partida en 40 ladrillos iguales.</a:t>
             </a:r>
             <a:endParaRPr lang="en-US" sz="1600" dirty="0"/>
           </a:p>
@@ -12595,7 +12595,7 @@
                   <a:schemeClr val="tx1"/>
                 </a:solidFill>
               </a:rPr>
-              <a:t>Mayo de 2024 · bancos</a:t>
+              <a:t>Diciembre de 2024</a:t>
             </a:r>
             <a:pPr indent="0" marL="0">
               <a:buNone/>
@@ -12606,7 +12606,7 @@
                   <a:schemeClr val="tx2"/>
                 </a:solidFill>
               </a:rPr>
-              <a:t>   2,8% en mora: 1 ladrillo de cada 40</a:t>
+              <a:t>   3,6% en mora: 1 ladrillo de cada 40</a:t>
             </a:r>
             <a:endParaRPr lang="en-US" sz="1500" dirty="0"/>
           </a:p>
@@ -15202,7 +15202,7 @@
                   <a:schemeClr val="tx1"/>
                 </a:solidFill>
               </a:rPr>
-              <a:t>Mayo de 2026 · bancos</a:t>
+              <a:t>Diciembre de 2025</a:t>
             </a:r>
             <a:pPr indent="0" marL="0">
               <a:buNone/>
@@ -15213,7 +15213,7 @@
                   <a:schemeClr val="tx2"/>
                 </a:solidFill>
               </a:rPr>
-              <a:t>   12,8% en mora: 5 de cada 40, o sea, 1 de cada 8</a:t>
+              <a:t>   12,6% en mora: 5 de cada 40</a:t>
             </a:r>
             <a:endParaRPr lang="en-US" sz="1500" dirty="0"/>
           </a:p>
@@ -17809,7 +17809,7 @@
                   <a:schemeClr val="tx1"/>
                 </a:solidFill>
               </a:rPr>
-              <a:t>Junio de 2026 · bancos, fintech y billeteras</a:t>
+              <a:t>Junio de 2026</a:t>
             </a:r>
             <a:pPr indent="0" marL="0">
               <a:buNone/>
@@ -17820,7 +17820,7 @@
                   <a:schemeClr val="tx2"/>
                 </a:solidFill>
               </a:rPr>
-              <a:t>   15,5% en mora: 6 de cada 40</a:t>
+              <a:t>   17,5% en mora: 7 de cada 40, más de 1 de cada 6</a:t>
             </a:r>
             <a:endParaRPr lang="en-US" sz="1500" dirty="0"/>
           </a:p>
@@ -18227,7 +18227,7 @@
             </a:avLst>
           </a:prstGeom>
           <a:solidFill>
-            <a:schemeClr val="accent4"/>
+            <a:schemeClr val="accent1"/>
           </a:solidFill>
           <a:ln/>
         </p:spPr>
@@ -18249,7 +18249,7 @@
             </a:avLst>
           </a:prstGeom>
           <a:solidFill>
-            <a:schemeClr val="accent4"/>
+            <a:schemeClr val="accent1"/>
           </a:solidFill>
           <a:ln/>
         </p:spPr>
@@ -18269,7 +18269,7 @@
             <a:avLst/>
           </a:prstGeom>
           <a:solidFill>
-            <a:srgbClr val="7D818A"/>
+            <a:srgbClr val="A92E25"/>
           </a:solidFill>
           <a:ln/>
         </p:spPr>
@@ -20416,7 +20416,7 @@
                   <a:schemeClr val="accent5"/>
                 </a:solidFill>
               </a:rPr>
-              <a:t>Fuentes: BCRA, Informe sobre Bancos (bancos); Mati Fernández sobre la Central de Deudores (incluye fintech y billeteras). Redondeado: 2,8% ≈ 1/40; 12,8% ≈ 5/40; 15,5% ≈ 6/40.</a:t>
+              <a:t>Fuente: EcoGo y Universidad Austral en base a la Central de Deudores del BCRA (crédito a personas: bancos, fintech y billeteras). Redondeado: 3,6% ≈ 1/40; 12,6% ≈ 5/40; 17,5% = 7/40.</a:t>
             </a:r>
             <a:endParaRPr lang="en-US" sz="1000" dirty="0"/>
           </a:p>
@@ -21112,7 +21112,7 @@
                   <a:schemeClr val="tx2"/>
                 </a:solidFill>
               </a:rPr>
-              <a:t>billones están en mora: el 15,5% de todo lo que deben las personas.</a:t>
+              <a:t>billones de pesos están en mora, sumando todas las deudas atrasadas de las personas.</a:t>
             </a:r>
             <a:endParaRPr lang="en-US" sz="1300" dirty="0"/>
           </a:p>
@@ -28188,7 +28188,7 @@
                   <a:schemeClr val="tx1"/>
                 </a:solidFill>
               </a:rPr>
-              <a:t>12,8%</a:t>
+              <a:t>17,5%</a:t>
             </a:r>
             <a:endParaRPr lang="en-US" sz="4000" dirty="0"/>
           </a:p>
@@ -28224,7 +28224,7 @@
                   <a:schemeClr val="tx2"/>
                 </a:solidFill>
               </a:rPr>
-              <a:t>de la deuda de las familias con bancos está en mora (mayo de 2026).</a:t>
+              <a:t>de lo prestado a las personas está en mora, con bancos, fintech y billeteras (junio de 2026).</a:t>
             </a:r>
             <a:endParaRPr lang="en-US" sz="1500" dirty="0"/>
           </a:p>

</xml_diff>

<commit_message>
Santa Fe: actualizar descripción del Código de consumidores y quitar nombres de firmantes
Co-Authored-By: Claude Opus 5.5 <noreply@anthropic.com>
Claude-Session: https://claude.ai/code/session_01LjZCUeZeukTqwmHG81QxgV
</commit_message>
<xml_diff>
--- a/presentaciones/crisis_fundar_ladrillos.pptx
+++ b/presentaciones/crisis_fundar_ladrillos.pptx
@@ -119,12 +119,12 @@
   <p:extLst>
     <p:ext uri="{521415D9-36F7-43E2-AB2F-B90AF26B5E84}">
       <p14:sectionLst xmlns:p14="http://schemas.microsoft.com/office/powerpoint/2010/main">
-        <p14:section name="Portada" id="{4c9c26c7-bf61-557c-50f0-f57f48584aea}">
+        <p14:section name="Portada" id="{57dc3b63-1917-fce3-456b-63ba5e0f8d4e}">
           <p14:sldIdLst>
             <p14:sldId id="256"/>
           </p14:sldIdLst>
         </p14:section>
-        <p14:section name="Resumen" id="{cfedb59a-bca9-5a7d-5c8d-e0e82d4daa2b}">
+        <p14:section name="Resumen" id="{0dd9bd58-80ab-a222-871e-6574f7e498db}">
           <p14:sldIdLst>
             <p14:sldId id="257"/>
             <p14:sldId id="258"/>
@@ -132,7 +132,7 @@
             <p14:sldId id="260"/>
           </p14:sldIdLst>
         </p14:section>
-        <p14:section name="Cómo se armó" id="{bc1141d1-d027-34aa-32c9-032b973ab47e}">
+        <p14:section name="Cómo se armó" id="{82ec4138-c3e5-a655-075c-402270c6d1a1}">
           <p14:sldIdLst>
             <p14:sldId id="261"/>
             <p14:sldId id="262"/>
@@ -140,7 +140,7 @@
             <p14:sldId id="264"/>
           </p14:sldIdLst>
         </p14:section>
-        <p14:section name="Qué hacer" id="{243554f9-a5b3-1997-737b-b19cb83b252b}">
+        <p14:section name="Qué hacer" id="{d94ec7d2-46fd-b30a-5c60-f539fde7b2d4}">
           <p14:sldIdLst>
             <p14:sldId id="265"/>
             <p14:sldId id="266"/>
@@ -4567,7 +4567,7 @@
           <a:p>
             <a:r>
               <a:rPr lang="en-US" dirty="0"/>
-              <a:t>Santa Fe ya tiene un plan en marcha para unificar deudas (Plan de Protección de los Ingresos, con el Banco Santa Fe) y tres proyectos en la Legislatura. El Código de Protección de Consumidores de Mahmud es el que más se parece a nuestra recomendación provincial. Verificar si el plan siguió abierto después del 30 de septiembre.</a:t>
+              <a:t>Santa Fe ya tiene un plan en marcha para unificar deudas (Plan de Protección de los Ingresos, con el Banco Santa Fe) y tres proyectos en la Legislatura. El Código de Implementación de los Derechos de las Personas Consumidoras y Usuarias es el que más se parece a nuestra recomendación provincial: préstamo responsable para todo el que preste (regulado o no por el BCRA), límites a la cobranza y una oficina de renegociación con audiencia única, plan de hasta 5 años y piso de un salario mínimo. Verificar si el plan siguió abierto después del 30 de septiembre.</a:t>
             </a:r>
             <a:endParaRPr lang="en-US" dirty="0"/>
           </a:p>
@@ -11658,7 +11658,7 @@
                   <a:schemeClr val="tx1"/>
                 </a:solidFill>
               </a:rPr>
-              <a:t>Código de Protección de Consumidores</a:t>
+              <a:t>Código de derechos de consumidores</a:t>
             </a:r>
             <a:pPr indent="0" marL="0">
               <a:buNone/>
@@ -11666,10 +11666,10 @@
             <a:r>
               <a:rPr lang="en-US" sz="1400" dirty="0">
                 <a:solidFill>
-                  <a:schemeClr val="accent5"/>
+                  <a:schemeClr val="tx1"/>
                 </a:solidFill>
               </a:rPr>
-              <a:t> (Gisel Mahmud): </a:t>
+              <a:t>: </a:t>
             </a:r>
             <a:pPr indent="0" marL="0">
               <a:buNone/>
@@ -11680,7 +11680,7 @@
                   <a:schemeClr val="tx2"/>
                 </a:solidFill>
               </a:rPr>
-              <a:t>renegociar todas las deudas de la familia juntas, con asesoramiento del Estado.</a:t>
+              <a:t>préstamo responsable también para fintech y billeteras, y una audiencia única para renegociar todas las deudas.</a:t>
             </a:r>
             <a:endParaRPr lang="en-US" sz="1400" dirty="0"/>
           </a:p>
@@ -11724,10 +11724,10 @@
             <a:r>
               <a:rPr lang="en-US" sz="1400" dirty="0">
                 <a:solidFill>
-                  <a:schemeClr val="accent5"/>
+                  <a:schemeClr val="tx1"/>
                 </a:solidFill>
               </a:rPr>
-              <a:t> (Lucila De Ponti): </a:t>
+              <a:t>: </a:t>
             </a:r>
             <a:pPr indent="0" marL="0">
               <a:buNone/>
@@ -11782,10 +11782,10 @@
             <a:r>
               <a:rPr lang="en-US" sz="1400" dirty="0">
                 <a:solidFill>
-                  <a:schemeClr val="accent5"/>
+                  <a:schemeClr val="tx1"/>
                 </a:solidFill>
               </a:rPr>
-              <a:t> (Marcos Corach): </a:t>
+              <a:t>: </a:t>
             </a:r>
             <a:pPr indent="0" marL="0">
               <a:buNone/>

</xml_diff>

<commit_message>
Presentación: usar 'propuestas' e 'iniciativas' en lugar de 'piezas' en la parte de soluciones
Co-Authored-By: Claude Opus 5.5 <noreply@anthropic.com>
Claude-Session: https://claude.ai/code/session_01LjZCUeZeukTqwmHG81QxgV
</commit_message>
<xml_diff>
--- a/presentaciones/crisis_fundar_ladrillos.pptx
+++ b/presentaciones/crisis_fundar_ladrillos.pptx
@@ -119,12 +119,12 @@
   <p:extLst>
     <p:ext uri="{521415D9-36F7-43E2-AB2F-B90AF26B5E84}">
       <p14:sectionLst xmlns:p14="http://schemas.microsoft.com/office/powerpoint/2010/main">
-        <p14:section name="Portada" id="{57dc3b63-1917-fce3-456b-63ba5e0f8d4e}">
+        <p14:section name="Portada" id="{a6b33d0b-6ccb-6878-9545-888f4e9c847d}">
           <p14:sldIdLst>
             <p14:sldId id="256"/>
           </p14:sldIdLst>
         </p14:section>
-        <p14:section name="Resumen" id="{0dd9bd58-80ab-a222-871e-6574f7e498db}">
+        <p14:section name="Resumen" id="{fa201db4-d2a4-eaf2-58d1-1174891ca921}">
           <p14:sldIdLst>
             <p14:sldId id="257"/>
             <p14:sldId id="258"/>
@@ -132,7 +132,7 @@
             <p14:sldId id="260"/>
           </p14:sldIdLst>
         </p14:section>
-        <p14:section name="Cómo se armó" id="{82ec4138-c3e5-a655-075c-402270c6d1a1}">
+        <p14:section name="Cómo se armó" id="{9bb2d8a4-f621-e459-90de-dc46fa9e459b}">
           <p14:sldIdLst>
             <p14:sldId id="261"/>
             <p14:sldId id="262"/>
@@ -140,7 +140,7 @@
             <p14:sldId id="264"/>
           </p14:sldIdLst>
         </p14:section>
-        <p14:section name="Qué hacer" id="{d94ec7d2-46fd-b30a-5c60-f539fde7b2d4}">
+        <p14:section name="Qué hacer" id="{3cb2e1ab-0d26-68f7-6056-db180c67767c}">
           <p14:sldIdLst>
             <p14:sldId id="265"/>
             <p14:sldId id="266"/>
@@ -7038,7 +7038,7 @@
                   <a:schemeClr val="tx1"/>
                 </a:solidFill>
               </a:rPr>
-              <a:t>Cuatro piezas para sacar a las familias de la deuda</a:t>
+              <a:t>Cuatro propuestas para sacar a las familias de la deuda</a:t>
             </a:r>
             <a:endParaRPr lang="en-US" sz="3200" dirty="0"/>
           </a:p>
@@ -11308,7 +11308,7 @@
                   <a:schemeClr val="tx1"/>
                 </a:solidFill>
               </a:rPr>
-              <a:t>En Santa Fe ya hay piezas en marcha</a:t>
+              <a:t>En Santa Fe ya hay iniciativas en marcha</a:t>
             </a:r>
             <a:endParaRPr lang="en-US" sz="3200" dirty="0"/>
           </a:p>
@@ -11859,7 +11859,7 @@
                   <a:schemeClr val="tx1"/>
                 </a:solidFill>
               </a:rPr>
-              <a:t>Encaja con la pieza amarilla: </a:t>
+              <a:t>Encaja con la propuesta provincial: </a:t>
             </a:r>
             <a:pPr indent="0" marL="0">
               <a:buNone/>
@@ -12052,7 +12052,7 @@
                   <a:schemeClr val="tx1"/>
                 </a:solidFill>
               </a:rPr>
-              <a:t>Ninguna de estas piezas reemplaza a la primera</a:t>
+              <a:t>Ninguna propuesta reemplaza a la primera pieza</a:t>
             </a:r>
             <a:endParaRPr lang="en-US" sz="3200" dirty="0"/>
           </a:p>

</xml_diff>